<commit_message>
Add conference keynote presentation and generation script
17-slide dark-themed deck covering Mirror Palace architecture, philosophy,
framework library, status system, agent archetypes, and integration model.
Built with PptxGenJS for reproducible generation from source.

Co-Authored-By: Claude Opus 4.6 <noreply@anthropic.com>
</commit_message>
<xml_diff>
--- a/mirror-palace-keynote.pptx
+++ b/mirror-palace-keynote.pptx
@@ -2520,7 +2520,7 @@
                 <a:ea typeface="Calibri" pitchFamily="34" charset="-122"/>
                 <a:cs typeface="Calibri" pitchFamily="34" charset="-120"/>
               </a:rPr>
-              <a:t>Taylor O'Neal</a:t>
+              <a:t>[Speaker Name]</a:t>
             </a:r>
             <a:endParaRPr lang="en-US" sz="1800" dirty="0"/>
           </a:p>
@@ -9023,13 +9023,13 @@
             <a:r>
               <a:rPr lang="en-US" sz="1400" dirty="0">
                 <a:solidFill>
-                  <a:srgbClr val="C8C8D8"/>
-                </a:solidFill>
-                <a:latin typeface="Calibri" pitchFamily="34" charset="0"/>
-                <a:ea typeface="Calibri" pitchFamily="34" charset="-122"/>
-                <a:cs typeface="Calibri" pitchFamily="34" charset="-120"/>
-              </a:rPr>
-              <a:t>github.com/TaylorONeal/mirror-palace</a:t>
+                  <a:srgbClr val="9999BB"/>
+                </a:solidFill>
+                <a:latin typeface="Calibri" pitchFamily="34" charset="0"/>
+                <a:ea typeface="Calibri" pitchFamily="34" charset="-122"/>
+                <a:cs typeface="Calibri" pitchFamily="34" charset="-120"/>
+              </a:rPr>
+              <a:t>[github.com/your-repo/mirror-palace]</a:t>
             </a:r>
             <a:endParaRPr lang="en-US" sz="1400" dirty="0"/>
           </a:p>

</xml_diff>

<commit_message>
Replace placeholders with real name and repo URL
Co-Authored-By: Claude Opus 4.6 <noreply@anthropic.com>
</commit_message>
<xml_diff>
--- a/mirror-palace-keynote.pptx
+++ b/mirror-palace-keynote.pptx
@@ -2520,7 +2520,7 @@
                 <a:ea typeface="Calibri" pitchFamily="34" charset="-122"/>
                 <a:cs typeface="Calibri" pitchFamily="34" charset="-120"/>
               </a:rPr>
-              <a:t>[Speaker Name]</a:t>
+              <a:t>Taylor O'Neal</a:t>
             </a:r>
             <a:endParaRPr lang="en-US" sz="1800" dirty="0"/>
           </a:p>
@@ -9023,13 +9023,13 @@
             <a:r>
               <a:rPr lang="en-US" sz="1400" dirty="0">
                 <a:solidFill>
-                  <a:srgbClr val="9999BB"/>
-                </a:solidFill>
-                <a:latin typeface="Calibri" pitchFamily="34" charset="0"/>
-                <a:ea typeface="Calibri" pitchFamily="34" charset="-122"/>
-                <a:cs typeface="Calibri" pitchFamily="34" charset="-120"/>
-              </a:rPr>
-              <a:t>[github.com/your-repo/mirror-palace]</a:t>
+                  <a:srgbClr val="C8C8D8"/>
+                </a:solidFill>
+                <a:latin typeface="Calibri" pitchFamily="34" charset="0"/>
+                <a:ea typeface="Calibri" pitchFamily="34" charset="-122"/>
+                <a:cs typeface="Calibri" pitchFamily="34" charset="-120"/>
+              </a:rPr>
+              <a:t>github.com/TaylorONeal/mirror-palace</a:t>
             </a:r>
             <a:endParaRPr lang="en-US" sz="1400" dirty="0"/>
           </a:p>

</xml_diff>

<commit_message>
Add OpenClaw/Telegram, Agent Ecosystem, and Future Vision slides
Three new slides inserted before the closing sequence:
- How You Actually Use It: OpenClaw runtime + Telegram conversational loop
- The Agent Ecosystem: Claude Code, OpenClaw, and Claude Managed Agents
- Where This Is Going: NOW/EMERGING/NEXT timeline for agent platforms

Deck is now 20 slides.

Co-Authored-By: Claude Opus 4.6 <noreply@anthropic.com>
</commit_message>
<xml_diff>
--- a/mirror-palace-keynote.pptx
+++ b/mirror-palace-keynote.pptx
@@ -22,9 +22,12 @@
     <p:sldId id="270" r:id="rId16"/>
     <p:sldId id="271" r:id="rId17"/>
     <p:sldId id="272" r:id="rId18"/>
+    <p:sldId id="273" r:id="rId19"/>
+    <p:sldId id="274" r:id="rId20"/>
+    <p:sldId id="275" r:id="rId21"/>
   </p:sldIdLst>
   <p:notesMasterIdLst>
-    <p:notesMasterId r:id="rId19"/>
+    <p:notesMasterId r:id="rId22"/>
   </p:notesMasterIdLst>
   <p:sldSz cx="9144000" cy="5143500"/>
   <p:notesSz cx="5143500" cy="9144000"/>
@@ -1264,6 +1267,182 @@
 </p:notes>
 </file>
 
+<file path=ppt/notesSlides/notesSlide18.xml><?xml version="1.0" encoding="utf-8"?>
+<p:notes xmlns:a="http://schemas.openxmlformats.org/drawingml/2006/main" xmlns:r="http://schemas.openxmlformats.org/officeDocument/2006/relationships" xmlns:p="http://schemas.openxmlformats.org/presentationml/2006/main">
+  <p:cSld>
+    <p:spTree>
+      <p:nvGrpSpPr>
+        <p:cNvPr id="1" name=""/>
+        <p:cNvGrpSpPr/>
+        <p:nvPr/>
+      </p:nvGrpSpPr>
+      <p:grpSpPr>
+        <a:xfrm>
+          <a:off x="0" y="0"/>
+          <a:ext cx="0" cy="0"/>
+          <a:chOff x="0" y="0"/>
+          <a:chExt cx="0" cy="0"/>
+        </a:xfrm>
+      </p:grpSpPr>
+      <p:sp>
+        <p:nvSpPr>
+          <p:cNvPr id="2" name="Slide Image Placeholder 1"/>
+          <p:cNvSpPr>
+            <a:spLocks noGrp="1" noRot="1" noChangeAspect="1"/>
+          </p:cNvSpPr>
+          <p:nvPr>
+            <p:ph type="sldImg"/>
+          </p:nvPr>
+        </p:nvSpPr>
+        <p:spPr/>
+      </p:sp>
+      <p:sp>
+        <p:nvSpPr>
+          <p:cNvPr id="3" name="Notes Placeholder 2"/>
+          <p:cNvSpPr>
+            <a:spLocks noGrp="1"/>
+          </p:cNvSpPr>
+          <p:nvPr>
+            <p:ph type="body" idx="1"/>
+          </p:nvPr>
+        </p:nvSpPr>
+        <p:spPr/>
+        <p:txBody>
+          <a:bodyPr/>
+          <a:lstStyle/>
+          <a:p>
+            <a:r>
+              <a:rPr lang="en-US" dirty="0"/>
+              <a:t/>
+            </a:r>
+            <a:endParaRPr lang="en-US" dirty="0"/>
+          </a:p>
+        </p:txBody>
+      </p:sp>
+      <p:sp>
+        <p:nvSpPr>
+          <p:cNvPr id="4" name="Slide Number Placeholder 3"/>
+          <p:cNvSpPr>
+            <a:spLocks noGrp="1"/>
+          </p:cNvSpPr>
+          <p:nvPr>
+            <p:ph type="sldNum" sz="quarter" idx="10"/>
+          </p:nvPr>
+        </p:nvSpPr>
+        <p:spPr/>
+        <p:txBody>
+          <a:bodyPr/>
+          <a:lstStyle/>
+          <a:p>
+            <a:fld id="{F7021451-1387-4CA6-816F-3879F97B5CBC}" type="slidenum">
+              <a:rPr lang="en-US"/>
+              <a:t>18</a:t>
+            </a:fld>
+            <a:endParaRPr lang="en-US"/>
+          </a:p>
+        </p:txBody>
+      </p:sp>
+    </p:spTree>
+    <p:extLst>
+      <p:ext uri="{BB962C8B-B14F-4D97-AF65-F5344CB8AC3E}">
+        <p14:creationId xmlns:p14="http://schemas.microsoft.com/office/powerpoint/2010/main" val="1024086991"/>
+      </p:ext>
+    </p:extLst>
+  </p:cSld>
+  <p:clrMapOvr>
+    <a:masterClrMapping/>
+  </p:clrMapOvr>
+</p:notes>
+</file>
+
+<file path=ppt/notesSlides/notesSlide19.xml><?xml version="1.0" encoding="utf-8"?>
+<p:notes xmlns:a="http://schemas.openxmlformats.org/drawingml/2006/main" xmlns:r="http://schemas.openxmlformats.org/officeDocument/2006/relationships" xmlns:p="http://schemas.openxmlformats.org/presentationml/2006/main">
+  <p:cSld>
+    <p:spTree>
+      <p:nvGrpSpPr>
+        <p:cNvPr id="1" name=""/>
+        <p:cNvGrpSpPr/>
+        <p:nvPr/>
+      </p:nvGrpSpPr>
+      <p:grpSpPr>
+        <a:xfrm>
+          <a:off x="0" y="0"/>
+          <a:ext cx="0" cy="0"/>
+          <a:chOff x="0" y="0"/>
+          <a:chExt cx="0" cy="0"/>
+        </a:xfrm>
+      </p:grpSpPr>
+      <p:sp>
+        <p:nvSpPr>
+          <p:cNvPr id="2" name="Slide Image Placeholder 1"/>
+          <p:cNvSpPr>
+            <a:spLocks noGrp="1" noRot="1" noChangeAspect="1"/>
+          </p:cNvSpPr>
+          <p:nvPr>
+            <p:ph type="sldImg"/>
+          </p:nvPr>
+        </p:nvSpPr>
+        <p:spPr/>
+      </p:sp>
+      <p:sp>
+        <p:nvSpPr>
+          <p:cNvPr id="3" name="Notes Placeholder 2"/>
+          <p:cNvSpPr>
+            <a:spLocks noGrp="1"/>
+          </p:cNvSpPr>
+          <p:nvPr>
+            <p:ph type="body" idx="1"/>
+          </p:nvPr>
+        </p:nvSpPr>
+        <p:spPr/>
+        <p:txBody>
+          <a:bodyPr/>
+          <a:lstStyle/>
+          <a:p>
+            <a:r>
+              <a:rPr lang="en-US" dirty="0"/>
+              <a:t/>
+            </a:r>
+            <a:endParaRPr lang="en-US" dirty="0"/>
+          </a:p>
+        </p:txBody>
+      </p:sp>
+      <p:sp>
+        <p:nvSpPr>
+          <p:cNvPr id="4" name="Slide Number Placeholder 3"/>
+          <p:cNvSpPr>
+            <a:spLocks noGrp="1"/>
+          </p:cNvSpPr>
+          <p:nvPr>
+            <p:ph type="sldNum" sz="quarter" idx="10"/>
+          </p:nvPr>
+        </p:nvSpPr>
+        <p:spPr/>
+        <p:txBody>
+          <a:bodyPr/>
+          <a:lstStyle/>
+          <a:p>
+            <a:fld id="{F7021451-1387-4CA6-816F-3879F97B5CBC}" type="slidenum">
+              <a:rPr lang="en-US"/>
+              <a:t>19</a:t>
+            </a:fld>
+            <a:endParaRPr lang="en-US"/>
+          </a:p>
+        </p:txBody>
+      </p:sp>
+    </p:spTree>
+    <p:extLst>
+      <p:ext uri="{BB962C8B-B14F-4D97-AF65-F5344CB8AC3E}">
+        <p14:creationId xmlns:p14="http://schemas.microsoft.com/office/powerpoint/2010/main" val="1024086991"/>
+      </p:ext>
+    </p:extLst>
+  </p:cSld>
+  <p:clrMapOvr>
+    <a:masterClrMapping/>
+  </p:clrMapOvr>
+</p:notes>
+</file>
+
 <file path=ppt/notesSlides/notesSlide2.xml><?xml version="1.0" encoding="utf-8"?>
 <p:notes xmlns:a="http://schemas.openxmlformats.org/drawingml/2006/main" xmlns:r="http://schemas.openxmlformats.org/officeDocument/2006/relationships" xmlns:p="http://schemas.openxmlformats.org/presentationml/2006/main">
   <p:cSld>
@@ -1334,6 +1513,94 @@
             <a:fld id="{F7021451-1387-4CA6-816F-3879F97B5CBC}" type="slidenum">
               <a:rPr lang="en-US"/>
               <a:t>2</a:t>
+            </a:fld>
+            <a:endParaRPr lang="en-US"/>
+          </a:p>
+        </p:txBody>
+      </p:sp>
+    </p:spTree>
+    <p:extLst>
+      <p:ext uri="{BB962C8B-B14F-4D97-AF65-F5344CB8AC3E}">
+        <p14:creationId xmlns:p14="http://schemas.microsoft.com/office/powerpoint/2010/main" val="1024086991"/>
+      </p:ext>
+    </p:extLst>
+  </p:cSld>
+  <p:clrMapOvr>
+    <a:masterClrMapping/>
+  </p:clrMapOvr>
+</p:notes>
+</file>
+
+<file path=ppt/notesSlides/notesSlide20.xml><?xml version="1.0" encoding="utf-8"?>
+<p:notes xmlns:a="http://schemas.openxmlformats.org/drawingml/2006/main" xmlns:r="http://schemas.openxmlformats.org/officeDocument/2006/relationships" xmlns:p="http://schemas.openxmlformats.org/presentationml/2006/main">
+  <p:cSld>
+    <p:spTree>
+      <p:nvGrpSpPr>
+        <p:cNvPr id="1" name=""/>
+        <p:cNvGrpSpPr/>
+        <p:nvPr/>
+      </p:nvGrpSpPr>
+      <p:grpSpPr>
+        <a:xfrm>
+          <a:off x="0" y="0"/>
+          <a:ext cx="0" cy="0"/>
+          <a:chOff x="0" y="0"/>
+          <a:chExt cx="0" cy="0"/>
+        </a:xfrm>
+      </p:grpSpPr>
+      <p:sp>
+        <p:nvSpPr>
+          <p:cNvPr id="2" name="Slide Image Placeholder 1"/>
+          <p:cNvSpPr>
+            <a:spLocks noGrp="1" noRot="1" noChangeAspect="1"/>
+          </p:cNvSpPr>
+          <p:nvPr>
+            <p:ph type="sldImg"/>
+          </p:nvPr>
+        </p:nvSpPr>
+        <p:spPr/>
+      </p:sp>
+      <p:sp>
+        <p:nvSpPr>
+          <p:cNvPr id="3" name="Notes Placeholder 2"/>
+          <p:cNvSpPr>
+            <a:spLocks noGrp="1"/>
+          </p:cNvSpPr>
+          <p:nvPr>
+            <p:ph type="body" idx="1"/>
+          </p:nvPr>
+        </p:nvSpPr>
+        <p:spPr/>
+        <p:txBody>
+          <a:bodyPr/>
+          <a:lstStyle/>
+          <a:p>
+            <a:r>
+              <a:rPr lang="en-US" dirty="0"/>
+              <a:t/>
+            </a:r>
+            <a:endParaRPr lang="en-US" dirty="0"/>
+          </a:p>
+        </p:txBody>
+      </p:sp>
+      <p:sp>
+        <p:nvSpPr>
+          <p:cNvPr id="4" name="Slide Number Placeholder 3"/>
+          <p:cNvSpPr>
+            <a:spLocks noGrp="1"/>
+          </p:cNvSpPr>
+          <p:nvPr>
+            <p:ph type="sldNum" sz="quarter" idx="10"/>
+          </p:nvPr>
+        </p:nvSpPr>
+        <p:spPr/>
+        <p:txBody>
+          <a:bodyPr/>
+          <a:lstStyle/>
+          <a:p>
+            <a:fld id="{F7021451-1387-4CA6-816F-3879F97B5CBC}" type="slidenum">
+              <a:rPr lang="en-US"/>
+              <a:t>20</a:t>
             </a:fld>
             <a:endParaRPr lang="en-US"/>
           </a:p>
@@ -8181,6 +8448,1234 @@
     <p:bg>
       <p:bgPr>
         <a:solidFill>
+          <a:srgbClr val="0F0F23"/>
+        </a:solidFill>
+      </p:bgPr>
+    </p:bg>
+    <p:spTree>
+      <p:nvGrpSpPr>
+        <p:cNvPr id="1" name=""/>
+        <p:cNvGrpSpPr/>
+        <p:nvPr/>
+      </p:nvGrpSpPr>
+      <p:grpSpPr>
+        <a:xfrm>
+          <a:off x="0" y="0"/>
+          <a:ext cx="0" cy="0"/>
+          <a:chOff x="0" y="0"/>
+          <a:chExt cx="0" cy="0"/>
+        </a:xfrm>
+      </p:grpSpPr>
+      <p:sp>
+        <p:nvSpPr>
+          <p:cNvPr id="2" name="Shape 0"/>
+          <p:cNvSpPr/>
+          <p:nvPr/>
+        </p:nvSpPr>
+        <p:spPr>
+          <a:xfrm>
+            <a:off x="0" y="0"/>
+            <a:ext cx="9144000" cy="54864"/>
+          </a:xfrm>
+          <a:prstGeom prst="rect">
+            <a:avLst/>
+          </a:prstGeom>
+          <a:solidFill>
+            <a:srgbClr val="4ECDC4"/>
+          </a:solidFill>
+          <a:ln/>
+        </p:spPr>
+      </p:sp>
+      <p:sp>
+        <p:nvSpPr>
+          <p:cNvPr id="3" name="Text 1"/>
+          <p:cNvSpPr/>
+          <p:nvPr/>
+        </p:nvSpPr>
+        <p:spPr>
+          <a:xfrm>
+            <a:off x="457200" y="274320"/>
+            <a:ext cx="8229600" cy="457200"/>
+          </a:xfrm>
+          <a:prstGeom prst="rect">
+            <a:avLst/>
+          </a:prstGeom>
+          <a:noFill/>
+          <a:ln/>
+        </p:spPr>
+        <p:txBody>
+          <a:bodyPr wrap="square" lIns="0" tIns="0" rIns="0" bIns="0" rtlCol="0" anchor="ctr"/>
+          <a:lstStyle/>
+          <a:p>
+            <a:pPr indent="0" marL="0">
+              <a:buNone/>
+            </a:pPr>
+            <a:r>
+              <a:rPr lang="en-US" sz="1400" b="1" spc="600" kern="0" dirty="0">
+                <a:solidFill>
+                  <a:srgbClr val="4ECDC4"/>
+                </a:solidFill>
+                <a:latin typeface="Calibri" pitchFamily="34" charset="0"/>
+                <a:ea typeface="Calibri" pitchFamily="34" charset="-122"/>
+                <a:cs typeface="Calibri" pitchFamily="34" charset="-120"/>
+              </a:rPr>
+              <a:t>HOW YOU ACTUALLY USE IT</a:t>
+            </a:r>
+            <a:endParaRPr lang="en-US" sz="1400" dirty="0"/>
+          </a:p>
+        </p:txBody>
+      </p:sp>
+      <p:sp>
+        <p:nvSpPr>
+          <p:cNvPr id="4" name="Text 2"/>
+          <p:cNvSpPr/>
+          <p:nvPr/>
+        </p:nvSpPr>
+        <p:spPr>
+          <a:xfrm>
+            <a:off x="457200" y="685800"/>
+            <a:ext cx="8229600" cy="411480"/>
+          </a:xfrm>
+          <a:prstGeom prst="rect">
+            <a:avLst/>
+          </a:prstGeom>
+          <a:noFill/>
+          <a:ln/>
+        </p:spPr>
+        <p:txBody>
+          <a:bodyPr wrap="square" lIns="0" tIns="0" rIns="0" bIns="0" rtlCol="0" anchor="ctr"/>
+          <a:lstStyle/>
+          <a:p>
+            <a:pPr indent="0" marL="0">
+              <a:buNone/>
+            </a:pPr>
+            <a:r>
+              <a:rPr lang="en-US" sz="2000" dirty="0">
+                <a:solidFill>
+                  <a:srgbClr val="C8C8D8"/>
+                </a:solidFill>
+                <a:latin typeface="Calibri" pitchFamily="34" charset="0"/>
+                <a:ea typeface="Calibri" pitchFamily="34" charset="-122"/>
+                <a:cs typeface="Calibri" pitchFamily="34" charset="-120"/>
+              </a:rPr>
+              <a:t>OpenClaw + Telegram</a:t>
+            </a:r>
+            <a:endParaRPr lang="en-US" sz="2000" dirty="0"/>
+          </a:p>
+        </p:txBody>
+      </p:sp>
+      <p:sp>
+        <p:nvSpPr>
+          <p:cNvPr id="5" name="Shape 3"/>
+          <p:cNvSpPr/>
+          <p:nvPr/>
+        </p:nvSpPr>
+        <p:spPr>
+          <a:xfrm>
+            <a:off x="457200" y="1280160"/>
+            <a:ext cx="3931920" cy="3200400"/>
+          </a:xfrm>
+          <a:prstGeom prst="rect">
+            <a:avLst/>
+          </a:prstGeom>
+          <a:solidFill>
+            <a:srgbClr val="16213E"/>
+          </a:solidFill>
+          <a:ln/>
+          <a:effectLst>
+            <a:outerShdw sx="100000" sy="100000" kx="0" ky="0" algn="bl" rotWithShape="0" blurRad="76200" dist="25400" dir="8100000">
+              <a:srgbClr val="000000">
+                <a:alpha val="20000"/>
+              </a:srgbClr>
+            </a:outerShdw>
+          </a:effectLst>
+        </p:spPr>
+      </p:sp>
+      <p:sp>
+        <p:nvSpPr>
+          <p:cNvPr id="6" name="Shape 4"/>
+          <p:cNvSpPr/>
+          <p:nvPr/>
+        </p:nvSpPr>
+        <p:spPr>
+          <a:xfrm>
+            <a:off x="457200" y="1280160"/>
+            <a:ext cx="3931920" cy="45720"/>
+          </a:xfrm>
+          <a:prstGeom prst="rect">
+            <a:avLst/>
+          </a:prstGeom>
+          <a:solidFill>
+            <a:srgbClr val="4ECDC4"/>
+          </a:solidFill>
+          <a:ln/>
+        </p:spPr>
+      </p:sp>
+      <p:pic>
+        <p:nvPicPr>
+          <p:cNvPr id="7" name="Image 0" descr="preencoded.png">    </p:cNvPr>
+          <p:cNvPicPr>
+            <a:picLocks noChangeAspect="1"/>
+          </p:cNvPicPr>
+          <p:nvPr/>
+        </p:nvPicPr>
+        <p:blipFill>
+          <a:blip r:embed="rId1"/>
+          <a:stretch>
+            <a:fillRect/>
+          </a:stretch>
+        </p:blipFill>
+        <p:spPr>
+          <a:xfrm>
+            <a:off x="731520" y="1508760"/>
+            <a:ext cx="320040" cy="320040"/>
+          </a:xfrm>
+          <a:prstGeom prst="rect">
+            <a:avLst/>
+          </a:prstGeom>
+        </p:spPr>
+      </p:pic>
+      <p:sp>
+        <p:nvSpPr>
+          <p:cNvPr id="8" name="Text 5"/>
+          <p:cNvSpPr/>
+          <p:nvPr/>
+        </p:nvSpPr>
+        <p:spPr>
+          <a:xfrm>
+            <a:off x="1188720" y="1463040"/>
+            <a:ext cx="2743200" cy="411480"/>
+          </a:xfrm>
+          <a:prstGeom prst="rect">
+            <a:avLst/>
+          </a:prstGeom>
+          <a:noFill/>
+          <a:ln/>
+        </p:spPr>
+        <p:txBody>
+          <a:bodyPr wrap="square" lIns="0" tIns="0" rIns="0" bIns="0" rtlCol="0" anchor="ctr"/>
+          <a:lstStyle/>
+          <a:p>
+            <a:pPr indent="0" marL="0">
+              <a:buNone/>
+            </a:pPr>
+            <a:r>
+              <a:rPr lang="en-US" sz="1500" b="1" dirty="0">
+                <a:solidFill>
+                  <a:srgbClr val="4ECDC4"/>
+                </a:solidFill>
+                <a:latin typeface="Calibri" pitchFamily="34" charset="0"/>
+                <a:ea typeface="Calibri" pitchFamily="34" charset="-122"/>
+                <a:cs typeface="Calibri" pitchFamily="34" charset="-120"/>
+              </a:rPr>
+              <a:t>OPENCLAW</a:t>
+            </a:r>
+            <a:endParaRPr lang="en-US" sz="1500" dirty="0"/>
+          </a:p>
+        </p:txBody>
+      </p:sp>
+      <p:sp>
+        <p:nvSpPr>
+          <p:cNvPr id="9" name="Text 6"/>
+          <p:cNvSpPr/>
+          <p:nvPr/>
+        </p:nvSpPr>
+        <p:spPr>
+          <a:xfrm>
+            <a:off x="731520" y="1965960"/>
+            <a:ext cx="3474720" cy="274320"/>
+          </a:xfrm>
+          <a:prstGeom prst="rect">
+            <a:avLst/>
+          </a:prstGeom>
+          <a:noFill/>
+          <a:ln/>
+        </p:spPr>
+        <p:txBody>
+          <a:bodyPr wrap="square" lIns="0" tIns="0" rIns="0" bIns="0" rtlCol="0" anchor="ctr"/>
+          <a:lstStyle/>
+          <a:p>
+            <a:pPr indent="0" marL="0">
+              <a:buNone/>
+            </a:pPr>
+            <a:r>
+              <a:rPr lang="en-US" sz="1200" dirty="0">
+                <a:solidFill>
+                  <a:srgbClr val="C8C8D8"/>
+                </a:solidFill>
+                <a:latin typeface="Calibri" pitchFamily="34" charset="0"/>
+                <a:ea typeface="Calibri" pitchFamily="34" charset="-122"/>
+                <a:cs typeface="Calibri" pitchFamily="34" charset="-120"/>
+              </a:rPr>
+              <a:t>Open-source agent runtime</a:t>
+            </a:r>
+            <a:endParaRPr lang="en-US" sz="1200" dirty="0"/>
+          </a:p>
+        </p:txBody>
+      </p:sp>
+      <p:sp>
+        <p:nvSpPr>
+          <p:cNvPr id="10" name="Shape 7"/>
+          <p:cNvSpPr/>
+          <p:nvPr/>
+        </p:nvSpPr>
+        <p:spPr>
+          <a:xfrm>
+            <a:off x="731520" y="2377440"/>
+            <a:ext cx="3474720" cy="384048"/>
+          </a:xfrm>
+          <a:prstGeom prst="rect">
+            <a:avLst/>
+          </a:prstGeom>
+          <a:solidFill>
+            <a:srgbClr val="4ECDC4">
+              <a:alpha val="8000"/>
+            </a:srgbClr>
+          </a:solidFill>
+          <a:ln/>
+        </p:spPr>
+      </p:sp>
+      <p:sp>
+        <p:nvSpPr>
+          <p:cNvPr id="11" name="Text 8"/>
+          <p:cNvSpPr/>
+          <p:nvPr/>
+        </p:nvSpPr>
+        <p:spPr>
+          <a:xfrm>
+            <a:off x="914400" y="2377440"/>
+            <a:ext cx="1188720" cy="384048"/>
+          </a:xfrm>
+          <a:prstGeom prst="rect">
+            <a:avLst/>
+          </a:prstGeom>
+          <a:noFill/>
+          <a:ln/>
+        </p:spPr>
+        <p:txBody>
+          <a:bodyPr wrap="square" lIns="0" tIns="0" rIns="0" bIns="0" rtlCol="0" anchor="ctr"/>
+          <a:lstStyle/>
+          <a:p>
+            <a:pPr indent="0" marL="0">
+              <a:buNone/>
+            </a:pPr>
+            <a:r>
+              <a:rPr lang="en-US" sz="1100" b="1" dirty="0">
+                <a:solidFill>
+                  <a:srgbClr val="4ECDC4"/>
+                </a:solidFill>
+                <a:latin typeface="Calibri" pitchFamily="34" charset="0"/>
+                <a:ea typeface="Calibri" pitchFamily="34" charset="-122"/>
+                <a:cs typeface="Calibri" pitchFamily="34" charset="-120"/>
+              </a:rPr>
+              <a:t>Agent runtime</a:t>
+            </a:r>
+            <a:endParaRPr lang="en-US" sz="1100" dirty="0"/>
+          </a:p>
+        </p:txBody>
+      </p:sp>
+      <p:sp>
+        <p:nvSpPr>
+          <p:cNvPr id="12" name="Text 9"/>
+          <p:cNvSpPr/>
+          <p:nvPr/>
+        </p:nvSpPr>
+        <p:spPr>
+          <a:xfrm>
+            <a:off x="2103120" y="2377440"/>
+            <a:ext cx="2011680" cy="384048"/>
+          </a:xfrm>
+          <a:prstGeom prst="rect">
+            <a:avLst/>
+          </a:prstGeom>
+          <a:noFill/>
+          <a:ln/>
+        </p:spPr>
+        <p:txBody>
+          <a:bodyPr wrap="square" lIns="0" tIns="0" rIns="0" bIns="0" rtlCol="0" anchor="ctr"/>
+          <a:lstStyle/>
+          <a:p>
+            <a:pPr indent="0" marL="0">
+              <a:buNone/>
+            </a:pPr>
+            <a:r>
+              <a:rPr lang="en-US" sz="1000" dirty="0">
+                <a:solidFill>
+                  <a:srgbClr val="C8C8D8"/>
+                </a:solidFill>
+                <a:latin typeface="Calibri" pitchFamily="34" charset="0"/>
+                <a:ea typeface="Calibri" pitchFamily="34" charset="-122"/>
+                <a:cs typeface="Calibri" pitchFamily="34" charset="-120"/>
+              </a:rPr>
+              <a:t>Runs your Mirror Palace agents locally or in the cloud</a:t>
+            </a:r>
+            <a:endParaRPr lang="en-US" sz="1000" dirty="0"/>
+          </a:p>
+        </p:txBody>
+      </p:sp>
+      <p:sp>
+        <p:nvSpPr>
+          <p:cNvPr id="13" name="Shape 10"/>
+          <p:cNvSpPr/>
+          <p:nvPr/>
+        </p:nvSpPr>
+        <p:spPr>
+          <a:xfrm>
+            <a:off x="731520" y="2852928"/>
+            <a:ext cx="3474720" cy="384048"/>
+          </a:xfrm>
+          <a:prstGeom prst="rect">
+            <a:avLst/>
+          </a:prstGeom>
+          <a:solidFill>
+            <a:srgbClr val="4ECDC4">
+              <a:alpha val="8000"/>
+            </a:srgbClr>
+          </a:solidFill>
+          <a:ln/>
+        </p:spPr>
+      </p:sp>
+      <p:sp>
+        <p:nvSpPr>
+          <p:cNvPr id="14" name="Text 11"/>
+          <p:cNvSpPr/>
+          <p:nvPr/>
+        </p:nvSpPr>
+        <p:spPr>
+          <a:xfrm>
+            <a:off x="914400" y="2852928"/>
+            <a:ext cx="1188720" cy="384048"/>
+          </a:xfrm>
+          <a:prstGeom prst="rect">
+            <a:avLst/>
+          </a:prstGeom>
+          <a:noFill/>
+          <a:ln/>
+        </p:spPr>
+        <p:txBody>
+          <a:bodyPr wrap="square" lIns="0" tIns="0" rIns="0" bIns="0" rtlCol="0" anchor="ctr"/>
+          <a:lstStyle/>
+          <a:p>
+            <a:pPr indent="0" marL="0">
+              <a:buNone/>
+            </a:pPr>
+            <a:r>
+              <a:rPr lang="en-US" sz="1100" b="1" dirty="0">
+                <a:solidFill>
+                  <a:srgbClr val="4ECDC4"/>
+                </a:solidFill>
+                <a:latin typeface="Calibri" pitchFamily="34" charset="0"/>
+                <a:ea typeface="Calibri" pitchFamily="34" charset="-122"/>
+                <a:cs typeface="Calibri" pitchFamily="34" charset="-120"/>
+              </a:rPr>
+              <a:t>Any LLM backend</a:t>
+            </a:r>
+            <a:endParaRPr lang="en-US" sz="1100" dirty="0"/>
+          </a:p>
+        </p:txBody>
+      </p:sp>
+      <p:sp>
+        <p:nvSpPr>
+          <p:cNvPr id="15" name="Text 12"/>
+          <p:cNvSpPr/>
+          <p:nvPr/>
+        </p:nvSpPr>
+        <p:spPr>
+          <a:xfrm>
+            <a:off x="2103120" y="2852928"/>
+            <a:ext cx="2011680" cy="384048"/>
+          </a:xfrm>
+          <a:prstGeom prst="rect">
+            <a:avLst/>
+          </a:prstGeom>
+          <a:noFill/>
+          <a:ln/>
+        </p:spPr>
+        <p:txBody>
+          <a:bodyPr wrap="square" lIns="0" tIns="0" rIns="0" bIns="0" rtlCol="0" anchor="ctr"/>
+          <a:lstStyle/>
+          <a:p>
+            <a:pPr indent="0" marL="0">
+              <a:buNone/>
+            </a:pPr>
+            <a:r>
+              <a:rPr lang="en-US" sz="1000" dirty="0">
+                <a:solidFill>
+                  <a:srgbClr val="C8C8D8"/>
+                </a:solidFill>
+                <a:latin typeface="Calibri" pitchFamily="34" charset="0"/>
+                <a:ea typeface="Calibri" pitchFamily="34" charset="-122"/>
+                <a:cs typeface="Calibri" pitchFamily="34" charset="-120"/>
+              </a:rPr>
+              <a:t>Claude, GPT, local models</a:t>
+            </a:r>
+            <a:endParaRPr lang="en-US" sz="1000" dirty="0"/>
+          </a:p>
+        </p:txBody>
+      </p:sp>
+      <p:sp>
+        <p:nvSpPr>
+          <p:cNvPr id="16" name="Shape 13"/>
+          <p:cNvSpPr/>
+          <p:nvPr/>
+        </p:nvSpPr>
+        <p:spPr>
+          <a:xfrm>
+            <a:off x="731520" y="3328416"/>
+            <a:ext cx="3474720" cy="384048"/>
+          </a:xfrm>
+          <a:prstGeom prst="rect">
+            <a:avLst/>
+          </a:prstGeom>
+          <a:solidFill>
+            <a:srgbClr val="4ECDC4">
+              <a:alpha val="8000"/>
+            </a:srgbClr>
+          </a:solidFill>
+          <a:ln/>
+        </p:spPr>
+      </p:sp>
+      <p:sp>
+        <p:nvSpPr>
+          <p:cNvPr id="17" name="Text 14"/>
+          <p:cNvSpPr/>
+          <p:nvPr/>
+        </p:nvSpPr>
+        <p:spPr>
+          <a:xfrm>
+            <a:off x="914400" y="3328416"/>
+            <a:ext cx="1188720" cy="384048"/>
+          </a:xfrm>
+          <a:prstGeom prst="rect">
+            <a:avLst/>
+          </a:prstGeom>
+          <a:noFill/>
+          <a:ln/>
+        </p:spPr>
+        <p:txBody>
+          <a:bodyPr wrap="square" lIns="0" tIns="0" rIns="0" bIns="0" rtlCol="0" anchor="ctr"/>
+          <a:lstStyle/>
+          <a:p>
+            <a:pPr indent="0" marL="0">
+              <a:buNone/>
+            </a:pPr>
+            <a:r>
+              <a:rPr lang="en-US" sz="1100" b="1" dirty="0">
+                <a:solidFill>
+                  <a:srgbClr val="4ECDC4"/>
+                </a:solidFill>
+                <a:latin typeface="Calibri" pitchFamily="34" charset="0"/>
+                <a:ea typeface="Calibri" pitchFamily="34" charset="-122"/>
+                <a:cs typeface="Calibri" pitchFamily="34" charset="-120"/>
+              </a:rPr>
+              <a:t>Multi-channel</a:t>
+            </a:r>
+            <a:endParaRPr lang="en-US" sz="1100" dirty="0"/>
+          </a:p>
+        </p:txBody>
+      </p:sp>
+      <p:sp>
+        <p:nvSpPr>
+          <p:cNvPr id="18" name="Text 15"/>
+          <p:cNvSpPr/>
+          <p:nvPr/>
+        </p:nvSpPr>
+        <p:spPr>
+          <a:xfrm>
+            <a:off x="2103120" y="3328416"/>
+            <a:ext cx="2011680" cy="384048"/>
+          </a:xfrm>
+          <a:prstGeom prst="rect">
+            <a:avLst/>
+          </a:prstGeom>
+          <a:noFill/>
+          <a:ln/>
+        </p:spPr>
+        <p:txBody>
+          <a:bodyPr wrap="square" lIns="0" tIns="0" rIns="0" bIns="0" rtlCol="0" anchor="ctr"/>
+          <a:lstStyle/>
+          <a:p>
+            <a:pPr indent="0" marL="0">
+              <a:buNone/>
+            </a:pPr>
+            <a:r>
+              <a:rPr lang="en-US" sz="1000" dirty="0">
+                <a:solidFill>
+                  <a:srgbClr val="C8C8D8"/>
+                </a:solidFill>
+                <a:latin typeface="Calibri" pitchFamily="34" charset="0"/>
+                <a:ea typeface="Calibri" pitchFamily="34" charset="-122"/>
+                <a:cs typeface="Calibri" pitchFamily="34" charset="-120"/>
+              </a:rPr>
+              <a:t>Telegram, Discord, web, CLI</a:t>
+            </a:r>
+            <a:endParaRPr lang="en-US" sz="1000" dirty="0"/>
+          </a:p>
+        </p:txBody>
+      </p:sp>
+      <p:sp>
+        <p:nvSpPr>
+          <p:cNvPr id="19" name="Shape 16"/>
+          <p:cNvSpPr/>
+          <p:nvPr/>
+        </p:nvSpPr>
+        <p:spPr>
+          <a:xfrm>
+            <a:off x="731520" y="3803904"/>
+            <a:ext cx="3474720" cy="384048"/>
+          </a:xfrm>
+          <a:prstGeom prst="rect">
+            <a:avLst/>
+          </a:prstGeom>
+          <a:solidFill>
+            <a:srgbClr val="4ECDC4">
+              <a:alpha val="8000"/>
+            </a:srgbClr>
+          </a:solidFill>
+          <a:ln/>
+        </p:spPr>
+      </p:sp>
+      <p:sp>
+        <p:nvSpPr>
+          <p:cNvPr id="20" name="Text 17"/>
+          <p:cNvSpPr/>
+          <p:nvPr/>
+        </p:nvSpPr>
+        <p:spPr>
+          <a:xfrm>
+            <a:off x="914400" y="3803904"/>
+            <a:ext cx="1188720" cy="384048"/>
+          </a:xfrm>
+          <a:prstGeom prst="rect">
+            <a:avLst/>
+          </a:prstGeom>
+          <a:noFill/>
+          <a:ln/>
+        </p:spPr>
+        <p:txBody>
+          <a:bodyPr wrap="square" lIns="0" tIns="0" rIns="0" bIns="0" rtlCol="0" anchor="ctr"/>
+          <a:lstStyle/>
+          <a:p>
+            <a:pPr indent="0" marL="0">
+              <a:buNone/>
+            </a:pPr>
+            <a:r>
+              <a:rPr lang="en-US" sz="1100" b="1" dirty="0">
+                <a:solidFill>
+                  <a:srgbClr val="4ECDC4"/>
+                </a:solidFill>
+                <a:latin typeface="Calibri" pitchFamily="34" charset="0"/>
+                <a:ea typeface="Calibri" pitchFamily="34" charset="-122"/>
+                <a:cs typeface="Calibri" pitchFamily="34" charset="-120"/>
+              </a:rPr>
+              <a:t>Open source</a:t>
+            </a:r>
+            <a:endParaRPr lang="en-US" sz="1100" dirty="0"/>
+          </a:p>
+        </p:txBody>
+      </p:sp>
+      <p:sp>
+        <p:nvSpPr>
+          <p:cNvPr id="21" name="Text 18"/>
+          <p:cNvSpPr/>
+          <p:nvPr/>
+        </p:nvSpPr>
+        <p:spPr>
+          <a:xfrm>
+            <a:off x="2103120" y="3803904"/>
+            <a:ext cx="2011680" cy="384048"/>
+          </a:xfrm>
+          <a:prstGeom prst="rect">
+            <a:avLst/>
+          </a:prstGeom>
+          <a:noFill/>
+          <a:ln/>
+        </p:spPr>
+        <p:txBody>
+          <a:bodyPr wrap="square" lIns="0" tIns="0" rIns="0" bIns="0" rtlCol="0" anchor="ctr"/>
+          <a:lstStyle/>
+          <a:p>
+            <a:pPr indent="0" marL="0">
+              <a:buNone/>
+            </a:pPr>
+            <a:r>
+              <a:rPr lang="en-US" sz="1000" dirty="0">
+                <a:solidFill>
+                  <a:srgbClr val="C8C8D8"/>
+                </a:solidFill>
+                <a:latin typeface="Calibri" pitchFamily="34" charset="0"/>
+                <a:ea typeface="Calibri" pitchFamily="34" charset="-122"/>
+                <a:cs typeface="Calibri" pitchFamily="34" charset="-120"/>
+              </a:rPr>
+              <a:t>You own the infrastructure</a:t>
+            </a:r>
+            <a:endParaRPr lang="en-US" sz="1000" dirty="0"/>
+          </a:p>
+        </p:txBody>
+      </p:sp>
+      <p:sp>
+        <p:nvSpPr>
+          <p:cNvPr id="22" name="Shape 19"/>
+          <p:cNvSpPr/>
+          <p:nvPr/>
+        </p:nvSpPr>
+        <p:spPr>
+          <a:xfrm>
+            <a:off x="4754880" y="1280160"/>
+            <a:ext cx="3931920" cy="3200400"/>
+          </a:xfrm>
+          <a:prstGeom prst="rect">
+            <a:avLst/>
+          </a:prstGeom>
+          <a:solidFill>
+            <a:srgbClr val="16213E"/>
+          </a:solidFill>
+          <a:ln/>
+          <a:effectLst>
+            <a:outerShdw sx="100000" sy="100000" kx="0" ky="0" algn="bl" rotWithShape="0" blurRad="76200" dist="25400" dir="8100000">
+              <a:srgbClr val="000000">
+                <a:alpha val="20000"/>
+              </a:srgbClr>
+            </a:outerShdw>
+          </a:effectLst>
+        </p:spPr>
+      </p:sp>
+      <p:sp>
+        <p:nvSpPr>
+          <p:cNvPr id="23" name="Shape 20"/>
+          <p:cNvSpPr/>
+          <p:nvPr/>
+        </p:nvSpPr>
+        <p:spPr>
+          <a:xfrm>
+            <a:off x="4754880" y="1280160"/>
+            <a:ext cx="3931920" cy="45720"/>
+          </a:xfrm>
+          <a:prstGeom prst="rect">
+            <a:avLst/>
+          </a:prstGeom>
+          <a:solidFill>
+            <a:srgbClr val="FF6B6B"/>
+          </a:solidFill>
+          <a:ln/>
+        </p:spPr>
+      </p:sp>
+      <p:pic>
+        <p:nvPicPr>
+          <p:cNvPr id="24" name="Image 1" descr="preencoded.png">    </p:cNvPr>
+          <p:cNvPicPr>
+            <a:picLocks noChangeAspect="1"/>
+          </p:cNvPicPr>
+          <p:nvPr/>
+        </p:nvPicPr>
+        <p:blipFill>
+          <a:blip r:embed="rId2"/>
+          <a:stretch>
+            <a:fillRect/>
+          </a:stretch>
+        </p:blipFill>
+        <p:spPr>
+          <a:xfrm>
+            <a:off x="5029200" y="1508760"/>
+            <a:ext cx="320040" cy="320040"/>
+          </a:xfrm>
+          <a:prstGeom prst="rect">
+            <a:avLst/>
+          </a:prstGeom>
+        </p:spPr>
+      </p:pic>
+      <p:sp>
+        <p:nvSpPr>
+          <p:cNvPr id="25" name="Text 21"/>
+          <p:cNvSpPr/>
+          <p:nvPr/>
+        </p:nvSpPr>
+        <p:spPr>
+          <a:xfrm>
+            <a:off x="5486400" y="1463040"/>
+            <a:ext cx="2743200" cy="411480"/>
+          </a:xfrm>
+          <a:prstGeom prst="rect">
+            <a:avLst/>
+          </a:prstGeom>
+          <a:noFill/>
+          <a:ln/>
+        </p:spPr>
+        <p:txBody>
+          <a:bodyPr wrap="square" lIns="0" tIns="0" rIns="0" bIns="0" rtlCol="0" anchor="ctr"/>
+          <a:lstStyle/>
+          <a:p>
+            <a:pPr indent="0" marL="0">
+              <a:buNone/>
+            </a:pPr>
+            <a:r>
+              <a:rPr lang="en-US" sz="1500" b="1" dirty="0">
+                <a:solidFill>
+                  <a:srgbClr val="FF6B6B"/>
+                </a:solidFill>
+                <a:latin typeface="Calibri" pitchFamily="34" charset="0"/>
+                <a:ea typeface="Calibri" pitchFamily="34" charset="-122"/>
+                <a:cs typeface="Calibri" pitchFamily="34" charset="-120"/>
+              </a:rPr>
+              <a:t>TELEGRAM</a:t>
+            </a:r>
+            <a:endParaRPr lang="en-US" sz="1500" dirty="0"/>
+          </a:p>
+        </p:txBody>
+      </p:sp>
+      <p:sp>
+        <p:nvSpPr>
+          <p:cNvPr id="26" name="Text 22"/>
+          <p:cNvSpPr/>
+          <p:nvPr/>
+        </p:nvSpPr>
+        <p:spPr>
+          <a:xfrm>
+            <a:off x="5029200" y="1965960"/>
+            <a:ext cx="3474720" cy="274320"/>
+          </a:xfrm>
+          <a:prstGeom prst="rect">
+            <a:avLst/>
+          </a:prstGeom>
+          <a:noFill/>
+          <a:ln/>
+        </p:spPr>
+        <p:txBody>
+          <a:bodyPr wrap="square" lIns="0" tIns="0" rIns="0" bIns="0" rtlCol="0" anchor="ctr"/>
+          <a:lstStyle/>
+          <a:p>
+            <a:pPr indent="0" marL="0">
+              <a:buNone/>
+            </a:pPr>
+            <a:r>
+              <a:rPr lang="en-US" sz="1200" dirty="0">
+                <a:solidFill>
+                  <a:srgbClr val="C8C8D8"/>
+                </a:solidFill>
+                <a:latin typeface="Calibri" pitchFamily="34" charset="0"/>
+                <a:ea typeface="Calibri" pitchFamily="34" charset="-122"/>
+                <a:cs typeface="Calibri" pitchFamily="34" charset="-120"/>
+              </a:rPr>
+              <a:t>Full conversational loop</a:t>
+            </a:r>
+            <a:endParaRPr lang="en-US" sz="1200" dirty="0"/>
+          </a:p>
+        </p:txBody>
+      </p:sp>
+      <p:sp>
+        <p:nvSpPr>
+          <p:cNvPr id="27" name="Shape 23"/>
+          <p:cNvSpPr/>
+          <p:nvPr/>
+        </p:nvSpPr>
+        <p:spPr>
+          <a:xfrm>
+            <a:off x="5029200" y="2377440"/>
+            <a:ext cx="3474720" cy="384048"/>
+          </a:xfrm>
+          <a:prstGeom prst="rect">
+            <a:avLst/>
+          </a:prstGeom>
+          <a:solidFill>
+            <a:srgbClr val="FF6B6B">
+              <a:alpha val="8000"/>
+            </a:srgbClr>
+          </a:solidFill>
+          <a:ln/>
+        </p:spPr>
+      </p:sp>
+      <p:sp>
+        <p:nvSpPr>
+          <p:cNvPr id="28" name="Text 24"/>
+          <p:cNvSpPr/>
+          <p:nvPr/>
+        </p:nvSpPr>
+        <p:spPr>
+          <a:xfrm>
+            <a:off x="5212080" y="2377440"/>
+            <a:ext cx="1371600" cy="384048"/>
+          </a:xfrm>
+          <a:prstGeom prst="rect">
+            <a:avLst/>
+          </a:prstGeom>
+          <a:noFill/>
+          <a:ln/>
+        </p:spPr>
+        <p:txBody>
+          <a:bodyPr wrap="square" lIns="0" tIns="0" rIns="0" bIns="0" rtlCol="0" anchor="ctr"/>
+          <a:lstStyle/>
+          <a:p>
+            <a:pPr indent="0" marL="0">
+              <a:buNone/>
+            </a:pPr>
+            <a:r>
+              <a:rPr lang="en-US" sz="1100" b="1" dirty="0">
+                <a:solidFill>
+                  <a:srgbClr val="FF6B6B"/>
+                </a:solidFill>
+                <a:latin typeface="Calibri" pitchFamily="34" charset="0"/>
+                <a:ea typeface="Calibri" pitchFamily="34" charset="-122"/>
+                <a:cs typeface="Calibri" pitchFamily="34" charset="-120"/>
+              </a:rPr>
+              <a:t>Agents push to you</a:t>
+            </a:r>
+            <a:endParaRPr lang="en-US" sz="1100" dirty="0"/>
+          </a:p>
+        </p:txBody>
+      </p:sp>
+      <p:sp>
+        <p:nvSpPr>
+          <p:cNvPr id="29" name="Text 25"/>
+          <p:cNvSpPr/>
+          <p:nvPr/>
+        </p:nvSpPr>
+        <p:spPr>
+          <a:xfrm>
+            <a:off x="6583680" y="2377440"/>
+            <a:ext cx="1828800" cy="384048"/>
+          </a:xfrm>
+          <a:prstGeom prst="rect">
+            <a:avLst/>
+          </a:prstGeom>
+          <a:noFill/>
+          <a:ln/>
+        </p:spPr>
+        <p:txBody>
+          <a:bodyPr wrap="square" lIns="0" tIns="0" rIns="0" bIns="0" rtlCol="0" anchor="ctr"/>
+          <a:lstStyle/>
+          <a:p>
+            <a:pPr indent="0" marL="0">
+              <a:buNone/>
+            </a:pPr>
+            <a:r>
+              <a:rPr lang="en-US" sz="1000" dirty="0">
+                <a:solidFill>
+                  <a:srgbClr val="C8C8D8"/>
+                </a:solidFill>
+                <a:latin typeface="Calibri" pitchFamily="34" charset="0"/>
+                <a:ea typeface="Calibri" pitchFamily="34" charset="-122"/>
+                <a:cs typeface="Calibri" pitchFamily="34" charset="-120"/>
+              </a:rPr>
+              <a:t>Morning briefings, pattern alerts, drift warnings</a:t>
+            </a:r>
+            <a:endParaRPr lang="en-US" sz="1000" dirty="0"/>
+          </a:p>
+        </p:txBody>
+      </p:sp>
+      <p:sp>
+        <p:nvSpPr>
+          <p:cNvPr id="30" name="Shape 26"/>
+          <p:cNvSpPr/>
+          <p:nvPr/>
+        </p:nvSpPr>
+        <p:spPr>
+          <a:xfrm>
+            <a:off x="5029200" y="2852928"/>
+            <a:ext cx="3474720" cy="384048"/>
+          </a:xfrm>
+          <a:prstGeom prst="rect">
+            <a:avLst/>
+          </a:prstGeom>
+          <a:solidFill>
+            <a:srgbClr val="FF6B6B">
+              <a:alpha val="8000"/>
+            </a:srgbClr>
+          </a:solidFill>
+          <a:ln/>
+        </p:spPr>
+      </p:sp>
+      <p:sp>
+        <p:nvSpPr>
+          <p:cNvPr id="31" name="Text 27"/>
+          <p:cNvSpPr/>
+          <p:nvPr/>
+        </p:nvSpPr>
+        <p:spPr>
+          <a:xfrm>
+            <a:off x="5212080" y="2852928"/>
+            <a:ext cx="1371600" cy="384048"/>
+          </a:xfrm>
+          <a:prstGeom prst="rect">
+            <a:avLst/>
+          </a:prstGeom>
+          <a:noFill/>
+          <a:ln/>
+        </p:spPr>
+        <p:txBody>
+          <a:bodyPr wrap="square" lIns="0" tIns="0" rIns="0" bIns="0" rtlCol="0" anchor="ctr"/>
+          <a:lstStyle/>
+          <a:p>
+            <a:pPr indent="0" marL="0">
+              <a:buNone/>
+            </a:pPr>
+            <a:r>
+              <a:rPr lang="en-US" sz="1100" b="1" dirty="0">
+                <a:solidFill>
+                  <a:srgbClr val="FF6B6B"/>
+                </a:solidFill>
+                <a:latin typeface="Calibri" pitchFamily="34" charset="0"/>
+                <a:ea typeface="Calibri" pitchFamily="34" charset="-122"/>
+                <a:cs typeface="Calibri" pitchFamily="34" charset="-120"/>
+              </a:rPr>
+              <a:t>You talk back</a:t>
+            </a:r>
+            <a:endParaRPr lang="en-US" sz="1100" dirty="0"/>
+          </a:p>
+        </p:txBody>
+      </p:sp>
+      <p:sp>
+        <p:nvSpPr>
+          <p:cNvPr id="32" name="Text 28"/>
+          <p:cNvSpPr/>
+          <p:nvPr/>
+        </p:nvSpPr>
+        <p:spPr>
+          <a:xfrm>
+            <a:off x="6583680" y="2852928"/>
+            <a:ext cx="1828800" cy="384048"/>
+          </a:xfrm>
+          <a:prstGeom prst="rect">
+            <a:avLst/>
+          </a:prstGeom>
+          <a:noFill/>
+          <a:ln/>
+        </p:spPr>
+        <p:txBody>
+          <a:bodyPr wrap="square" lIns="0" tIns="0" rIns="0" bIns="0" rtlCol="0" anchor="ctr"/>
+          <a:lstStyle/>
+          <a:p>
+            <a:pPr indent="0" marL="0">
+              <a:buNone/>
+            </a:pPr>
+            <a:r>
+              <a:rPr lang="en-US" sz="1000" dirty="0">
+                <a:solidFill>
+                  <a:srgbClr val="C8C8D8"/>
+                </a:solidFill>
+                <a:latin typeface="Calibri" pitchFamily="34" charset="0"/>
+                <a:ea typeface="Calibri" pitchFamily="34" charset="-122"/>
+                <a:cs typeface="Calibri" pitchFamily="34" charset="-120"/>
+              </a:rPr>
+              <a:t>Run frameworks, update status, ask questions</a:t>
+            </a:r>
+            <a:endParaRPr lang="en-US" sz="1000" dirty="0"/>
+          </a:p>
+        </p:txBody>
+      </p:sp>
+      <p:sp>
+        <p:nvSpPr>
+          <p:cNvPr id="33" name="Shape 29"/>
+          <p:cNvSpPr/>
+          <p:nvPr/>
+        </p:nvSpPr>
+        <p:spPr>
+          <a:xfrm>
+            <a:off x="5029200" y="3328416"/>
+            <a:ext cx="3474720" cy="384048"/>
+          </a:xfrm>
+          <a:prstGeom prst="rect">
+            <a:avLst/>
+          </a:prstGeom>
+          <a:solidFill>
+            <a:srgbClr val="FF6B6B">
+              <a:alpha val="8000"/>
+            </a:srgbClr>
+          </a:solidFill>
+          <a:ln/>
+        </p:spPr>
+      </p:sp>
+      <p:sp>
+        <p:nvSpPr>
+          <p:cNvPr id="34" name="Text 30"/>
+          <p:cNvSpPr/>
+          <p:nvPr/>
+        </p:nvSpPr>
+        <p:spPr>
+          <a:xfrm>
+            <a:off x="5212080" y="3328416"/>
+            <a:ext cx="1371600" cy="384048"/>
+          </a:xfrm>
+          <a:prstGeom prst="rect">
+            <a:avLst/>
+          </a:prstGeom>
+          <a:noFill/>
+          <a:ln/>
+        </p:spPr>
+        <p:txBody>
+          <a:bodyPr wrap="square" lIns="0" tIns="0" rIns="0" bIns="0" rtlCol="0" anchor="ctr"/>
+          <a:lstStyle/>
+          <a:p>
+            <a:pPr indent="0" marL="0">
+              <a:buNone/>
+            </a:pPr>
+            <a:r>
+              <a:rPr lang="en-US" sz="1100" b="1" dirty="0">
+                <a:solidFill>
+                  <a:srgbClr val="FF6B6B"/>
+                </a:solidFill>
+                <a:latin typeface="Calibri" pitchFamily="34" charset="0"/>
+                <a:ea typeface="Calibri" pitchFamily="34" charset="-122"/>
+                <a:cs typeface="Calibri" pitchFamily="34" charset="-120"/>
+              </a:rPr>
+              <a:t>Full conversations</a:t>
+            </a:r>
+            <a:endParaRPr lang="en-US" sz="1100" dirty="0"/>
+          </a:p>
+        </p:txBody>
+      </p:sp>
+      <p:sp>
+        <p:nvSpPr>
+          <p:cNvPr id="35" name="Text 31"/>
+          <p:cNvSpPr/>
+          <p:nvPr/>
+        </p:nvSpPr>
+        <p:spPr>
+          <a:xfrm>
+            <a:off x="6583680" y="3328416"/>
+            <a:ext cx="1828800" cy="384048"/>
+          </a:xfrm>
+          <a:prstGeom prst="rect">
+            <a:avLst/>
+          </a:prstGeom>
+          <a:noFill/>
+          <a:ln/>
+        </p:spPr>
+        <p:txBody>
+          <a:bodyPr wrap="square" lIns="0" tIns="0" rIns="0" bIns="0" rtlCol="0" anchor="ctr"/>
+          <a:lstStyle/>
+          <a:p>
+            <a:pPr indent="0" marL="0">
+              <a:buNone/>
+            </a:pPr>
+            <a:r>
+              <a:rPr lang="en-US" sz="1000" dirty="0">
+                <a:solidFill>
+                  <a:srgbClr val="C8C8D8"/>
+                </a:solidFill>
+                <a:latin typeface="Calibri" pitchFamily="34" charset="0"/>
+                <a:ea typeface="Calibri" pitchFamily="34" charset="-122"/>
+                <a:cs typeface="Calibri" pitchFamily="34" charset="-120"/>
+              </a:rPr>
+              <a:t>Not just commands. Real dialogue with your agents.</a:t>
+            </a:r>
+            <a:endParaRPr lang="en-US" sz="1000" dirty="0"/>
+          </a:p>
+        </p:txBody>
+      </p:sp>
+      <p:sp>
+        <p:nvSpPr>
+          <p:cNvPr id="36" name="Shape 32"/>
+          <p:cNvSpPr/>
+          <p:nvPr/>
+        </p:nvSpPr>
+        <p:spPr>
+          <a:xfrm>
+            <a:off x="5029200" y="3803904"/>
+            <a:ext cx="3474720" cy="384048"/>
+          </a:xfrm>
+          <a:prstGeom prst="rect">
+            <a:avLst/>
+          </a:prstGeom>
+          <a:solidFill>
+            <a:srgbClr val="FF6B6B">
+              <a:alpha val="8000"/>
+            </a:srgbClr>
+          </a:solidFill>
+          <a:ln/>
+        </p:spPr>
+      </p:sp>
+      <p:sp>
+        <p:nvSpPr>
+          <p:cNvPr id="37" name="Text 33"/>
+          <p:cNvSpPr/>
+          <p:nvPr/>
+        </p:nvSpPr>
+        <p:spPr>
+          <a:xfrm>
+            <a:off x="5212080" y="3803904"/>
+            <a:ext cx="1371600" cy="384048"/>
+          </a:xfrm>
+          <a:prstGeom prst="rect">
+            <a:avLst/>
+          </a:prstGeom>
+          <a:noFill/>
+          <a:ln/>
+        </p:spPr>
+        <p:txBody>
+          <a:bodyPr wrap="square" lIns="0" tIns="0" rIns="0" bIns="0" rtlCol="0" anchor="ctr"/>
+          <a:lstStyle/>
+          <a:p>
+            <a:pPr indent="0" marL="0">
+              <a:buNone/>
+            </a:pPr>
+            <a:r>
+              <a:rPr lang="en-US" sz="1100" b="1" dirty="0">
+                <a:solidFill>
+                  <a:srgbClr val="FF6B6B"/>
+                </a:solidFill>
+                <a:latin typeface="Calibri" pitchFamily="34" charset="0"/>
+                <a:ea typeface="Calibri" pitchFamily="34" charset="-122"/>
+                <a:cs typeface="Calibri" pitchFamily="34" charset="-120"/>
+              </a:rPr>
+              <a:t>From your phone</a:t>
+            </a:r>
+            <a:endParaRPr lang="en-US" sz="1100" dirty="0"/>
+          </a:p>
+        </p:txBody>
+      </p:sp>
+      <p:sp>
+        <p:nvSpPr>
+          <p:cNvPr id="38" name="Text 34"/>
+          <p:cNvSpPr/>
+          <p:nvPr/>
+        </p:nvSpPr>
+        <p:spPr>
+          <a:xfrm>
+            <a:off x="6583680" y="3803904"/>
+            <a:ext cx="1828800" cy="384048"/>
+          </a:xfrm>
+          <a:prstGeom prst="rect">
+            <a:avLst/>
+          </a:prstGeom>
+          <a:noFill/>
+          <a:ln/>
+        </p:spPr>
+        <p:txBody>
+          <a:bodyPr wrap="square" lIns="0" tIns="0" rIns="0" bIns="0" rtlCol="0" anchor="ctr"/>
+          <a:lstStyle/>
+          <a:p>
+            <a:pPr indent="0" marL="0">
+              <a:buNone/>
+            </a:pPr>
+            <a:r>
+              <a:rPr lang="en-US" sz="1000" dirty="0">
+                <a:solidFill>
+                  <a:srgbClr val="C8C8D8"/>
+                </a:solidFill>
+                <a:latin typeface="Calibri" pitchFamily="34" charset="0"/>
+                <a:ea typeface="Calibri" pitchFamily="34" charset="-122"/>
+                <a:cs typeface="Calibri" pitchFamily="34" charset="-120"/>
+              </a:rPr>
+              <a:t>No app install. Works anywhere Telegram does.</a:t>
+            </a:r>
+            <a:endParaRPr lang="en-US" sz="1000" dirty="0"/>
+          </a:p>
+        </p:txBody>
+      </p:sp>
+    </p:spTree>
+  </p:cSld>
+  <p:clrMapOvr>
+    <a:masterClrMapping/>
+  </p:clrMapOvr>
+</p:sld>
+</file>
+
+<file path=ppt/slides/slide17.xml><?xml version="1.0" encoding="utf-8"?>
+<p:sld xmlns:a="http://schemas.openxmlformats.org/drawingml/2006/main" xmlns:r="http://schemas.openxmlformats.org/officeDocument/2006/relationships" xmlns:p="http://schemas.openxmlformats.org/presentationml/2006/main">
+  <p:cSld name="Slide 17">
+    <p:bg>
+      <p:bgPr>
+        <a:solidFill>
           <a:srgbClr val="1A1A2E"/>
         </a:solidFill>
       </p:bgPr>
@@ -8214,7 +9709,7 @@
             <a:avLst/>
           </a:prstGeom>
           <a:solidFill>
-            <a:srgbClr val="FFD93D"/>
+            <a:srgbClr val="6C5CE7"/>
           </a:solidFill>
           <a:ln/>
         </p:spPr>
@@ -8246,34 +9741,640 @@
             <a:r>
               <a:rPr lang="en-US" sz="1400" b="1" spc="600" kern="0" dirty="0">
                 <a:solidFill>
+                  <a:srgbClr val="6C5CE7"/>
+                </a:solidFill>
+                <a:latin typeface="Calibri" pitchFamily="34" charset="0"/>
+                <a:ea typeface="Calibri" pitchFamily="34" charset="-122"/>
+                <a:cs typeface="Calibri" pitchFamily="34" charset="-120"/>
+              </a:rPr>
+              <a:t>THE AGENT ECOSYSTEM</a:t>
+            </a:r>
+            <a:endParaRPr lang="en-US" sz="1400" dirty="0"/>
+          </a:p>
+        </p:txBody>
+      </p:sp>
+      <p:sp>
+        <p:nvSpPr>
+          <p:cNvPr id="4" name="Text 2"/>
+          <p:cNvSpPr/>
+          <p:nvPr/>
+        </p:nvSpPr>
+        <p:spPr>
+          <a:xfrm>
+            <a:off x="457200" y="685800"/>
+            <a:ext cx="8229600" cy="365760"/>
+          </a:xfrm>
+          <a:prstGeom prst="rect">
+            <a:avLst/>
+          </a:prstGeom>
+          <a:noFill/>
+          <a:ln/>
+        </p:spPr>
+        <p:txBody>
+          <a:bodyPr wrap="square" lIns="0" tIns="0" rIns="0" bIns="0" rtlCol="0" anchor="ctr"/>
+          <a:lstStyle/>
+          <a:p>
+            <a:pPr indent="0" marL="0">
+              <a:buNone/>
+            </a:pPr>
+            <a:r>
+              <a:rPr lang="en-US" sz="1800" dirty="0">
+                <a:solidFill>
+                  <a:srgbClr val="C8C8D8"/>
+                </a:solidFill>
+                <a:latin typeface="Calibri" pitchFamily="34" charset="0"/>
+                <a:ea typeface="Calibri" pitchFamily="34" charset="-122"/>
+                <a:cs typeface="Calibri" pitchFamily="34" charset="-120"/>
+              </a:rPr>
+              <a:t>Mirror Palace as a knowledge layer for any agent runtime</a:t>
+            </a:r>
+            <a:endParaRPr lang="en-US" sz="1800" dirty="0"/>
+          </a:p>
+        </p:txBody>
+      </p:sp>
+      <p:sp>
+        <p:nvSpPr>
+          <p:cNvPr id="5" name="Shape 3"/>
+          <p:cNvSpPr/>
+          <p:nvPr/>
+        </p:nvSpPr>
+        <p:spPr>
+          <a:xfrm>
+            <a:off x="457200" y="1280160"/>
+            <a:ext cx="8229600" cy="1005840"/>
+          </a:xfrm>
+          <a:prstGeom prst="rect">
+            <a:avLst/>
+          </a:prstGeom>
+          <a:solidFill>
+            <a:srgbClr val="16213E"/>
+          </a:solidFill>
+          <a:ln/>
+          <a:effectLst>
+            <a:outerShdw sx="100000" sy="100000" kx="0" ky="0" algn="bl" rotWithShape="0" blurRad="76200" dist="25400" dir="8100000">
+              <a:srgbClr val="000000">
+                <a:alpha val="20000"/>
+              </a:srgbClr>
+            </a:outerShdw>
+          </a:effectLst>
+        </p:spPr>
+      </p:sp>
+      <p:sp>
+        <p:nvSpPr>
+          <p:cNvPr id="6" name="Shape 4"/>
+          <p:cNvSpPr/>
+          <p:nvPr/>
+        </p:nvSpPr>
+        <p:spPr>
+          <a:xfrm>
+            <a:off x="457200" y="1280160"/>
+            <a:ext cx="64008" cy="1005840"/>
+          </a:xfrm>
+          <a:prstGeom prst="rect">
+            <a:avLst/>
+          </a:prstGeom>
+          <a:solidFill>
+            <a:srgbClr val="4ECDC4"/>
+          </a:solidFill>
+          <a:ln/>
+        </p:spPr>
+      </p:sp>
+      <p:sp>
+        <p:nvSpPr>
+          <p:cNvPr id="7" name="Text 5"/>
+          <p:cNvSpPr/>
+          <p:nvPr/>
+        </p:nvSpPr>
+        <p:spPr>
+          <a:xfrm>
+            <a:off x="777240" y="1371600"/>
+            <a:ext cx="2743200" cy="320040"/>
+          </a:xfrm>
+          <a:prstGeom prst="rect">
+            <a:avLst/>
+          </a:prstGeom>
+          <a:noFill/>
+          <a:ln/>
+        </p:spPr>
+        <p:txBody>
+          <a:bodyPr wrap="square" lIns="0" tIns="0" rIns="0" bIns="0" rtlCol="0" anchor="ctr"/>
+          <a:lstStyle/>
+          <a:p>
+            <a:pPr indent="0" marL="0">
+              <a:buNone/>
+            </a:pPr>
+            <a:r>
+              <a:rPr lang="en-US" sz="1600" b="1" dirty="0">
+                <a:solidFill>
+                  <a:srgbClr val="4ECDC4"/>
+                </a:solidFill>
+                <a:latin typeface="Calibri" pitchFamily="34" charset="0"/>
+                <a:ea typeface="Calibri" pitchFamily="34" charset="-122"/>
+                <a:cs typeface="Calibri" pitchFamily="34" charset="-120"/>
+              </a:rPr>
+              <a:t>Claude Code</a:t>
+            </a:r>
+            <a:endParaRPr lang="en-US" sz="1600" dirty="0"/>
+          </a:p>
+        </p:txBody>
+      </p:sp>
+      <p:sp>
+        <p:nvSpPr>
+          <p:cNvPr id="8" name="Shape 6"/>
+          <p:cNvSpPr/>
+          <p:nvPr/>
+        </p:nvSpPr>
+        <p:spPr>
+          <a:xfrm>
+            <a:off x="7132320" y="1389888"/>
+            <a:ext cx="1280160" cy="274320"/>
+          </a:xfrm>
+          <a:prstGeom prst="rect">
+            <a:avLst/>
+          </a:prstGeom>
+          <a:solidFill>
+            <a:srgbClr val="4ECDC4">
+              <a:alpha val="20000"/>
+            </a:srgbClr>
+          </a:solidFill>
+          <a:ln/>
+        </p:spPr>
+      </p:sp>
+      <p:sp>
+        <p:nvSpPr>
+          <p:cNvPr id="9" name="Text 7"/>
+          <p:cNvSpPr/>
+          <p:nvPr/>
+        </p:nvSpPr>
+        <p:spPr>
+          <a:xfrm>
+            <a:off x="7132320" y="1389888"/>
+            <a:ext cx="1280160" cy="274320"/>
+          </a:xfrm>
+          <a:prstGeom prst="rect">
+            <a:avLst/>
+          </a:prstGeom>
+          <a:noFill/>
+          <a:ln/>
+        </p:spPr>
+        <p:txBody>
+          <a:bodyPr wrap="square" lIns="0" tIns="0" rIns="0" bIns="0" rtlCol="0" anchor="ctr"/>
+          <a:lstStyle/>
+          <a:p>
+            <a:pPr algn="ctr" indent="0" marL="0">
+              <a:buNone/>
+            </a:pPr>
+            <a:r>
+              <a:rPr lang="en-US" sz="900" b="1" spc="200" kern="0" dirty="0">
+                <a:solidFill>
+                  <a:srgbClr val="4ECDC4"/>
+                </a:solidFill>
+                <a:latin typeface="Calibri" pitchFamily="34" charset="0"/>
+                <a:ea typeface="Calibri" pitchFamily="34" charset="-122"/>
+                <a:cs typeface="Calibri" pitchFamily="34" charset="-120"/>
+              </a:rPr>
+              <a:t>LIVE</a:t>
+            </a:r>
+            <a:endParaRPr lang="en-US" sz="900" dirty="0"/>
+          </a:p>
+        </p:txBody>
+      </p:sp>
+      <p:sp>
+        <p:nvSpPr>
+          <p:cNvPr id="10" name="Text 8"/>
+          <p:cNvSpPr/>
+          <p:nvPr/>
+        </p:nvSpPr>
+        <p:spPr>
+          <a:xfrm>
+            <a:off x="777240" y="1737360"/>
+            <a:ext cx="7589520" cy="457200"/>
+          </a:xfrm>
+          <a:prstGeom prst="rect">
+            <a:avLst/>
+          </a:prstGeom>
+          <a:noFill/>
+          <a:ln/>
+        </p:spPr>
+        <p:txBody>
+          <a:bodyPr wrap="square" lIns="0" tIns="0" rIns="0" bIns="0" rtlCol="0" anchor="ctr"/>
+          <a:lstStyle/>
+          <a:p>
+            <a:pPr indent="0" marL="0">
+              <a:lnSpc>
+                <a:spcPct val="130000"/>
+              </a:lnSpc>
+              <a:buNone/>
+            </a:pPr>
+            <a:r>
+              <a:rPr lang="en-US" sz="1100" dirty="0">
+                <a:solidFill>
+                  <a:srgbClr val="C8C8D8"/>
+                </a:solidFill>
+                <a:latin typeface="Calibri" pitchFamily="34" charset="0"/>
+                <a:ea typeface="Calibri" pitchFamily="34" charset="-122"/>
+                <a:cs typeface="Calibri" pitchFamily="34" charset="-120"/>
+              </a:rPr>
+              <a:t>Direct integration via CLAUDE.md and AGENTS.md. Agents read frameworks, update status, and apply patterns in every session.</a:t>
+            </a:r>
+            <a:endParaRPr lang="en-US" sz="1100" dirty="0"/>
+          </a:p>
+        </p:txBody>
+      </p:sp>
+      <p:sp>
+        <p:nvSpPr>
+          <p:cNvPr id="11" name="Shape 9"/>
+          <p:cNvSpPr/>
+          <p:nvPr/>
+        </p:nvSpPr>
+        <p:spPr>
+          <a:xfrm>
+            <a:off x="457200" y="2468880"/>
+            <a:ext cx="8229600" cy="1005840"/>
+          </a:xfrm>
+          <a:prstGeom prst="rect">
+            <a:avLst/>
+          </a:prstGeom>
+          <a:solidFill>
+            <a:srgbClr val="16213E"/>
+          </a:solidFill>
+          <a:ln/>
+          <a:effectLst>
+            <a:outerShdw sx="100000" sy="100000" kx="0" ky="0" algn="bl" rotWithShape="0" blurRad="76200" dist="25400" dir="8100000">
+              <a:srgbClr val="000000">
+                <a:alpha val="20000"/>
+              </a:srgbClr>
+            </a:outerShdw>
+          </a:effectLst>
+        </p:spPr>
+      </p:sp>
+      <p:sp>
+        <p:nvSpPr>
+          <p:cNvPr id="12" name="Shape 10"/>
+          <p:cNvSpPr/>
+          <p:nvPr/>
+        </p:nvSpPr>
+        <p:spPr>
+          <a:xfrm>
+            <a:off x="457200" y="2468880"/>
+            <a:ext cx="64008" cy="1005840"/>
+          </a:xfrm>
+          <a:prstGeom prst="rect">
+            <a:avLst/>
+          </a:prstGeom>
+          <a:solidFill>
+            <a:srgbClr val="FF6B6B"/>
+          </a:solidFill>
+          <a:ln/>
+        </p:spPr>
+      </p:sp>
+      <p:sp>
+        <p:nvSpPr>
+          <p:cNvPr id="13" name="Text 11"/>
+          <p:cNvSpPr/>
+          <p:nvPr/>
+        </p:nvSpPr>
+        <p:spPr>
+          <a:xfrm>
+            <a:off x="777240" y="2560320"/>
+            <a:ext cx="2743200" cy="320040"/>
+          </a:xfrm>
+          <a:prstGeom prst="rect">
+            <a:avLst/>
+          </a:prstGeom>
+          <a:noFill/>
+          <a:ln/>
+        </p:spPr>
+        <p:txBody>
+          <a:bodyPr wrap="square" lIns="0" tIns="0" rIns="0" bIns="0" rtlCol="0" anchor="ctr"/>
+          <a:lstStyle/>
+          <a:p>
+            <a:pPr indent="0" marL="0">
+              <a:buNone/>
+            </a:pPr>
+            <a:r>
+              <a:rPr lang="en-US" sz="1600" b="1" dirty="0">
+                <a:solidFill>
+                  <a:srgbClr val="FF6B6B"/>
+                </a:solidFill>
+                <a:latin typeface="Calibri" pitchFamily="34" charset="0"/>
+                <a:ea typeface="Calibri" pitchFamily="34" charset="-122"/>
+                <a:cs typeface="Calibri" pitchFamily="34" charset="-120"/>
+              </a:rPr>
+              <a:t>OpenClaw</a:t>
+            </a:r>
+            <a:endParaRPr lang="en-US" sz="1600" dirty="0"/>
+          </a:p>
+        </p:txBody>
+      </p:sp>
+      <p:sp>
+        <p:nvSpPr>
+          <p:cNvPr id="14" name="Shape 12"/>
+          <p:cNvSpPr/>
+          <p:nvPr/>
+        </p:nvSpPr>
+        <p:spPr>
+          <a:xfrm>
+            <a:off x="7132320" y="2578608"/>
+            <a:ext cx="1280160" cy="274320"/>
+          </a:xfrm>
+          <a:prstGeom prst="rect">
+            <a:avLst/>
+          </a:prstGeom>
+          <a:solidFill>
+            <a:srgbClr val="4ECDC4">
+              <a:alpha val="20000"/>
+            </a:srgbClr>
+          </a:solidFill>
+          <a:ln/>
+        </p:spPr>
+      </p:sp>
+      <p:sp>
+        <p:nvSpPr>
+          <p:cNvPr id="15" name="Text 13"/>
+          <p:cNvSpPr/>
+          <p:nvPr/>
+        </p:nvSpPr>
+        <p:spPr>
+          <a:xfrm>
+            <a:off x="7132320" y="2578608"/>
+            <a:ext cx="1280160" cy="274320"/>
+          </a:xfrm>
+          <a:prstGeom prst="rect">
+            <a:avLst/>
+          </a:prstGeom>
+          <a:noFill/>
+          <a:ln/>
+        </p:spPr>
+        <p:txBody>
+          <a:bodyPr wrap="square" lIns="0" tIns="0" rIns="0" bIns="0" rtlCol="0" anchor="ctr"/>
+          <a:lstStyle/>
+          <a:p>
+            <a:pPr algn="ctr" indent="0" marL="0">
+              <a:buNone/>
+            </a:pPr>
+            <a:r>
+              <a:rPr lang="en-US" sz="900" b="1" spc="200" kern="0" dirty="0">
+                <a:solidFill>
+                  <a:srgbClr val="4ECDC4"/>
+                </a:solidFill>
+                <a:latin typeface="Calibri" pitchFamily="34" charset="0"/>
+                <a:ea typeface="Calibri" pitchFamily="34" charset="-122"/>
+                <a:cs typeface="Calibri" pitchFamily="34" charset="-120"/>
+              </a:rPr>
+              <a:t>LIVE</a:t>
+            </a:r>
+            <a:endParaRPr lang="en-US" sz="900" dirty="0"/>
+          </a:p>
+        </p:txBody>
+      </p:sp>
+      <p:sp>
+        <p:nvSpPr>
+          <p:cNvPr id="16" name="Text 14"/>
+          <p:cNvSpPr/>
+          <p:nvPr/>
+        </p:nvSpPr>
+        <p:spPr>
+          <a:xfrm>
+            <a:off x="777240" y="2926080"/>
+            <a:ext cx="7589520" cy="457200"/>
+          </a:xfrm>
+          <a:prstGeom prst="rect">
+            <a:avLst/>
+          </a:prstGeom>
+          <a:noFill/>
+          <a:ln/>
+        </p:spPr>
+        <p:txBody>
+          <a:bodyPr wrap="square" lIns="0" tIns="0" rIns="0" bIns="0" rtlCol="0" anchor="ctr"/>
+          <a:lstStyle/>
+          <a:p>
+            <a:pPr indent="0" marL="0">
+              <a:lnSpc>
+                <a:spcPct val="130000"/>
+              </a:lnSpc>
+              <a:buNone/>
+            </a:pPr>
+            <a:r>
+              <a:rPr lang="en-US" sz="1100" dirty="0">
+                <a:solidFill>
+                  <a:srgbClr val="C8C8D8"/>
+                </a:solidFill>
+                <a:latin typeface="Calibri" pitchFamily="34" charset="0"/>
+                <a:ea typeface="Calibri" pitchFamily="34" charset="-122"/>
+                <a:cs typeface="Calibri" pitchFamily="34" charset="-120"/>
+              </a:rPr>
+              <a:t>Open-source agent runtime with Telegram, Discord, and web channels. Full conversational loop with your Mirror Palace agents from your phone.</a:t>
+            </a:r>
+            <a:endParaRPr lang="en-US" sz="1100" dirty="0"/>
+          </a:p>
+        </p:txBody>
+      </p:sp>
+      <p:sp>
+        <p:nvSpPr>
+          <p:cNvPr id="17" name="Shape 15"/>
+          <p:cNvSpPr/>
+          <p:nvPr/>
+        </p:nvSpPr>
+        <p:spPr>
+          <a:xfrm>
+            <a:off x="457200" y="3657600"/>
+            <a:ext cx="8229600" cy="1005840"/>
+          </a:xfrm>
+          <a:prstGeom prst="rect">
+            <a:avLst/>
+          </a:prstGeom>
+          <a:solidFill>
+            <a:srgbClr val="16213E"/>
+          </a:solidFill>
+          <a:ln/>
+          <a:effectLst>
+            <a:outerShdw sx="100000" sy="100000" kx="0" ky="0" algn="bl" rotWithShape="0" blurRad="76200" dist="25400" dir="8100000">
+              <a:srgbClr val="000000">
+                <a:alpha val="20000"/>
+              </a:srgbClr>
+            </a:outerShdw>
+          </a:effectLst>
+        </p:spPr>
+      </p:sp>
+      <p:sp>
+        <p:nvSpPr>
+          <p:cNvPr id="18" name="Shape 16"/>
+          <p:cNvSpPr/>
+          <p:nvPr/>
+        </p:nvSpPr>
+        <p:spPr>
+          <a:xfrm>
+            <a:off x="457200" y="3657600"/>
+            <a:ext cx="64008" cy="1005840"/>
+          </a:xfrm>
+          <a:prstGeom prst="rect">
+            <a:avLst/>
+          </a:prstGeom>
+          <a:solidFill>
+            <a:srgbClr val="6C5CE7"/>
+          </a:solidFill>
+          <a:ln/>
+        </p:spPr>
+      </p:sp>
+      <p:sp>
+        <p:nvSpPr>
+          <p:cNvPr id="19" name="Text 17"/>
+          <p:cNvSpPr/>
+          <p:nvPr/>
+        </p:nvSpPr>
+        <p:spPr>
+          <a:xfrm>
+            <a:off x="777240" y="3749040"/>
+            <a:ext cx="2743200" cy="320040"/>
+          </a:xfrm>
+          <a:prstGeom prst="rect">
+            <a:avLst/>
+          </a:prstGeom>
+          <a:noFill/>
+          <a:ln/>
+        </p:spPr>
+        <p:txBody>
+          <a:bodyPr wrap="square" lIns="0" tIns="0" rIns="0" bIns="0" rtlCol="0" anchor="ctr"/>
+          <a:lstStyle/>
+          <a:p>
+            <a:pPr indent="0" marL="0">
+              <a:buNone/>
+            </a:pPr>
+            <a:r>
+              <a:rPr lang="en-US" sz="1600" b="1" dirty="0">
+                <a:solidFill>
+                  <a:srgbClr val="6C5CE7"/>
+                </a:solidFill>
+                <a:latin typeface="Calibri" pitchFamily="34" charset="0"/>
+                <a:ea typeface="Calibri" pitchFamily="34" charset="-122"/>
+                <a:cs typeface="Calibri" pitchFamily="34" charset="-120"/>
+              </a:rPr>
+              <a:t>Claude Managed Agents</a:t>
+            </a:r>
+            <a:endParaRPr lang="en-US" sz="1600" dirty="0"/>
+          </a:p>
+        </p:txBody>
+      </p:sp>
+      <p:sp>
+        <p:nvSpPr>
+          <p:cNvPr id="20" name="Shape 18"/>
+          <p:cNvSpPr/>
+          <p:nvPr/>
+        </p:nvSpPr>
+        <p:spPr>
+          <a:xfrm>
+            <a:off x="7132320" y="3767328"/>
+            <a:ext cx="1280160" cy="274320"/>
+          </a:xfrm>
+          <a:prstGeom prst="rect">
+            <a:avLst/>
+          </a:prstGeom>
+          <a:solidFill>
+            <a:srgbClr val="FFD93D">
+              <a:alpha val="20000"/>
+            </a:srgbClr>
+          </a:solidFill>
+          <a:ln/>
+        </p:spPr>
+      </p:sp>
+      <p:sp>
+        <p:nvSpPr>
+          <p:cNvPr id="21" name="Text 19"/>
+          <p:cNvSpPr/>
+          <p:nvPr/>
+        </p:nvSpPr>
+        <p:spPr>
+          <a:xfrm>
+            <a:off x="7132320" y="3767328"/>
+            <a:ext cx="1280160" cy="274320"/>
+          </a:xfrm>
+          <a:prstGeom prst="rect">
+            <a:avLst/>
+          </a:prstGeom>
+          <a:noFill/>
+          <a:ln/>
+        </p:spPr>
+        <p:txBody>
+          <a:bodyPr wrap="square" lIns="0" tIns="0" rIns="0" bIns="0" rtlCol="0" anchor="ctr"/>
+          <a:lstStyle/>
+          <a:p>
+            <a:pPr algn="ctr" indent="0" marL="0">
+              <a:buNone/>
+            </a:pPr>
+            <a:r>
+              <a:rPr lang="en-US" sz="900" b="1" spc="200" kern="0" dirty="0">
+                <a:solidFill>
                   <a:srgbClr val="FFD93D"/>
                 </a:solidFill>
                 <a:latin typeface="Calibri" pitchFamily="34" charset="0"/>
                 <a:ea typeface="Calibri" pitchFamily="34" charset="-122"/>
                 <a:cs typeface="Calibri" pitchFamily="34" charset="-120"/>
               </a:rPr>
-              <a:t>THE DEEPER POINT</a:t>
-            </a:r>
-            <a:endParaRPr lang="en-US" sz="1400" dirty="0"/>
-          </a:p>
-        </p:txBody>
-      </p:sp>
-      <p:sp>
-        <p:nvSpPr>
-          <p:cNvPr id="4" name="Shape 2"/>
-          <p:cNvSpPr/>
-          <p:nvPr/>
-        </p:nvSpPr>
-        <p:spPr>
-          <a:xfrm>
-            <a:off x="457200" y="822960"/>
-            <a:ext cx="8229600" cy="731520"/>
-          </a:xfrm>
-          <a:prstGeom prst="rect">
-            <a:avLst/>
-          </a:prstGeom>
-          <a:solidFill>
-            <a:srgbClr val="FFD93D">
+              <a:t>APRIL 2026</a:t>
+            </a:r>
+            <a:endParaRPr lang="en-US" sz="900" dirty="0"/>
+          </a:p>
+        </p:txBody>
+      </p:sp>
+      <p:sp>
+        <p:nvSpPr>
+          <p:cNvPr id="22" name="Text 20"/>
+          <p:cNvSpPr/>
+          <p:nvPr/>
+        </p:nvSpPr>
+        <p:spPr>
+          <a:xfrm>
+            <a:off x="777240" y="4114800"/>
+            <a:ext cx="7589520" cy="457200"/>
+          </a:xfrm>
+          <a:prstGeom prst="rect">
+            <a:avLst/>
+          </a:prstGeom>
+          <a:noFill/>
+          <a:ln/>
+        </p:spPr>
+        <p:txBody>
+          <a:bodyPr wrap="square" lIns="0" tIns="0" rIns="0" bIns="0" rtlCol="0" anchor="ctr"/>
+          <a:lstStyle/>
+          <a:p>
+            <a:pPr indent="0" marL="0">
+              <a:lnSpc>
+                <a:spcPct val="130000"/>
+              </a:lnSpc>
+              <a:buNone/>
+            </a:pPr>
+            <a:r>
+              <a:rPr lang="en-US" sz="1100" dirty="0">
+                <a:solidFill>
+                  <a:srgbClr val="C8C8D8"/>
+                </a:solidFill>
+                <a:latin typeface="Calibri" pitchFamily="34" charset="0"/>
+                <a:ea typeface="Calibri" pitchFamily="34" charset="-122"/>
+                <a:cs typeface="Calibri" pitchFamily="34" charset="-120"/>
+              </a:rPr>
+              <a:t>Anthropic's new managed infrastructure for autonomous agents. Persistent state, sandboxed execution, long-running tasks. Mirror Palace provides the self-knowledge layer.</a:t>
+            </a:r>
+            <a:endParaRPr lang="en-US" sz="1100" dirty="0"/>
+          </a:p>
+        </p:txBody>
+      </p:sp>
+      <p:sp>
+        <p:nvSpPr>
+          <p:cNvPr id="23" name="Shape 21"/>
+          <p:cNvSpPr/>
+          <p:nvPr/>
+        </p:nvSpPr>
+        <p:spPr>
+          <a:xfrm>
+            <a:off x="457200" y="4434840"/>
+            <a:ext cx="8229600" cy="365760"/>
+          </a:xfrm>
+          <a:prstGeom prst="rect">
+            <a:avLst/>
+          </a:prstGeom>
+          <a:solidFill>
+            <a:srgbClr val="6C5CE7">
               <a:alpha val="10000"/>
             </a:srgbClr>
           </a:solidFill>
@@ -8282,433 +10383,38 @@
       </p:sp>
       <p:sp>
         <p:nvSpPr>
-          <p:cNvPr id="5" name="Text 3"/>
-          <p:cNvSpPr/>
-          <p:nvPr/>
-        </p:nvSpPr>
-        <p:spPr>
-          <a:xfrm>
-            <a:off x="640080" y="822960"/>
-            <a:ext cx="7863840" cy="731520"/>
-          </a:xfrm>
-          <a:prstGeom prst="rect">
-            <a:avLst/>
-          </a:prstGeom>
-          <a:noFill/>
-          <a:ln/>
-        </p:spPr>
-        <p:txBody>
-          <a:bodyPr wrap="square" lIns="0" tIns="0" rIns="0" bIns="0" rtlCol="0" anchor="ctr"/>
-          <a:lstStyle/>
-          <a:p>
-            <a:pPr indent="0" marL="0">
-              <a:buNone/>
-            </a:pPr>
-            <a:r>
-              <a:rPr lang="en-US" sz="2000" b="1" dirty="0">
-                <a:solidFill>
-                  <a:srgbClr val="FFFFFF"/>
-                </a:solidFill>
-                <a:latin typeface="Calibri" pitchFamily="34" charset="0"/>
-                <a:ea typeface="Calibri" pitchFamily="34" charset="-122"/>
-                <a:cs typeface="Calibri" pitchFamily="34" charset="-120"/>
-              </a:rPr>
-              <a:t>It knows when "I'll start Monday" means "I'm avoiding this."</a:t>
-            </a:r>
-            <a:endParaRPr lang="en-US" sz="2000" dirty="0"/>
-          </a:p>
-        </p:txBody>
-      </p:sp>
-      <p:sp>
-        <p:nvSpPr>
-          <p:cNvPr id="6" name="Shape 4"/>
-          <p:cNvSpPr/>
-          <p:nvPr/>
-        </p:nvSpPr>
-        <p:spPr>
-          <a:xfrm>
-            <a:off x="457200" y="1737360"/>
-            <a:ext cx="8229600" cy="502920"/>
-          </a:xfrm>
-          <a:prstGeom prst="rect">
-            <a:avLst/>
-          </a:prstGeom>
-          <a:solidFill>
-            <a:srgbClr val="16213E"/>
-          </a:solidFill>
-          <a:ln/>
-        </p:spPr>
-      </p:sp>
-      <p:sp>
-        <p:nvSpPr>
-          <p:cNvPr id="7" name="Shape 5"/>
-          <p:cNvSpPr/>
-          <p:nvPr/>
-        </p:nvSpPr>
-        <p:spPr>
-          <a:xfrm>
-            <a:off x="457200" y="1737360"/>
-            <a:ext cx="54864" cy="502920"/>
-          </a:xfrm>
-          <a:prstGeom prst="rect">
-            <a:avLst/>
-          </a:prstGeom>
-          <a:solidFill>
-            <a:srgbClr val="4ECDC4"/>
-          </a:solidFill>
-          <a:ln/>
-        </p:spPr>
-      </p:sp>
-      <p:sp>
-        <p:nvSpPr>
-          <p:cNvPr id="8" name="Text 6"/>
-          <p:cNvSpPr/>
-          <p:nvPr/>
-        </p:nvSpPr>
-        <p:spPr>
-          <a:xfrm>
-            <a:off x="731520" y="1737360"/>
-            <a:ext cx="7772400" cy="502920"/>
-          </a:xfrm>
-          <a:prstGeom prst="rect">
-            <a:avLst/>
-          </a:prstGeom>
-          <a:noFill/>
-          <a:ln/>
-        </p:spPr>
-        <p:txBody>
-          <a:bodyPr wrap="square" lIns="0" tIns="0" rIns="0" bIns="0" rtlCol="0" anchor="ctr"/>
-          <a:lstStyle/>
-          <a:p>
-            <a:pPr indent="0" marL="0">
-              <a:buNone/>
-            </a:pPr>
-            <a:r>
-              <a:rPr lang="en-US" sz="1200" dirty="0">
-                <a:solidFill>
-                  <a:srgbClr val="C8C8D8"/>
-                </a:solidFill>
-                <a:latin typeface="Calibri" pitchFamily="34" charset="0"/>
-                <a:ea typeface="Calibri" pitchFamily="34" charset="-122"/>
-                <a:cs typeface="Calibri" pitchFamily="34" charset="-120"/>
-              </a:rPr>
-              <a:t>When your calendar fills up, it's not ambition. It's over-commitment.</a:t>
-            </a:r>
-            <a:endParaRPr lang="en-US" sz="1200" dirty="0"/>
-          </a:p>
-        </p:txBody>
-      </p:sp>
-      <p:sp>
-        <p:nvSpPr>
-          <p:cNvPr id="9" name="Shape 7"/>
-          <p:cNvSpPr/>
-          <p:nvPr/>
-        </p:nvSpPr>
-        <p:spPr>
-          <a:xfrm>
-            <a:off x="457200" y="2359152"/>
-            <a:ext cx="8229600" cy="502920"/>
-          </a:xfrm>
-          <a:prstGeom prst="rect">
-            <a:avLst/>
-          </a:prstGeom>
-          <a:solidFill>
-            <a:srgbClr val="16213E"/>
-          </a:solidFill>
-          <a:ln/>
-        </p:spPr>
-      </p:sp>
-      <p:sp>
-        <p:nvSpPr>
-          <p:cNvPr id="10" name="Shape 8"/>
-          <p:cNvSpPr/>
-          <p:nvPr/>
-        </p:nvSpPr>
-        <p:spPr>
-          <a:xfrm>
-            <a:off x="457200" y="2359152"/>
-            <a:ext cx="54864" cy="502920"/>
-          </a:xfrm>
-          <a:prstGeom prst="rect">
-            <a:avLst/>
-          </a:prstGeom>
-          <a:solidFill>
-            <a:srgbClr val="FF6B6B"/>
-          </a:solidFill>
-          <a:ln/>
-        </p:spPr>
-      </p:sp>
-      <p:sp>
-        <p:nvSpPr>
-          <p:cNvPr id="11" name="Text 9"/>
-          <p:cNvSpPr/>
-          <p:nvPr/>
-        </p:nvSpPr>
-        <p:spPr>
-          <a:xfrm>
-            <a:off x="731520" y="2359152"/>
-            <a:ext cx="7772400" cy="502920"/>
-          </a:xfrm>
-          <a:prstGeom prst="rect">
-            <a:avLst/>
-          </a:prstGeom>
-          <a:noFill/>
-          <a:ln/>
-        </p:spPr>
-        <p:txBody>
-          <a:bodyPr wrap="square" lIns="0" tIns="0" rIns="0" bIns="0" rtlCol="0" anchor="ctr"/>
-          <a:lstStyle/>
-          <a:p>
-            <a:pPr indent="0" marL="0">
-              <a:buNone/>
-            </a:pPr>
-            <a:r>
-              <a:rPr lang="en-US" sz="1200" dirty="0">
-                <a:solidFill>
-                  <a:srgbClr val="C8C8D8"/>
-                </a:solidFill>
-                <a:latin typeface="Calibri" pitchFamily="34" charset="0"/>
-                <a:ea typeface="Calibri" pitchFamily="34" charset="-122"/>
-                <a:cs typeface="Calibri" pitchFamily="34" charset="-120"/>
-              </a:rPr>
-              <a:t>When you go quiet in relationships, it's a pattern, not a preference.</a:t>
-            </a:r>
-            <a:endParaRPr lang="en-US" sz="1200" dirty="0"/>
-          </a:p>
-        </p:txBody>
-      </p:sp>
-      <p:sp>
-        <p:nvSpPr>
-          <p:cNvPr id="12" name="Shape 10"/>
-          <p:cNvSpPr/>
-          <p:nvPr/>
-        </p:nvSpPr>
-        <p:spPr>
-          <a:xfrm>
-            <a:off x="457200" y="2980944"/>
-            <a:ext cx="8229600" cy="502920"/>
-          </a:xfrm>
-          <a:prstGeom prst="rect">
-            <a:avLst/>
-          </a:prstGeom>
-          <a:solidFill>
-            <a:srgbClr val="16213E"/>
-          </a:solidFill>
-          <a:ln/>
-        </p:spPr>
-      </p:sp>
-      <p:sp>
-        <p:nvSpPr>
-          <p:cNvPr id="13" name="Shape 11"/>
-          <p:cNvSpPr/>
-          <p:nvPr/>
-        </p:nvSpPr>
-        <p:spPr>
-          <a:xfrm>
-            <a:off x="457200" y="2980944"/>
-            <a:ext cx="54864" cy="502920"/>
-          </a:xfrm>
-          <a:prstGeom prst="rect">
-            <a:avLst/>
-          </a:prstGeom>
-          <a:solidFill>
-            <a:srgbClr val="6C5CE7"/>
-          </a:solidFill>
-          <a:ln/>
-        </p:spPr>
-      </p:sp>
-      <p:sp>
-        <p:nvSpPr>
-          <p:cNvPr id="14" name="Text 12"/>
-          <p:cNvSpPr/>
-          <p:nvPr/>
-        </p:nvSpPr>
-        <p:spPr>
-          <a:xfrm>
-            <a:off x="731520" y="2980944"/>
-            <a:ext cx="7772400" cy="502920"/>
-          </a:xfrm>
-          <a:prstGeom prst="rect">
-            <a:avLst/>
-          </a:prstGeom>
-          <a:noFill/>
-          <a:ln/>
-        </p:spPr>
-        <p:txBody>
-          <a:bodyPr wrap="square" lIns="0" tIns="0" rIns="0" bIns="0" rtlCol="0" anchor="ctr"/>
-          <a:lstStyle/>
-          <a:p>
-            <a:pPr indent="0" marL="0">
-              <a:buNone/>
-            </a:pPr>
-            <a:r>
-              <a:rPr lang="en-US" sz="1200" dirty="0">
-                <a:solidFill>
-                  <a:srgbClr val="C8C8D8"/>
-                </a:solidFill>
-                <a:latin typeface="Calibri" pitchFamily="34" charset="0"/>
-                <a:ea typeface="Calibri" pitchFamily="34" charset="-122"/>
-                <a:cs typeface="Calibri" pitchFamily="34" charset="-120"/>
-              </a:rPr>
-              <a:t>When you compare yourself to others, your self-worth is untethered from your actual work.</a:t>
-            </a:r>
-            <a:endParaRPr lang="en-US" sz="1200" dirty="0"/>
-          </a:p>
-        </p:txBody>
-      </p:sp>
-      <p:sp>
-        <p:nvSpPr>
-          <p:cNvPr id="15" name="Shape 13"/>
-          <p:cNvSpPr/>
-          <p:nvPr/>
-        </p:nvSpPr>
-        <p:spPr>
-          <a:xfrm>
-            <a:off x="457200" y="3602736"/>
-            <a:ext cx="8229600" cy="502920"/>
-          </a:xfrm>
-          <a:prstGeom prst="rect">
-            <a:avLst/>
-          </a:prstGeom>
-          <a:solidFill>
-            <a:srgbClr val="16213E"/>
-          </a:solidFill>
-          <a:ln/>
-        </p:spPr>
-      </p:sp>
-      <p:sp>
-        <p:nvSpPr>
-          <p:cNvPr id="16" name="Shape 14"/>
-          <p:cNvSpPr/>
-          <p:nvPr/>
-        </p:nvSpPr>
-        <p:spPr>
-          <a:xfrm>
-            <a:off x="457200" y="3602736"/>
-            <a:ext cx="54864" cy="502920"/>
-          </a:xfrm>
-          <a:prstGeom prst="rect">
-            <a:avLst/>
-          </a:prstGeom>
-          <a:solidFill>
-            <a:srgbClr val="FFD93D"/>
-          </a:solidFill>
-          <a:ln/>
-        </p:spPr>
-      </p:sp>
-      <p:sp>
-        <p:nvSpPr>
-          <p:cNvPr id="17" name="Text 15"/>
-          <p:cNvSpPr/>
-          <p:nvPr/>
-        </p:nvSpPr>
-        <p:spPr>
-          <a:xfrm>
-            <a:off x="731520" y="3602736"/>
-            <a:ext cx="7772400" cy="502920"/>
-          </a:xfrm>
-          <a:prstGeom prst="rect">
-            <a:avLst/>
-          </a:prstGeom>
-          <a:noFill/>
-          <a:ln/>
-        </p:spPr>
-        <p:txBody>
-          <a:bodyPr wrap="square" lIns="0" tIns="0" rIns="0" bIns="0" rtlCol="0" anchor="ctr"/>
-          <a:lstStyle/>
-          <a:p>
-            <a:pPr indent="0" marL="0">
-              <a:buNone/>
-            </a:pPr>
-            <a:r>
-              <a:rPr lang="en-US" sz="1200" dirty="0">
-                <a:solidFill>
-                  <a:srgbClr val="C8C8D8"/>
-                </a:solidFill>
-                <a:latin typeface="Calibri" pitchFamily="34" charset="0"/>
-                <a:ea typeface="Calibri" pitchFamily="34" charset="-122"/>
-                <a:cs typeface="Calibri" pitchFamily="34" charset="-120"/>
-              </a:rPr>
-              <a:t>When you start something new with intense energy, the follow-through is the real test.</a:t>
-            </a:r>
-            <a:endParaRPr lang="en-US" sz="1200" dirty="0"/>
-          </a:p>
-        </p:txBody>
-      </p:sp>
-      <p:sp>
-        <p:nvSpPr>
-          <p:cNvPr id="18" name="Shape 16"/>
-          <p:cNvSpPr/>
-          <p:nvPr/>
-        </p:nvSpPr>
-        <p:spPr>
-          <a:xfrm>
-            <a:off x="457200" y="4224528"/>
-            <a:ext cx="8229600" cy="502920"/>
-          </a:xfrm>
-          <a:prstGeom prst="rect">
-            <a:avLst/>
-          </a:prstGeom>
-          <a:solidFill>
-            <a:srgbClr val="16213E"/>
-          </a:solidFill>
-          <a:ln/>
-        </p:spPr>
-      </p:sp>
-      <p:sp>
-        <p:nvSpPr>
-          <p:cNvPr id="19" name="Shape 17"/>
-          <p:cNvSpPr/>
-          <p:nvPr/>
-        </p:nvSpPr>
-        <p:spPr>
-          <a:xfrm>
-            <a:off x="457200" y="4224528"/>
-            <a:ext cx="54864" cy="502920"/>
-          </a:xfrm>
-          <a:prstGeom prst="rect">
-            <a:avLst/>
-          </a:prstGeom>
-          <a:solidFill>
-            <a:srgbClr val="4ECDC4"/>
-          </a:solidFill>
-          <a:ln/>
-        </p:spPr>
-      </p:sp>
-      <p:sp>
-        <p:nvSpPr>
-          <p:cNvPr id="20" name="Text 18"/>
-          <p:cNvSpPr/>
-          <p:nvPr/>
-        </p:nvSpPr>
-        <p:spPr>
-          <a:xfrm>
-            <a:off x="731520" y="4224528"/>
-            <a:ext cx="7772400" cy="502920"/>
-          </a:xfrm>
-          <a:prstGeom prst="rect">
-            <a:avLst/>
-          </a:prstGeom>
-          <a:noFill/>
-          <a:ln/>
-        </p:spPr>
-        <p:txBody>
-          <a:bodyPr wrap="square" lIns="0" tIns="0" rIns="0" bIns="0" rtlCol="0" anchor="ctr"/>
-          <a:lstStyle/>
-          <a:p>
-            <a:pPr indent="0" marL="0">
-              <a:buNone/>
-            </a:pPr>
-            <a:r>
-              <a:rPr lang="en-US" sz="1200" dirty="0">
-                <a:solidFill>
-                  <a:srgbClr val="C8C8D8"/>
-                </a:solidFill>
-                <a:latin typeface="Calibri" pitchFamily="34" charset="0"/>
-                <a:ea typeface="Calibri" pitchFamily="34" charset="-122"/>
-                <a:cs typeface="Calibri" pitchFamily="34" charset="-120"/>
-              </a:rPr>
-              <a:t>That knowledge, structured and continuously updated, turns an assistant into a thinking partner.</a:t>
+          <p:cNvPr id="24" name="Text 22"/>
+          <p:cNvSpPr/>
+          <p:nvPr/>
+        </p:nvSpPr>
+        <p:spPr>
+          <a:xfrm>
+            <a:off x="640080" y="4434840"/>
+            <a:ext cx="7863840" cy="365760"/>
+          </a:xfrm>
+          <a:prstGeom prst="rect">
+            <a:avLst/>
+          </a:prstGeom>
+          <a:noFill/>
+          <a:ln/>
+        </p:spPr>
+        <p:txBody>
+          <a:bodyPr wrap="square" lIns="0" tIns="0" rIns="0" bIns="0" rtlCol="0" anchor="ctr"/>
+          <a:lstStyle/>
+          <a:p>
+            <a:pPr indent="0" marL="0">
+              <a:buNone/>
+            </a:pPr>
+            <a:r>
+              <a:rPr lang="en-US" sz="1200" b="1" dirty="0">
+                <a:solidFill>
+                  <a:srgbClr val="6C5CE7"/>
+                </a:solidFill>
+                <a:latin typeface="Calibri" pitchFamily="34" charset="0"/>
+                <a:ea typeface="Calibri" pitchFamily="34" charset="-122"/>
+                <a:cs typeface="Calibri" pitchFamily="34" charset="-120"/>
+              </a:rPr>
+              <a:t>The pattern: frameworks are the knowledge layer. The runtime is swappable.</a:t>
             </a:r>
             <a:endParaRPr lang="en-US" sz="1200" dirty="0"/>
           </a:p>
@@ -8722,9 +10428,9 @@
 </p:sld>
 </file>
 
-<file path=ppt/slides/slide17.xml><?xml version="1.0" encoding="utf-8"?>
+<file path=ppt/slides/slide18.xml><?xml version="1.0" encoding="utf-8"?>
 <p:sld xmlns:a="http://schemas.openxmlformats.org/drawingml/2006/main" xmlns:r="http://schemas.openxmlformats.org/officeDocument/2006/relationships" xmlns:p="http://schemas.openxmlformats.org/presentationml/2006/main">
-  <p:cSld name="Slide 17">
+  <p:cSld name="Slide 18">
     <p:bg>
       <p:bgPr>
         <a:solidFill>
@@ -8754,50 +10460,6 @@
         </p:nvSpPr>
         <p:spPr>
           <a:xfrm>
-            <a:off x="6400800" y="-457200"/>
-            <a:ext cx="4114800" cy="4114800"/>
-          </a:xfrm>
-          <a:prstGeom prst="ellipse">
-            <a:avLst/>
-          </a:prstGeom>
-          <a:solidFill>
-            <a:srgbClr val="4ECDC4">
-              <a:alpha val="7000"/>
-            </a:srgbClr>
-          </a:solidFill>
-          <a:ln/>
-        </p:spPr>
-      </p:sp>
-      <p:sp>
-        <p:nvSpPr>
-          <p:cNvPr id="3" name="Shape 1"/>
-          <p:cNvSpPr/>
-          <p:nvPr/>
-        </p:nvSpPr>
-        <p:spPr>
-          <a:xfrm>
-            <a:off x="-1371600" y="3200400"/>
-            <a:ext cx="3657600" cy="3657600"/>
-          </a:xfrm>
-          <a:prstGeom prst="ellipse">
-            <a:avLst/>
-          </a:prstGeom>
-          <a:solidFill>
-            <a:srgbClr val="6C5CE7">
-              <a:alpha val="7000"/>
-            </a:srgbClr>
-          </a:solidFill>
-          <a:ln/>
-        </p:spPr>
-      </p:sp>
-      <p:sp>
-        <p:nvSpPr>
-          <p:cNvPr id="4" name="Shape 2"/>
-          <p:cNvSpPr/>
-          <p:nvPr/>
-        </p:nvSpPr>
-        <p:spPr>
-          <a:xfrm>
             <a:off x="0" y="0"/>
             <a:ext cx="9144000" cy="54864"/>
           </a:xfrm>
@@ -8805,44 +10467,20 @@
             <a:avLst/>
           </a:prstGeom>
           <a:solidFill>
-            <a:srgbClr val="4ECDC4"/>
-          </a:solidFill>
-          <a:ln/>
-        </p:spPr>
-      </p:sp>
-      <p:pic>
-        <p:nvPicPr>
-          <p:cNvPr id="5" name="Image 0" descr="preencoded.png">    </p:cNvPr>
-          <p:cNvPicPr>
-            <a:picLocks noChangeAspect="1"/>
-          </p:cNvPicPr>
-          <p:nvPr/>
-        </p:nvPicPr>
-        <p:blipFill>
-          <a:blip r:embed="rId1"/>
-          <a:stretch>
-            <a:fillRect/>
-          </a:stretch>
-        </p:blipFill>
-        <p:spPr>
-          <a:xfrm>
-            <a:off x="4114800" y="548640"/>
-            <a:ext cx="731520" cy="731520"/>
-          </a:xfrm>
-          <a:prstGeom prst="rect">
-            <a:avLst/>
-          </a:prstGeom>
-        </p:spPr>
-      </p:pic>
-      <p:sp>
-        <p:nvSpPr>
-          <p:cNvPr id="6" name="Text 3"/>
-          <p:cNvSpPr/>
-          <p:nvPr/>
-        </p:nvSpPr>
-        <p:spPr>
-          <a:xfrm>
-            <a:off x="457200" y="1371600"/>
+            <a:srgbClr val="FFD93D"/>
+          </a:solidFill>
+          <a:ln/>
+        </p:spPr>
+      </p:sp>
+      <p:sp>
+        <p:nvSpPr>
+          <p:cNvPr id="3" name="Text 1"/>
+          <p:cNvSpPr/>
+          <p:nvPr/>
+        </p:nvSpPr>
+        <p:spPr>
+          <a:xfrm>
+            <a:off x="457200" y="274320"/>
             <a:ext cx="8229600" cy="457200"/>
           </a:xfrm>
           <a:prstGeom prst="rect">
@@ -8855,19 +10493,19 @@
           <a:bodyPr wrap="square" lIns="0" tIns="0" rIns="0" bIns="0" rtlCol="0" anchor="ctr"/>
           <a:lstStyle/>
           <a:p>
-            <a:pPr algn="ctr" indent="0" marL="0">
+            <a:pPr indent="0" marL="0">
               <a:buNone/>
             </a:pPr>
             <a:r>
               <a:rPr lang="en-US" sz="1400" b="1" spc="600" kern="0" dirty="0">
                 <a:solidFill>
-                  <a:srgbClr val="4ECDC4"/>
-                </a:solidFill>
-                <a:latin typeface="Calibri" pitchFamily="34" charset="0"/>
-                <a:ea typeface="Calibri" pitchFamily="34" charset="-122"/>
-                <a:cs typeface="Calibri" pitchFamily="34" charset="-120"/>
-              </a:rPr>
-              <a:t>WHAT'S NEXT</a:t>
+                  <a:srgbClr val="FFD93D"/>
+                </a:solidFill>
+                <a:latin typeface="Calibri" pitchFamily="34" charset="0"/>
+                <a:ea typeface="Calibri" pitchFamily="34" charset="-122"/>
+                <a:cs typeface="Calibri" pitchFamily="34" charset="-120"/>
+              </a:rPr>
+              <a:t>WHERE THIS IS GOING</a:t>
             </a:r>
             <a:endParaRPr lang="en-US" sz="1400" dirty="0"/>
           </a:p>
@@ -8875,33 +10513,75 @@
       </p:sp>
       <p:sp>
         <p:nvSpPr>
-          <p:cNvPr id="7" name="Text 4"/>
-          <p:cNvSpPr/>
-          <p:nvPr/>
-        </p:nvSpPr>
-        <p:spPr>
-          <a:xfrm>
-            <a:off x="457200" y="1920240"/>
+          <p:cNvPr id="4" name="Shape 2"/>
+          <p:cNvSpPr/>
+          <p:nvPr/>
+        </p:nvSpPr>
+        <p:spPr>
+          <a:xfrm>
+            <a:off x="457200" y="914400"/>
             <a:ext cx="8229600" cy="914400"/>
           </a:xfrm>
           <a:prstGeom prst="rect">
             <a:avLst/>
           </a:prstGeom>
-          <a:noFill/>
-          <a:ln/>
-        </p:spPr>
-        <p:txBody>
-          <a:bodyPr wrap="square" lIns="0" tIns="0" rIns="0" bIns="0" rtlCol="0" anchor="ctr"/>
-          <a:lstStyle/>
-          <a:p>
-            <a:pPr algn="ctr" indent="0" marL="0">
+          <a:solidFill>
+            <a:srgbClr val="FFD93D">
+              <a:alpha val="10000"/>
+            </a:srgbClr>
+          </a:solidFill>
+          <a:ln/>
+        </p:spPr>
+      </p:sp>
+      <p:sp>
+        <p:nvSpPr>
+          <p:cNvPr id="5" name="Shape 3"/>
+          <p:cNvSpPr/>
+          <p:nvPr/>
+        </p:nvSpPr>
+        <p:spPr>
+          <a:xfrm>
+            <a:off x="457200" y="914400"/>
+            <a:ext cx="64008" cy="914400"/>
+          </a:xfrm>
+          <a:prstGeom prst="rect">
+            <a:avLst/>
+          </a:prstGeom>
+          <a:solidFill>
+            <a:srgbClr val="FFD93D"/>
+          </a:solidFill>
+          <a:ln/>
+        </p:spPr>
+      </p:sp>
+      <p:sp>
+        <p:nvSpPr>
+          <p:cNvPr id="6" name="Text 4"/>
+          <p:cNvSpPr/>
+          <p:nvPr/>
+        </p:nvSpPr>
+        <p:spPr>
+          <a:xfrm>
+            <a:off x="777240" y="914400"/>
+            <a:ext cx="7680960" cy="914400"/>
+          </a:xfrm>
+          <a:prstGeom prst="rect">
+            <a:avLst/>
+          </a:prstGeom>
+          <a:noFill/>
+          <a:ln/>
+        </p:spPr>
+        <p:txBody>
+          <a:bodyPr wrap="square" lIns="0" tIns="0" rIns="0" bIns="0" rtlCol="0" anchor="ctr"/>
+          <a:lstStyle/>
+          <a:p>
+            <a:pPr indent="0" marL="0">
               <a:lnSpc>
                 <a:spcPct val="130000"/>
               </a:lnSpc>
               <a:buNone/>
             </a:pPr>
             <a:r>
-              <a:rPr lang="en-US" sz="2600" b="1" dirty="0">
+              <a:rPr lang="en-US" sz="1600" dirty="0">
                 <a:solidFill>
                   <a:srgbClr val="FFFFFF"/>
                 </a:solidFill>
@@ -8909,19 +10589,610 @@
                 <a:ea typeface="Calibri" pitchFamily="34" charset="-122"/>
                 <a:cs typeface="Calibri" pitchFamily="34" charset="-120"/>
               </a:rPr>
-              <a:t>Build agents that actually understand</a:t>
-            </a:r>
-            <a:endParaRPr lang="en-US" sz="2600" dirty="0"/>
-          </a:p>
+              <a:t>Agent platforms are converging on persistent, stateful agents. The missing piece isn't better tooling. It's better understanding of the human in the loop.</a:t>
+            </a:r>
+            <a:endParaRPr lang="en-US" sz="1600" dirty="0"/>
+          </a:p>
+        </p:txBody>
+      </p:sp>
+      <p:sp>
+        <p:nvSpPr>
+          <p:cNvPr id="7" name="Shape 5"/>
+          <p:cNvSpPr/>
+          <p:nvPr/>
+        </p:nvSpPr>
+        <p:spPr>
+          <a:xfrm>
+            <a:off x="457200" y="2103120"/>
+            <a:ext cx="8229600" cy="731520"/>
+          </a:xfrm>
+          <a:prstGeom prst="rect">
+            <a:avLst/>
+          </a:prstGeom>
+          <a:solidFill>
+            <a:srgbClr val="16213E"/>
+          </a:solidFill>
+          <a:ln/>
+        </p:spPr>
+      </p:sp>
+      <p:sp>
+        <p:nvSpPr>
+          <p:cNvPr id="8" name="Shape 6"/>
+          <p:cNvSpPr/>
+          <p:nvPr/>
+        </p:nvSpPr>
+        <p:spPr>
+          <a:xfrm>
+            <a:off x="457200" y="2103120"/>
+            <a:ext cx="54864" cy="731520"/>
+          </a:xfrm>
+          <a:prstGeom prst="rect">
+            <a:avLst/>
+          </a:prstGeom>
+          <a:solidFill>
+            <a:srgbClr val="4ECDC4"/>
+          </a:solidFill>
+          <a:ln/>
+        </p:spPr>
+      </p:sp>
+      <p:sp>
+        <p:nvSpPr>
+          <p:cNvPr id="9" name="Shape 7"/>
+          <p:cNvSpPr/>
+          <p:nvPr/>
+        </p:nvSpPr>
+        <p:spPr>
+          <a:xfrm>
+            <a:off x="731520" y="2240280"/>
+            <a:ext cx="1097280" cy="274320"/>
+          </a:xfrm>
+          <a:prstGeom prst="rect">
+            <a:avLst/>
+          </a:prstGeom>
+          <a:solidFill>
+            <a:srgbClr val="4ECDC4">
+              <a:alpha val="20000"/>
+            </a:srgbClr>
+          </a:solidFill>
+          <a:ln/>
+        </p:spPr>
+      </p:sp>
+      <p:sp>
+        <p:nvSpPr>
+          <p:cNvPr id="10" name="Text 8"/>
+          <p:cNvSpPr/>
+          <p:nvPr/>
+        </p:nvSpPr>
+        <p:spPr>
+          <a:xfrm>
+            <a:off x="731520" y="2240280"/>
+            <a:ext cx="1097280" cy="274320"/>
+          </a:xfrm>
+          <a:prstGeom prst="rect">
+            <a:avLst/>
+          </a:prstGeom>
+          <a:noFill/>
+          <a:ln/>
+        </p:spPr>
+        <p:txBody>
+          <a:bodyPr wrap="square" lIns="0" tIns="0" rIns="0" bIns="0" rtlCol="0" anchor="ctr"/>
+          <a:lstStyle/>
           <a:p>
             <a:pPr algn="ctr" indent="0" marL="0">
-              <a:lnSpc>
-                <a:spcPct val="130000"/>
-              </a:lnSpc>
-              <a:buNone/>
-            </a:pPr>
-            <a:r>
-              <a:rPr lang="en-US" sz="2600" b="1" dirty="0">
+              <a:buNone/>
+            </a:pPr>
+            <a:r>
+              <a:rPr lang="en-US" sz="1100" b="1" spc="300" kern="0" dirty="0">
+                <a:solidFill>
+                  <a:srgbClr val="4ECDC4"/>
+                </a:solidFill>
+                <a:latin typeface="Calibri" pitchFamily="34" charset="0"/>
+                <a:ea typeface="Calibri" pitchFamily="34" charset="-122"/>
+                <a:cs typeface="Calibri" pitchFamily="34" charset="-120"/>
+              </a:rPr>
+              <a:t>NOW</a:t>
+            </a:r>
+            <a:endParaRPr lang="en-US" sz="1100" dirty="0"/>
+          </a:p>
+        </p:txBody>
+      </p:sp>
+      <p:sp>
+        <p:nvSpPr>
+          <p:cNvPr id="11" name="Text 9"/>
+          <p:cNvSpPr/>
+          <p:nvPr/>
+        </p:nvSpPr>
+        <p:spPr>
+          <a:xfrm>
+            <a:off x="2011680" y="2148840"/>
+            <a:ext cx="6400800" cy="640080"/>
+          </a:xfrm>
+          <a:prstGeom prst="rect">
+            <a:avLst/>
+          </a:prstGeom>
+          <a:noFill/>
+          <a:ln/>
+        </p:spPr>
+        <p:txBody>
+          <a:bodyPr wrap="square" lIns="0" tIns="0" rIns="0" bIns="0" rtlCol="0" anchor="ctr"/>
+          <a:lstStyle/>
+          <a:p>
+            <a:pPr indent="0" marL="0">
+              <a:buNone/>
+            </a:pPr>
+            <a:r>
+              <a:rPr lang="en-US" sz="1200" dirty="0">
+                <a:solidFill>
+                  <a:srgbClr val="C8C8D8"/>
+                </a:solidFill>
+                <a:latin typeface="Calibri" pitchFamily="34" charset="0"/>
+                <a:ea typeface="Calibri" pitchFamily="34" charset="-122"/>
+                <a:cs typeface="Calibri" pitchFamily="34" charset="-120"/>
+              </a:rPr>
+              <a:t>Claude Code integration, OpenClaw + Telegram, continuous learning protocol active</a:t>
+            </a:r>
+            <a:endParaRPr lang="en-US" sz="1200" dirty="0"/>
+          </a:p>
+        </p:txBody>
+      </p:sp>
+      <p:sp>
+        <p:nvSpPr>
+          <p:cNvPr id="12" name="Shape 10"/>
+          <p:cNvSpPr/>
+          <p:nvPr/>
+        </p:nvSpPr>
+        <p:spPr>
+          <a:xfrm>
+            <a:off x="457200" y="3017520"/>
+            <a:ext cx="8229600" cy="731520"/>
+          </a:xfrm>
+          <a:prstGeom prst="rect">
+            <a:avLst/>
+          </a:prstGeom>
+          <a:solidFill>
+            <a:srgbClr val="16213E"/>
+          </a:solidFill>
+          <a:ln/>
+        </p:spPr>
+      </p:sp>
+      <p:sp>
+        <p:nvSpPr>
+          <p:cNvPr id="13" name="Shape 11"/>
+          <p:cNvSpPr/>
+          <p:nvPr/>
+        </p:nvSpPr>
+        <p:spPr>
+          <a:xfrm>
+            <a:off x="457200" y="3017520"/>
+            <a:ext cx="54864" cy="731520"/>
+          </a:xfrm>
+          <a:prstGeom prst="rect">
+            <a:avLst/>
+          </a:prstGeom>
+          <a:solidFill>
+            <a:srgbClr val="6C5CE7"/>
+          </a:solidFill>
+          <a:ln/>
+        </p:spPr>
+      </p:sp>
+      <p:sp>
+        <p:nvSpPr>
+          <p:cNvPr id="14" name="Shape 12"/>
+          <p:cNvSpPr/>
+          <p:nvPr/>
+        </p:nvSpPr>
+        <p:spPr>
+          <a:xfrm>
+            <a:off x="731520" y="3154680"/>
+            <a:ext cx="1097280" cy="274320"/>
+          </a:xfrm>
+          <a:prstGeom prst="rect">
+            <a:avLst/>
+          </a:prstGeom>
+          <a:solidFill>
+            <a:srgbClr val="6C5CE7">
+              <a:alpha val="20000"/>
+            </a:srgbClr>
+          </a:solidFill>
+          <a:ln/>
+        </p:spPr>
+      </p:sp>
+      <p:sp>
+        <p:nvSpPr>
+          <p:cNvPr id="15" name="Text 13"/>
+          <p:cNvSpPr/>
+          <p:nvPr/>
+        </p:nvSpPr>
+        <p:spPr>
+          <a:xfrm>
+            <a:off x="731520" y="3154680"/>
+            <a:ext cx="1097280" cy="274320"/>
+          </a:xfrm>
+          <a:prstGeom prst="rect">
+            <a:avLst/>
+          </a:prstGeom>
+          <a:noFill/>
+          <a:ln/>
+        </p:spPr>
+        <p:txBody>
+          <a:bodyPr wrap="square" lIns="0" tIns="0" rIns="0" bIns="0" rtlCol="0" anchor="ctr"/>
+          <a:lstStyle/>
+          <a:p>
+            <a:pPr algn="ctr" indent="0" marL="0">
+              <a:buNone/>
+            </a:pPr>
+            <a:r>
+              <a:rPr lang="en-US" sz="1100" b="1" spc="300" kern="0" dirty="0">
+                <a:solidFill>
+                  <a:srgbClr val="6C5CE7"/>
+                </a:solidFill>
+                <a:latin typeface="Calibri" pitchFamily="34" charset="0"/>
+                <a:ea typeface="Calibri" pitchFamily="34" charset="-122"/>
+                <a:cs typeface="Calibri" pitchFamily="34" charset="-120"/>
+              </a:rPr>
+              <a:t>EMERGING</a:t>
+            </a:r>
+            <a:endParaRPr lang="en-US" sz="1100" dirty="0"/>
+          </a:p>
+        </p:txBody>
+      </p:sp>
+      <p:sp>
+        <p:nvSpPr>
+          <p:cNvPr id="16" name="Text 14"/>
+          <p:cNvSpPr/>
+          <p:nvPr/>
+        </p:nvSpPr>
+        <p:spPr>
+          <a:xfrm>
+            <a:off x="2011680" y="3063240"/>
+            <a:ext cx="6400800" cy="640080"/>
+          </a:xfrm>
+          <a:prstGeom prst="rect">
+            <a:avLst/>
+          </a:prstGeom>
+          <a:noFill/>
+          <a:ln/>
+        </p:spPr>
+        <p:txBody>
+          <a:bodyPr wrap="square" lIns="0" tIns="0" rIns="0" bIns="0" rtlCol="0" anchor="ctr"/>
+          <a:lstStyle/>
+          <a:p>
+            <a:pPr indent="0" marL="0">
+              <a:buNone/>
+            </a:pPr>
+            <a:r>
+              <a:rPr lang="en-US" sz="1200" dirty="0">
+                <a:solidFill>
+                  <a:srgbClr val="C8C8D8"/>
+                </a:solidFill>
+                <a:latin typeface="Calibri" pitchFamily="34" charset="0"/>
+                <a:ea typeface="Calibri" pitchFamily="34" charset="-122"/>
+                <a:cs typeface="Calibri" pitchFamily="34" charset="-120"/>
+              </a:rPr>
+              <a:t>Claude Managed Agents with persistent Mirror Palace state, long-running agent threads that remember your patterns across sessions</a:t>
+            </a:r>
+            <a:endParaRPr lang="en-US" sz="1200" dirty="0"/>
+          </a:p>
+        </p:txBody>
+      </p:sp>
+      <p:sp>
+        <p:nvSpPr>
+          <p:cNvPr id="17" name="Shape 15"/>
+          <p:cNvSpPr/>
+          <p:nvPr/>
+        </p:nvSpPr>
+        <p:spPr>
+          <a:xfrm>
+            <a:off x="457200" y="3931920"/>
+            <a:ext cx="8229600" cy="731520"/>
+          </a:xfrm>
+          <a:prstGeom prst="rect">
+            <a:avLst/>
+          </a:prstGeom>
+          <a:solidFill>
+            <a:srgbClr val="16213E"/>
+          </a:solidFill>
+          <a:ln/>
+        </p:spPr>
+      </p:sp>
+      <p:sp>
+        <p:nvSpPr>
+          <p:cNvPr id="18" name="Shape 16"/>
+          <p:cNvSpPr/>
+          <p:nvPr/>
+        </p:nvSpPr>
+        <p:spPr>
+          <a:xfrm>
+            <a:off x="457200" y="3931920"/>
+            <a:ext cx="54864" cy="731520"/>
+          </a:xfrm>
+          <a:prstGeom prst="rect">
+            <a:avLst/>
+          </a:prstGeom>
+          <a:solidFill>
+            <a:srgbClr val="FFD93D"/>
+          </a:solidFill>
+          <a:ln/>
+        </p:spPr>
+      </p:sp>
+      <p:sp>
+        <p:nvSpPr>
+          <p:cNvPr id="19" name="Shape 17"/>
+          <p:cNvSpPr/>
+          <p:nvPr/>
+        </p:nvSpPr>
+        <p:spPr>
+          <a:xfrm>
+            <a:off x="731520" y="4069080"/>
+            <a:ext cx="1097280" cy="274320"/>
+          </a:xfrm>
+          <a:prstGeom prst="rect">
+            <a:avLst/>
+          </a:prstGeom>
+          <a:solidFill>
+            <a:srgbClr val="FFD93D">
+              <a:alpha val="20000"/>
+            </a:srgbClr>
+          </a:solidFill>
+          <a:ln/>
+        </p:spPr>
+      </p:sp>
+      <p:sp>
+        <p:nvSpPr>
+          <p:cNvPr id="20" name="Text 18"/>
+          <p:cNvSpPr/>
+          <p:nvPr/>
+        </p:nvSpPr>
+        <p:spPr>
+          <a:xfrm>
+            <a:off x="731520" y="4069080"/>
+            <a:ext cx="1097280" cy="274320"/>
+          </a:xfrm>
+          <a:prstGeom prst="rect">
+            <a:avLst/>
+          </a:prstGeom>
+          <a:noFill/>
+          <a:ln/>
+        </p:spPr>
+        <p:txBody>
+          <a:bodyPr wrap="square" lIns="0" tIns="0" rIns="0" bIns="0" rtlCol="0" anchor="ctr"/>
+          <a:lstStyle/>
+          <a:p>
+            <a:pPr algn="ctr" indent="0" marL="0">
+              <a:buNone/>
+            </a:pPr>
+            <a:r>
+              <a:rPr lang="en-US" sz="1100" b="1" spc="300" kern="0" dirty="0">
+                <a:solidFill>
+                  <a:srgbClr val="FFD93D"/>
+                </a:solidFill>
+                <a:latin typeface="Calibri" pitchFamily="34" charset="0"/>
+                <a:ea typeface="Calibri" pitchFamily="34" charset="-122"/>
+                <a:cs typeface="Calibri" pitchFamily="34" charset="-120"/>
+              </a:rPr>
+              <a:t>NEXT</a:t>
+            </a:r>
+            <a:endParaRPr lang="en-US" sz="1100" dirty="0"/>
+          </a:p>
+        </p:txBody>
+      </p:sp>
+      <p:sp>
+        <p:nvSpPr>
+          <p:cNvPr id="21" name="Text 19"/>
+          <p:cNvSpPr/>
+          <p:nvPr/>
+        </p:nvSpPr>
+        <p:spPr>
+          <a:xfrm>
+            <a:off x="2011680" y="3977640"/>
+            <a:ext cx="6400800" cy="640080"/>
+          </a:xfrm>
+          <a:prstGeom prst="rect">
+            <a:avLst/>
+          </a:prstGeom>
+          <a:noFill/>
+          <a:ln/>
+        </p:spPr>
+        <p:txBody>
+          <a:bodyPr wrap="square" lIns="0" tIns="0" rIns="0" bIns="0" rtlCol="0" anchor="ctr"/>
+          <a:lstStyle/>
+          <a:p>
+            <a:pPr indent="0" marL="0">
+              <a:buNone/>
+            </a:pPr>
+            <a:r>
+              <a:rPr lang="en-US" sz="1200" dirty="0">
+                <a:solidFill>
+                  <a:srgbClr val="C8C8D8"/>
+                </a:solidFill>
+                <a:latin typeface="Calibri" pitchFamily="34" charset="0"/>
+                <a:ea typeface="Calibri" pitchFamily="34" charset="-122"/>
+                <a:cs typeface="Calibri" pitchFamily="34" charset="-120"/>
+              </a:rPr>
+              <a:t>Any agent runtime that supports structured memory can load Mirror Palace. Your self-knowledge travels with you across platforms.</a:t>
+            </a:r>
+            <a:endParaRPr lang="en-US" sz="1200" dirty="0"/>
+          </a:p>
+        </p:txBody>
+      </p:sp>
+      <p:sp>
+        <p:nvSpPr>
+          <p:cNvPr id="22" name="Text 20"/>
+          <p:cNvSpPr/>
+          <p:nvPr/>
+        </p:nvSpPr>
+        <p:spPr>
+          <a:xfrm>
+            <a:off x="457200" y="4572000"/>
+            <a:ext cx="8229600" cy="365760"/>
+          </a:xfrm>
+          <a:prstGeom prst="rect">
+            <a:avLst/>
+          </a:prstGeom>
+          <a:noFill/>
+          <a:ln/>
+        </p:spPr>
+        <p:txBody>
+          <a:bodyPr wrap="square" lIns="0" tIns="0" rIns="0" bIns="0" rtlCol="0" anchor="ctr"/>
+          <a:lstStyle/>
+          <a:p>
+            <a:pPr algn="ctr" indent="0" marL="0">
+              <a:buNone/>
+            </a:pPr>
+            <a:r>
+              <a:rPr lang="en-US" sz="1400" i="1" dirty="0">
+                <a:solidFill>
+                  <a:srgbClr val="FFD93D"/>
+                </a:solidFill>
+                <a:latin typeface="Calibri" pitchFamily="34" charset="0"/>
+                <a:ea typeface="Calibri" pitchFamily="34" charset="-122"/>
+                <a:cs typeface="Calibri" pitchFamily="34" charset="-120"/>
+              </a:rPr>
+              <a:t>Whoever owns the self-knowledge layer wins the agent UX war.</a:t>
+            </a:r>
+            <a:endParaRPr lang="en-US" sz="1400" dirty="0"/>
+          </a:p>
+        </p:txBody>
+      </p:sp>
+    </p:spTree>
+  </p:cSld>
+  <p:clrMapOvr>
+    <a:masterClrMapping/>
+  </p:clrMapOvr>
+</p:sld>
+</file>
+
+<file path=ppt/slides/slide19.xml><?xml version="1.0" encoding="utf-8"?>
+<p:sld xmlns:a="http://schemas.openxmlformats.org/drawingml/2006/main" xmlns:r="http://schemas.openxmlformats.org/officeDocument/2006/relationships" xmlns:p="http://schemas.openxmlformats.org/presentationml/2006/main">
+  <p:cSld name="Slide 19">
+    <p:bg>
+      <p:bgPr>
+        <a:solidFill>
+          <a:srgbClr val="1A1A2E"/>
+        </a:solidFill>
+      </p:bgPr>
+    </p:bg>
+    <p:spTree>
+      <p:nvGrpSpPr>
+        <p:cNvPr id="1" name=""/>
+        <p:cNvGrpSpPr/>
+        <p:nvPr/>
+      </p:nvGrpSpPr>
+      <p:grpSpPr>
+        <a:xfrm>
+          <a:off x="0" y="0"/>
+          <a:ext cx="0" cy="0"/>
+          <a:chOff x="0" y="0"/>
+          <a:chExt cx="0" cy="0"/>
+        </a:xfrm>
+      </p:grpSpPr>
+      <p:sp>
+        <p:nvSpPr>
+          <p:cNvPr id="2" name="Shape 0"/>
+          <p:cNvSpPr/>
+          <p:nvPr/>
+        </p:nvSpPr>
+        <p:spPr>
+          <a:xfrm>
+            <a:off x="0" y="0"/>
+            <a:ext cx="9144000" cy="54864"/>
+          </a:xfrm>
+          <a:prstGeom prst="rect">
+            <a:avLst/>
+          </a:prstGeom>
+          <a:solidFill>
+            <a:srgbClr val="FFD93D"/>
+          </a:solidFill>
+          <a:ln/>
+        </p:spPr>
+      </p:sp>
+      <p:sp>
+        <p:nvSpPr>
+          <p:cNvPr id="3" name="Text 1"/>
+          <p:cNvSpPr/>
+          <p:nvPr/>
+        </p:nvSpPr>
+        <p:spPr>
+          <a:xfrm>
+            <a:off x="457200" y="274320"/>
+            <a:ext cx="8229600" cy="457200"/>
+          </a:xfrm>
+          <a:prstGeom prst="rect">
+            <a:avLst/>
+          </a:prstGeom>
+          <a:noFill/>
+          <a:ln/>
+        </p:spPr>
+        <p:txBody>
+          <a:bodyPr wrap="square" lIns="0" tIns="0" rIns="0" bIns="0" rtlCol="0" anchor="ctr"/>
+          <a:lstStyle/>
+          <a:p>
+            <a:pPr indent="0" marL="0">
+              <a:buNone/>
+            </a:pPr>
+            <a:r>
+              <a:rPr lang="en-US" sz="1400" b="1" spc="600" kern="0" dirty="0">
+                <a:solidFill>
+                  <a:srgbClr val="FFD93D"/>
+                </a:solidFill>
+                <a:latin typeface="Calibri" pitchFamily="34" charset="0"/>
+                <a:ea typeface="Calibri" pitchFamily="34" charset="-122"/>
+                <a:cs typeface="Calibri" pitchFamily="34" charset="-120"/>
+              </a:rPr>
+              <a:t>THE DEEPER POINT</a:t>
+            </a:r>
+            <a:endParaRPr lang="en-US" sz="1400" dirty="0"/>
+          </a:p>
+        </p:txBody>
+      </p:sp>
+      <p:sp>
+        <p:nvSpPr>
+          <p:cNvPr id="4" name="Shape 2"/>
+          <p:cNvSpPr/>
+          <p:nvPr/>
+        </p:nvSpPr>
+        <p:spPr>
+          <a:xfrm>
+            <a:off x="457200" y="822960"/>
+            <a:ext cx="8229600" cy="731520"/>
+          </a:xfrm>
+          <a:prstGeom prst="rect">
+            <a:avLst/>
+          </a:prstGeom>
+          <a:solidFill>
+            <a:srgbClr val="FFD93D">
+              <a:alpha val="10000"/>
+            </a:srgbClr>
+          </a:solidFill>
+          <a:ln/>
+        </p:spPr>
+      </p:sp>
+      <p:sp>
+        <p:nvSpPr>
+          <p:cNvPr id="5" name="Text 3"/>
+          <p:cNvSpPr/>
+          <p:nvPr/>
+        </p:nvSpPr>
+        <p:spPr>
+          <a:xfrm>
+            <a:off x="640080" y="822960"/>
+            <a:ext cx="7863840" cy="731520"/>
+          </a:xfrm>
+          <a:prstGeom prst="rect">
+            <a:avLst/>
+          </a:prstGeom>
+          <a:noFill/>
+          <a:ln/>
+        </p:spPr>
+        <p:txBody>
+          <a:bodyPr wrap="square" lIns="0" tIns="0" rIns="0" bIns="0" rtlCol="0" anchor="ctr"/>
+          <a:lstStyle/>
+          <a:p>
+            <a:pPr indent="0" marL="0">
+              <a:buNone/>
+            </a:pPr>
+            <a:r>
+              <a:rPr lang="en-US" sz="2000" b="1" dirty="0">
                 <a:solidFill>
                   <a:srgbClr val="FFFFFF"/>
                 </a:solidFill>
@@ -8929,99 +11200,78 @@
                 <a:ea typeface="Calibri" pitchFamily="34" charset="-122"/>
                 <a:cs typeface="Calibri" pitchFamily="34" charset="-120"/>
               </a:rPr>
-              <a:t>the humans they serve.</a:t>
-            </a:r>
-            <a:endParaRPr lang="en-US" sz="2600" dirty="0"/>
-          </a:p>
-        </p:txBody>
-      </p:sp>
-      <p:sp>
-        <p:nvSpPr>
-          <p:cNvPr id="8" name="Shape 5"/>
-          <p:cNvSpPr/>
-          <p:nvPr/>
-        </p:nvSpPr>
-        <p:spPr>
-          <a:xfrm>
-            <a:off x="2743200" y="3108960"/>
-            <a:ext cx="3657600" cy="594360"/>
-          </a:xfrm>
-          <a:prstGeom prst="rect">
-            <a:avLst/>
-          </a:prstGeom>
-          <a:solidFill>
-            <a:srgbClr val="4ECDC4">
-              <a:alpha val="15000"/>
-            </a:srgbClr>
-          </a:solidFill>
-          <a:ln/>
-        </p:spPr>
-      </p:sp>
-      <p:sp>
-        <p:nvSpPr>
-          <p:cNvPr id="9" name="Text 6"/>
-          <p:cNvSpPr/>
-          <p:nvPr/>
-        </p:nvSpPr>
-        <p:spPr>
-          <a:xfrm>
-            <a:off x="2743200" y="3108960"/>
-            <a:ext cx="3657600" cy="594360"/>
-          </a:xfrm>
-          <a:prstGeom prst="rect">
-            <a:avLst/>
-          </a:prstGeom>
-          <a:noFill/>
-          <a:ln/>
-        </p:spPr>
-        <p:txBody>
-          <a:bodyPr wrap="square" lIns="0" tIns="0" rIns="0" bIns="0" rtlCol="0" anchor="ctr"/>
-          <a:lstStyle/>
-          <a:p>
-            <a:pPr algn="ctr" indent="0" marL="0">
-              <a:buNone/>
-            </a:pPr>
-            <a:r>
-              <a:rPr lang="en-US" sz="1400" b="1" dirty="0">
-                <a:solidFill>
-                  <a:srgbClr val="4ECDC4"/>
-                </a:solidFill>
-                <a:latin typeface="Calibri" pitchFamily="34" charset="0"/>
-                <a:ea typeface="Calibri" pitchFamily="34" charset="-122"/>
-                <a:cs typeface="Calibri" pitchFamily="34" charset="-120"/>
-              </a:rPr>
-              <a:t>Open Source  ·  MIT Licensed  ·  GitHub</a:t>
-            </a:r>
-            <a:endParaRPr lang="en-US" sz="1400" dirty="0"/>
-          </a:p>
-        </p:txBody>
-      </p:sp>
-      <p:sp>
-        <p:nvSpPr>
-          <p:cNvPr id="10" name="Text 7"/>
-          <p:cNvSpPr/>
-          <p:nvPr/>
-        </p:nvSpPr>
-        <p:spPr>
-          <a:xfrm>
-            <a:off x="457200" y="3931920"/>
-            <a:ext cx="8229600" cy="457200"/>
-          </a:xfrm>
-          <a:prstGeom prst="rect">
-            <a:avLst/>
-          </a:prstGeom>
-          <a:noFill/>
-          <a:ln/>
-        </p:spPr>
-        <p:txBody>
-          <a:bodyPr wrap="square" lIns="0" tIns="0" rIns="0" bIns="0" rtlCol="0" anchor="ctr"/>
-          <a:lstStyle/>
-          <a:p>
-            <a:pPr algn="ctr" indent="0" marL="0">
-              <a:buNone/>
-            </a:pPr>
-            <a:r>
-              <a:rPr lang="en-US" sz="1400" dirty="0">
+              <a:t>It knows when "I'll start Monday" means "I'm avoiding this."</a:t>
+            </a:r>
+            <a:endParaRPr lang="en-US" sz="2000" dirty="0"/>
+          </a:p>
+        </p:txBody>
+      </p:sp>
+      <p:sp>
+        <p:nvSpPr>
+          <p:cNvPr id="6" name="Shape 4"/>
+          <p:cNvSpPr/>
+          <p:nvPr/>
+        </p:nvSpPr>
+        <p:spPr>
+          <a:xfrm>
+            <a:off x="457200" y="1737360"/>
+            <a:ext cx="8229600" cy="502920"/>
+          </a:xfrm>
+          <a:prstGeom prst="rect">
+            <a:avLst/>
+          </a:prstGeom>
+          <a:solidFill>
+            <a:srgbClr val="16213E"/>
+          </a:solidFill>
+          <a:ln/>
+        </p:spPr>
+      </p:sp>
+      <p:sp>
+        <p:nvSpPr>
+          <p:cNvPr id="7" name="Shape 5"/>
+          <p:cNvSpPr/>
+          <p:nvPr/>
+        </p:nvSpPr>
+        <p:spPr>
+          <a:xfrm>
+            <a:off x="457200" y="1737360"/>
+            <a:ext cx="54864" cy="502920"/>
+          </a:xfrm>
+          <a:prstGeom prst="rect">
+            <a:avLst/>
+          </a:prstGeom>
+          <a:solidFill>
+            <a:srgbClr val="4ECDC4"/>
+          </a:solidFill>
+          <a:ln/>
+        </p:spPr>
+      </p:sp>
+      <p:sp>
+        <p:nvSpPr>
+          <p:cNvPr id="8" name="Text 6"/>
+          <p:cNvSpPr/>
+          <p:nvPr/>
+        </p:nvSpPr>
+        <p:spPr>
+          <a:xfrm>
+            <a:off x="731520" y="1737360"/>
+            <a:ext cx="7772400" cy="502920"/>
+          </a:xfrm>
+          <a:prstGeom prst="rect">
+            <a:avLst/>
+          </a:prstGeom>
+          <a:noFill/>
+          <a:ln/>
+        </p:spPr>
+        <p:txBody>
+          <a:bodyPr wrap="square" lIns="0" tIns="0" rIns="0" bIns="0" rtlCol="0" anchor="ctr"/>
+          <a:lstStyle/>
+          <a:p>
+            <a:pPr indent="0" marL="0">
+              <a:buNone/>
+            </a:pPr>
+            <a:r>
+              <a:rPr lang="en-US" sz="1200" dirty="0">
                 <a:solidFill>
                   <a:srgbClr val="C8C8D8"/>
                 </a:solidFill>
@@ -9029,22 +11279,42 @@
                 <a:ea typeface="Calibri" pitchFamily="34" charset="-122"/>
                 <a:cs typeface="Calibri" pitchFamily="34" charset="-120"/>
               </a:rPr>
-              <a:t>github.com/TaylorONeal/mirror-palace</a:t>
-            </a:r>
-            <a:endParaRPr lang="en-US" sz="1400" dirty="0"/>
-          </a:p>
-        </p:txBody>
-      </p:sp>
-      <p:sp>
-        <p:nvSpPr>
-          <p:cNvPr id="11" name="Shape 8"/>
-          <p:cNvSpPr/>
-          <p:nvPr/>
-        </p:nvSpPr>
-        <p:spPr>
-          <a:xfrm>
-            <a:off x="0" y="5088636"/>
-            <a:ext cx="9144000" cy="54864"/>
+              <a:t>When your calendar fills up, it's not ambition. It's over-commitment.</a:t>
+            </a:r>
+            <a:endParaRPr lang="en-US" sz="1200" dirty="0"/>
+          </a:p>
+        </p:txBody>
+      </p:sp>
+      <p:sp>
+        <p:nvSpPr>
+          <p:cNvPr id="9" name="Shape 7"/>
+          <p:cNvSpPr/>
+          <p:nvPr/>
+        </p:nvSpPr>
+        <p:spPr>
+          <a:xfrm>
+            <a:off x="457200" y="2359152"/>
+            <a:ext cx="8229600" cy="502920"/>
+          </a:xfrm>
+          <a:prstGeom prst="rect">
+            <a:avLst/>
+          </a:prstGeom>
+          <a:solidFill>
+            <a:srgbClr val="16213E"/>
+          </a:solidFill>
+          <a:ln/>
+        </p:spPr>
+      </p:sp>
+      <p:sp>
+        <p:nvSpPr>
+          <p:cNvPr id="10" name="Shape 8"/>
+          <p:cNvSpPr/>
+          <p:nvPr/>
+        </p:nvSpPr>
+        <p:spPr>
+          <a:xfrm>
+            <a:off x="457200" y="2359152"/>
+            <a:ext cx="54864" cy="502920"/>
           </a:xfrm>
           <a:prstGeom prst="rect">
             <a:avLst/>
@@ -9054,6 +11324,282 @@
           </a:solidFill>
           <a:ln/>
         </p:spPr>
+      </p:sp>
+      <p:sp>
+        <p:nvSpPr>
+          <p:cNvPr id="11" name="Text 9"/>
+          <p:cNvSpPr/>
+          <p:nvPr/>
+        </p:nvSpPr>
+        <p:spPr>
+          <a:xfrm>
+            <a:off x="731520" y="2359152"/>
+            <a:ext cx="7772400" cy="502920"/>
+          </a:xfrm>
+          <a:prstGeom prst="rect">
+            <a:avLst/>
+          </a:prstGeom>
+          <a:noFill/>
+          <a:ln/>
+        </p:spPr>
+        <p:txBody>
+          <a:bodyPr wrap="square" lIns="0" tIns="0" rIns="0" bIns="0" rtlCol="0" anchor="ctr"/>
+          <a:lstStyle/>
+          <a:p>
+            <a:pPr indent="0" marL="0">
+              <a:buNone/>
+            </a:pPr>
+            <a:r>
+              <a:rPr lang="en-US" sz="1200" dirty="0">
+                <a:solidFill>
+                  <a:srgbClr val="C8C8D8"/>
+                </a:solidFill>
+                <a:latin typeface="Calibri" pitchFamily="34" charset="0"/>
+                <a:ea typeface="Calibri" pitchFamily="34" charset="-122"/>
+                <a:cs typeface="Calibri" pitchFamily="34" charset="-120"/>
+              </a:rPr>
+              <a:t>When you go quiet in relationships, it's a pattern, not a preference.</a:t>
+            </a:r>
+            <a:endParaRPr lang="en-US" sz="1200" dirty="0"/>
+          </a:p>
+        </p:txBody>
+      </p:sp>
+      <p:sp>
+        <p:nvSpPr>
+          <p:cNvPr id="12" name="Shape 10"/>
+          <p:cNvSpPr/>
+          <p:nvPr/>
+        </p:nvSpPr>
+        <p:spPr>
+          <a:xfrm>
+            <a:off x="457200" y="2980944"/>
+            <a:ext cx="8229600" cy="502920"/>
+          </a:xfrm>
+          <a:prstGeom prst="rect">
+            <a:avLst/>
+          </a:prstGeom>
+          <a:solidFill>
+            <a:srgbClr val="16213E"/>
+          </a:solidFill>
+          <a:ln/>
+        </p:spPr>
+      </p:sp>
+      <p:sp>
+        <p:nvSpPr>
+          <p:cNvPr id="13" name="Shape 11"/>
+          <p:cNvSpPr/>
+          <p:nvPr/>
+        </p:nvSpPr>
+        <p:spPr>
+          <a:xfrm>
+            <a:off x="457200" y="2980944"/>
+            <a:ext cx="54864" cy="502920"/>
+          </a:xfrm>
+          <a:prstGeom prst="rect">
+            <a:avLst/>
+          </a:prstGeom>
+          <a:solidFill>
+            <a:srgbClr val="6C5CE7"/>
+          </a:solidFill>
+          <a:ln/>
+        </p:spPr>
+      </p:sp>
+      <p:sp>
+        <p:nvSpPr>
+          <p:cNvPr id="14" name="Text 12"/>
+          <p:cNvSpPr/>
+          <p:nvPr/>
+        </p:nvSpPr>
+        <p:spPr>
+          <a:xfrm>
+            <a:off x="731520" y="2980944"/>
+            <a:ext cx="7772400" cy="502920"/>
+          </a:xfrm>
+          <a:prstGeom prst="rect">
+            <a:avLst/>
+          </a:prstGeom>
+          <a:noFill/>
+          <a:ln/>
+        </p:spPr>
+        <p:txBody>
+          <a:bodyPr wrap="square" lIns="0" tIns="0" rIns="0" bIns="0" rtlCol="0" anchor="ctr"/>
+          <a:lstStyle/>
+          <a:p>
+            <a:pPr indent="0" marL="0">
+              <a:buNone/>
+            </a:pPr>
+            <a:r>
+              <a:rPr lang="en-US" sz="1200" dirty="0">
+                <a:solidFill>
+                  <a:srgbClr val="C8C8D8"/>
+                </a:solidFill>
+                <a:latin typeface="Calibri" pitchFamily="34" charset="0"/>
+                <a:ea typeface="Calibri" pitchFamily="34" charset="-122"/>
+                <a:cs typeface="Calibri" pitchFamily="34" charset="-120"/>
+              </a:rPr>
+              <a:t>When you compare yourself to others, your self-worth is untethered from your actual work.</a:t>
+            </a:r>
+            <a:endParaRPr lang="en-US" sz="1200" dirty="0"/>
+          </a:p>
+        </p:txBody>
+      </p:sp>
+      <p:sp>
+        <p:nvSpPr>
+          <p:cNvPr id="15" name="Shape 13"/>
+          <p:cNvSpPr/>
+          <p:nvPr/>
+        </p:nvSpPr>
+        <p:spPr>
+          <a:xfrm>
+            <a:off x="457200" y="3602736"/>
+            <a:ext cx="8229600" cy="502920"/>
+          </a:xfrm>
+          <a:prstGeom prst="rect">
+            <a:avLst/>
+          </a:prstGeom>
+          <a:solidFill>
+            <a:srgbClr val="16213E"/>
+          </a:solidFill>
+          <a:ln/>
+        </p:spPr>
+      </p:sp>
+      <p:sp>
+        <p:nvSpPr>
+          <p:cNvPr id="16" name="Shape 14"/>
+          <p:cNvSpPr/>
+          <p:nvPr/>
+        </p:nvSpPr>
+        <p:spPr>
+          <a:xfrm>
+            <a:off x="457200" y="3602736"/>
+            <a:ext cx="54864" cy="502920"/>
+          </a:xfrm>
+          <a:prstGeom prst="rect">
+            <a:avLst/>
+          </a:prstGeom>
+          <a:solidFill>
+            <a:srgbClr val="FFD93D"/>
+          </a:solidFill>
+          <a:ln/>
+        </p:spPr>
+      </p:sp>
+      <p:sp>
+        <p:nvSpPr>
+          <p:cNvPr id="17" name="Text 15"/>
+          <p:cNvSpPr/>
+          <p:nvPr/>
+        </p:nvSpPr>
+        <p:spPr>
+          <a:xfrm>
+            <a:off x="731520" y="3602736"/>
+            <a:ext cx="7772400" cy="502920"/>
+          </a:xfrm>
+          <a:prstGeom prst="rect">
+            <a:avLst/>
+          </a:prstGeom>
+          <a:noFill/>
+          <a:ln/>
+        </p:spPr>
+        <p:txBody>
+          <a:bodyPr wrap="square" lIns="0" tIns="0" rIns="0" bIns="0" rtlCol="0" anchor="ctr"/>
+          <a:lstStyle/>
+          <a:p>
+            <a:pPr indent="0" marL="0">
+              <a:buNone/>
+            </a:pPr>
+            <a:r>
+              <a:rPr lang="en-US" sz="1200" dirty="0">
+                <a:solidFill>
+                  <a:srgbClr val="C8C8D8"/>
+                </a:solidFill>
+                <a:latin typeface="Calibri" pitchFamily="34" charset="0"/>
+                <a:ea typeface="Calibri" pitchFamily="34" charset="-122"/>
+                <a:cs typeface="Calibri" pitchFamily="34" charset="-120"/>
+              </a:rPr>
+              <a:t>When you start something new with intense energy, the follow-through is the real test.</a:t>
+            </a:r>
+            <a:endParaRPr lang="en-US" sz="1200" dirty="0"/>
+          </a:p>
+        </p:txBody>
+      </p:sp>
+      <p:sp>
+        <p:nvSpPr>
+          <p:cNvPr id="18" name="Shape 16"/>
+          <p:cNvSpPr/>
+          <p:nvPr/>
+        </p:nvSpPr>
+        <p:spPr>
+          <a:xfrm>
+            <a:off x="457200" y="4224528"/>
+            <a:ext cx="8229600" cy="502920"/>
+          </a:xfrm>
+          <a:prstGeom prst="rect">
+            <a:avLst/>
+          </a:prstGeom>
+          <a:solidFill>
+            <a:srgbClr val="16213E"/>
+          </a:solidFill>
+          <a:ln/>
+        </p:spPr>
+      </p:sp>
+      <p:sp>
+        <p:nvSpPr>
+          <p:cNvPr id="19" name="Shape 17"/>
+          <p:cNvSpPr/>
+          <p:nvPr/>
+        </p:nvSpPr>
+        <p:spPr>
+          <a:xfrm>
+            <a:off x="457200" y="4224528"/>
+            <a:ext cx="54864" cy="502920"/>
+          </a:xfrm>
+          <a:prstGeom prst="rect">
+            <a:avLst/>
+          </a:prstGeom>
+          <a:solidFill>
+            <a:srgbClr val="4ECDC4"/>
+          </a:solidFill>
+          <a:ln/>
+        </p:spPr>
+      </p:sp>
+      <p:sp>
+        <p:nvSpPr>
+          <p:cNvPr id="20" name="Text 18"/>
+          <p:cNvSpPr/>
+          <p:nvPr/>
+        </p:nvSpPr>
+        <p:spPr>
+          <a:xfrm>
+            <a:off x="731520" y="4224528"/>
+            <a:ext cx="7772400" cy="502920"/>
+          </a:xfrm>
+          <a:prstGeom prst="rect">
+            <a:avLst/>
+          </a:prstGeom>
+          <a:noFill/>
+          <a:ln/>
+        </p:spPr>
+        <p:txBody>
+          <a:bodyPr wrap="square" lIns="0" tIns="0" rIns="0" bIns="0" rtlCol="0" anchor="ctr"/>
+          <a:lstStyle/>
+          <a:p>
+            <a:pPr indent="0" marL="0">
+              <a:buNone/>
+            </a:pPr>
+            <a:r>
+              <a:rPr lang="en-US" sz="1200" dirty="0">
+                <a:solidFill>
+                  <a:srgbClr val="C8C8D8"/>
+                </a:solidFill>
+                <a:latin typeface="Calibri" pitchFamily="34" charset="0"/>
+                <a:ea typeface="Calibri" pitchFamily="34" charset="-122"/>
+                <a:cs typeface="Calibri" pitchFamily="34" charset="-120"/>
+              </a:rPr>
+              <a:t>That knowledge, structured and continuously updated, turns an assistant into a thinking partner.</a:t>
+            </a:r>
+            <a:endParaRPr lang="en-US" sz="1200" dirty="0"/>
+          </a:p>
+        </p:txBody>
       </p:sp>
     </p:spTree>
   </p:cSld>
@@ -9650,6 +12196,347 @@
           </a:prstGeom>
         </p:spPr>
       </p:pic>
+    </p:spTree>
+  </p:cSld>
+  <p:clrMapOvr>
+    <a:masterClrMapping/>
+  </p:clrMapOvr>
+</p:sld>
+</file>
+
+<file path=ppt/slides/slide20.xml><?xml version="1.0" encoding="utf-8"?>
+<p:sld xmlns:a="http://schemas.openxmlformats.org/drawingml/2006/main" xmlns:r="http://schemas.openxmlformats.org/officeDocument/2006/relationships" xmlns:p="http://schemas.openxmlformats.org/presentationml/2006/main">
+  <p:cSld name="Slide 20">
+    <p:bg>
+      <p:bgPr>
+        <a:solidFill>
+          <a:srgbClr val="0F0F23"/>
+        </a:solidFill>
+      </p:bgPr>
+    </p:bg>
+    <p:spTree>
+      <p:nvGrpSpPr>
+        <p:cNvPr id="1" name=""/>
+        <p:cNvGrpSpPr/>
+        <p:nvPr/>
+      </p:nvGrpSpPr>
+      <p:grpSpPr>
+        <a:xfrm>
+          <a:off x="0" y="0"/>
+          <a:ext cx="0" cy="0"/>
+          <a:chOff x="0" y="0"/>
+          <a:chExt cx="0" cy="0"/>
+        </a:xfrm>
+      </p:grpSpPr>
+      <p:sp>
+        <p:nvSpPr>
+          <p:cNvPr id="2" name="Shape 0"/>
+          <p:cNvSpPr/>
+          <p:nvPr/>
+        </p:nvSpPr>
+        <p:spPr>
+          <a:xfrm>
+            <a:off x="6400800" y="-457200"/>
+            <a:ext cx="4114800" cy="4114800"/>
+          </a:xfrm>
+          <a:prstGeom prst="ellipse">
+            <a:avLst/>
+          </a:prstGeom>
+          <a:solidFill>
+            <a:srgbClr val="4ECDC4">
+              <a:alpha val="7000"/>
+            </a:srgbClr>
+          </a:solidFill>
+          <a:ln/>
+        </p:spPr>
+      </p:sp>
+      <p:sp>
+        <p:nvSpPr>
+          <p:cNvPr id="3" name="Shape 1"/>
+          <p:cNvSpPr/>
+          <p:nvPr/>
+        </p:nvSpPr>
+        <p:spPr>
+          <a:xfrm>
+            <a:off x="-1371600" y="3200400"/>
+            <a:ext cx="3657600" cy="3657600"/>
+          </a:xfrm>
+          <a:prstGeom prst="ellipse">
+            <a:avLst/>
+          </a:prstGeom>
+          <a:solidFill>
+            <a:srgbClr val="6C5CE7">
+              <a:alpha val="7000"/>
+            </a:srgbClr>
+          </a:solidFill>
+          <a:ln/>
+        </p:spPr>
+      </p:sp>
+      <p:sp>
+        <p:nvSpPr>
+          <p:cNvPr id="4" name="Shape 2"/>
+          <p:cNvSpPr/>
+          <p:nvPr/>
+        </p:nvSpPr>
+        <p:spPr>
+          <a:xfrm>
+            <a:off x="0" y="0"/>
+            <a:ext cx="9144000" cy="54864"/>
+          </a:xfrm>
+          <a:prstGeom prst="rect">
+            <a:avLst/>
+          </a:prstGeom>
+          <a:solidFill>
+            <a:srgbClr val="4ECDC4"/>
+          </a:solidFill>
+          <a:ln/>
+        </p:spPr>
+      </p:sp>
+      <p:pic>
+        <p:nvPicPr>
+          <p:cNvPr id="5" name="Image 0" descr="preencoded.png">    </p:cNvPr>
+          <p:cNvPicPr>
+            <a:picLocks noChangeAspect="1"/>
+          </p:cNvPicPr>
+          <p:nvPr/>
+        </p:nvPicPr>
+        <p:blipFill>
+          <a:blip r:embed="rId1"/>
+          <a:stretch>
+            <a:fillRect/>
+          </a:stretch>
+        </p:blipFill>
+        <p:spPr>
+          <a:xfrm>
+            <a:off x="4114800" y="548640"/>
+            <a:ext cx="731520" cy="731520"/>
+          </a:xfrm>
+          <a:prstGeom prst="rect">
+            <a:avLst/>
+          </a:prstGeom>
+        </p:spPr>
+      </p:pic>
+      <p:sp>
+        <p:nvSpPr>
+          <p:cNvPr id="6" name="Text 3"/>
+          <p:cNvSpPr/>
+          <p:nvPr/>
+        </p:nvSpPr>
+        <p:spPr>
+          <a:xfrm>
+            <a:off x="457200" y="1371600"/>
+            <a:ext cx="8229600" cy="457200"/>
+          </a:xfrm>
+          <a:prstGeom prst="rect">
+            <a:avLst/>
+          </a:prstGeom>
+          <a:noFill/>
+          <a:ln/>
+        </p:spPr>
+        <p:txBody>
+          <a:bodyPr wrap="square" lIns="0" tIns="0" rIns="0" bIns="0" rtlCol="0" anchor="ctr"/>
+          <a:lstStyle/>
+          <a:p>
+            <a:pPr algn="ctr" indent="0" marL="0">
+              <a:buNone/>
+            </a:pPr>
+            <a:r>
+              <a:rPr lang="en-US" sz="1400" b="1" spc="600" kern="0" dirty="0">
+                <a:solidFill>
+                  <a:srgbClr val="4ECDC4"/>
+                </a:solidFill>
+                <a:latin typeface="Calibri" pitchFamily="34" charset="0"/>
+                <a:ea typeface="Calibri" pitchFamily="34" charset="-122"/>
+                <a:cs typeface="Calibri" pitchFamily="34" charset="-120"/>
+              </a:rPr>
+              <a:t>WHAT'S NEXT</a:t>
+            </a:r>
+            <a:endParaRPr lang="en-US" sz="1400" dirty="0"/>
+          </a:p>
+        </p:txBody>
+      </p:sp>
+      <p:sp>
+        <p:nvSpPr>
+          <p:cNvPr id="7" name="Text 4"/>
+          <p:cNvSpPr/>
+          <p:nvPr/>
+        </p:nvSpPr>
+        <p:spPr>
+          <a:xfrm>
+            <a:off x="457200" y="1920240"/>
+            <a:ext cx="8229600" cy="914400"/>
+          </a:xfrm>
+          <a:prstGeom prst="rect">
+            <a:avLst/>
+          </a:prstGeom>
+          <a:noFill/>
+          <a:ln/>
+        </p:spPr>
+        <p:txBody>
+          <a:bodyPr wrap="square" lIns="0" tIns="0" rIns="0" bIns="0" rtlCol="0" anchor="ctr"/>
+          <a:lstStyle/>
+          <a:p>
+            <a:pPr algn="ctr" indent="0" marL="0">
+              <a:lnSpc>
+                <a:spcPct val="130000"/>
+              </a:lnSpc>
+              <a:buNone/>
+            </a:pPr>
+            <a:r>
+              <a:rPr lang="en-US" sz="2600" b="1" dirty="0">
+                <a:solidFill>
+                  <a:srgbClr val="FFFFFF"/>
+                </a:solidFill>
+                <a:latin typeface="Calibri" pitchFamily="34" charset="0"/>
+                <a:ea typeface="Calibri" pitchFamily="34" charset="-122"/>
+                <a:cs typeface="Calibri" pitchFamily="34" charset="-120"/>
+              </a:rPr>
+              <a:t>Build agents that actually understand</a:t>
+            </a:r>
+            <a:endParaRPr lang="en-US" sz="2600" dirty="0"/>
+          </a:p>
+          <a:p>
+            <a:pPr algn="ctr" indent="0" marL="0">
+              <a:lnSpc>
+                <a:spcPct val="130000"/>
+              </a:lnSpc>
+              <a:buNone/>
+            </a:pPr>
+            <a:r>
+              <a:rPr lang="en-US" sz="2600" b="1" dirty="0">
+                <a:solidFill>
+                  <a:srgbClr val="FFFFFF"/>
+                </a:solidFill>
+                <a:latin typeface="Calibri" pitchFamily="34" charset="0"/>
+                <a:ea typeface="Calibri" pitchFamily="34" charset="-122"/>
+                <a:cs typeface="Calibri" pitchFamily="34" charset="-120"/>
+              </a:rPr>
+              <a:t>the humans they serve.</a:t>
+            </a:r>
+            <a:endParaRPr lang="en-US" sz="2600" dirty="0"/>
+          </a:p>
+        </p:txBody>
+      </p:sp>
+      <p:sp>
+        <p:nvSpPr>
+          <p:cNvPr id="8" name="Shape 5"/>
+          <p:cNvSpPr/>
+          <p:nvPr/>
+        </p:nvSpPr>
+        <p:spPr>
+          <a:xfrm>
+            <a:off x="2743200" y="3108960"/>
+            <a:ext cx="3657600" cy="594360"/>
+          </a:xfrm>
+          <a:prstGeom prst="rect">
+            <a:avLst/>
+          </a:prstGeom>
+          <a:solidFill>
+            <a:srgbClr val="4ECDC4">
+              <a:alpha val="15000"/>
+            </a:srgbClr>
+          </a:solidFill>
+          <a:ln/>
+        </p:spPr>
+      </p:sp>
+      <p:sp>
+        <p:nvSpPr>
+          <p:cNvPr id="9" name="Text 6"/>
+          <p:cNvSpPr/>
+          <p:nvPr/>
+        </p:nvSpPr>
+        <p:spPr>
+          <a:xfrm>
+            <a:off x="2743200" y="3108960"/>
+            <a:ext cx="3657600" cy="594360"/>
+          </a:xfrm>
+          <a:prstGeom prst="rect">
+            <a:avLst/>
+          </a:prstGeom>
+          <a:noFill/>
+          <a:ln/>
+        </p:spPr>
+        <p:txBody>
+          <a:bodyPr wrap="square" lIns="0" tIns="0" rIns="0" bIns="0" rtlCol="0" anchor="ctr"/>
+          <a:lstStyle/>
+          <a:p>
+            <a:pPr algn="ctr" indent="0" marL="0">
+              <a:buNone/>
+            </a:pPr>
+            <a:r>
+              <a:rPr lang="en-US" sz="1400" b="1" dirty="0">
+                <a:solidFill>
+                  <a:srgbClr val="4ECDC4"/>
+                </a:solidFill>
+                <a:latin typeface="Calibri" pitchFamily="34" charset="0"/>
+                <a:ea typeface="Calibri" pitchFamily="34" charset="-122"/>
+                <a:cs typeface="Calibri" pitchFamily="34" charset="-120"/>
+              </a:rPr>
+              <a:t>Open Source  ·  MIT Licensed  ·  GitHub</a:t>
+            </a:r>
+            <a:endParaRPr lang="en-US" sz="1400" dirty="0"/>
+          </a:p>
+        </p:txBody>
+      </p:sp>
+      <p:sp>
+        <p:nvSpPr>
+          <p:cNvPr id="10" name="Text 7"/>
+          <p:cNvSpPr/>
+          <p:nvPr/>
+        </p:nvSpPr>
+        <p:spPr>
+          <a:xfrm>
+            <a:off x="457200" y="3931920"/>
+            <a:ext cx="8229600" cy="457200"/>
+          </a:xfrm>
+          <a:prstGeom prst="rect">
+            <a:avLst/>
+          </a:prstGeom>
+          <a:noFill/>
+          <a:ln/>
+        </p:spPr>
+        <p:txBody>
+          <a:bodyPr wrap="square" lIns="0" tIns="0" rIns="0" bIns="0" rtlCol="0" anchor="ctr"/>
+          <a:lstStyle/>
+          <a:p>
+            <a:pPr algn="ctr" indent="0" marL="0">
+              <a:buNone/>
+            </a:pPr>
+            <a:r>
+              <a:rPr lang="en-US" sz="1400" dirty="0">
+                <a:solidFill>
+                  <a:srgbClr val="C8C8D8"/>
+                </a:solidFill>
+                <a:latin typeface="Calibri" pitchFamily="34" charset="0"/>
+                <a:ea typeface="Calibri" pitchFamily="34" charset="-122"/>
+                <a:cs typeface="Calibri" pitchFamily="34" charset="-120"/>
+              </a:rPr>
+              <a:t>github.com/TaylorONeal/mirror-palace</a:t>
+            </a:r>
+            <a:endParaRPr lang="en-US" sz="1400" dirty="0"/>
+          </a:p>
+        </p:txBody>
+      </p:sp>
+      <p:sp>
+        <p:nvSpPr>
+          <p:cNvPr id="11" name="Shape 8"/>
+          <p:cNvSpPr/>
+          <p:nvPr/>
+        </p:nvSpPr>
+        <p:spPr>
+          <a:xfrm>
+            <a:off x="0" y="5088636"/>
+            <a:ext cx="9144000" cy="54864"/>
+          </a:xfrm>
+          <a:prstGeom prst="rect">
+            <a:avLst/>
+          </a:prstGeom>
+          <a:solidFill>
+            <a:srgbClr val="FF6B6B"/>
+          </a:solidFill>
+          <a:ln/>
+        </p:spPr>
+      </p:sp>
     </p:spTree>
   </p:cSld>
   <p:clrMapOvr>

</xml_diff>

<commit_message>
Add live resource links to CTA slide
FRAMEWORK-MAP.md, framework-map.html, and routing-layer-task-status.md
shown as "LIVE NOW" cards on the closing slide.

Co-Authored-By: Claude Opus 4.6 <noreply@anthropic.com>
</commit_message>
<xml_diff>
--- a/mirror-palace-keynote.pptx
+++ b/mirror-palace-keynote.pptx
@@ -12308,8 +12308,8 @@
         </p:blipFill>
         <p:spPr>
           <a:xfrm>
-            <a:off x="4114800" y="548640"/>
-            <a:ext cx="731520" cy="731520"/>
+            <a:off x="4114800" y="365760"/>
+            <a:ext cx="640080" cy="640080"/>
           </a:xfrm>
           <a:prstGeom prst="rect">
             <a:avLst/>
@@ -12324,8 +12324,8 @@
         </p:nvSpPr>
         <p:spPr>
           <a:xfrm>
-            <a:off x="457200" y="1371600"/>
-            <a:ext cx="8229600" cy="457200"/>
+            <a:off x="457200" y="1051560"/>
+            <a:ext cx="8229600" cy="365760"/>
           </a:xfrm>
           <a:prstGeom prst="rect">
             <a:avLst/>
@@ -12363,8 +12363,8 @@
         </p:nvSpPr>
         <p:spPr>
           <a:xfrm>
-            <a:off x="457200" y="1920240"/>
-            <a:ext cx="8229600" cy="914400"/>
+            <a:off x="457200" y="1417320"/>
+            <a:ext cx="8229600" cy="777240"/>
           </a:xfrm>
           <a:prstGeom prst="rect">
             <a:avLst/>
@@ -12383,7 +12383,7 @@
               <a:buNone/>
             </a:pPr>
             <a:r>
-              <a:rPr lang="en-US" sz="2600" b="1" dirty="0">
+              <a:rPr lang="en-US" sz="2400" b="1" dirty="0">
                 <a:solidFill>
                   <a:srgbClr val="FFFFFF"/>
                 </a:solidFill>
@@ -12393,7 +12393,7 @@
               </a:rPr>
               <a:t>Build agents that actually understand</a:t>
             </a:r>
-            <a:endParaRPr lang="en-US" sz="2600" dirty="0"/>
+            <a:endParaRPr lang="en-US" sz="2400" dirty="0"/>
           </a:p>
           <a:p>
             <a:pPr algn="ctr" indent="0" marL="0">
@@ -12403,7 +12403,7 @@
               <a:buNone/>
             </a:pPr>
             <a:r>
-              <a:rPr lang="en-US" sz="2600" b="1" dirty="0">
+              <a:rPr lang="en-US" sz="2400" b="1" dirty="0">
                 <a:solidFill>
                   <a:srgbClr val="FFFFFF"/>
                 </a:solidFill>
@@ -12413,7 +12413,7 @@
               </a:rPr>
               <a:t>the humans they serve.</a:t>
             </a:r>
-            <a:endParaRPr lang="en-US" sz="2600" dirty="0"/>
+            <a:endParaRPr lang="en-US" sz="2400" dirty="0"/>
           </a:p>
         </p:txBody>
       </p:sp>
@@ -12425,8 +12425,8 @@
         </p:nvSpPr>
         <p:spPr>
           <a:xfrm>
-            <a:off x="2743200" y="3108960"/>
-            <a:ext cx="3657600" cy="594360"/>
+            <a:off x="2743200" y="2331720"/>
+            <a:ext cx="3657600" cy="502920"/>
           </a:xfrm>
           <a:prstGeom prst="rect">
             <a:avLst/>
@@ -12447,8 +12447,8 @@
         </p:nvSpPr>
         <p:spPr>
           <a:xfrm>
-            <a:off x="2743200" y="3108960"/>
-            <a:ext cx="3657600" cy="594360"/>
+            <a:off x="2743200" y="2331720"/>
+            <a:ext cx="3657600" cy="502920"/>
           </a:xfrm>
           <a:prstGeom prst="rect">
             <a:avLst/>
@@ -12464,7 +12464,7 @@
               <a:buNone/>
             </a:pPr>
             <a:r>
-              <a:rPr lang="en-US" sz="1400" b="1" dirty="0">
+              <a:rPr lang="en-US" sz="1300" b="1" dirty="0">
                 <a:solidFill>
                   <a:srgbClr val="4ECDC4"/>
                 </a:solidFill>
@@ -12474,20 +12474,59 @@
               </a:rPr>
               <a:t>Open Source  ·  MIT Licensed  ·  GitHub</a:t>
             </a:r>
+            <a:endParaRPr lang="en-US" sz="1300" dirty="0"/>
+          </a:p>
+        </p:txBody>
+      </p:sp>
+      <p:sp>
+        <p:nvSpPr>
+          <p:cNvPr id="10" name="Text 7"/>
+          <p:cNvSpPr/>
+          <p:nvPr/>
+        </p:nvSpPr>
+        <p:spPr>
+          <a:xfrm>
+            <a:off x="457200" y="2926080"/>
+            <a:ext cx="8229600" cy="365760"/>
+          </a:xfrm>
+          <a:prstGeom prst="rect">
+            <a:avLst/>
+          </a:prstGeom>
+          <a:noFill/>
+          <a:ln/>
+        </p:spPr>
+        <p:txBody>
+          <a:bodyPr wrap="square" lIns="0" tIns="0" rIns="0" bIns="0" rtlCol="0" anchor="ctr"/>
+          <a:lstStyle/>
+          <a:p>
+            <a:pPr algn="ctr" indent="0" marL="0">
+              <a:buNone/>
+            </a:pPr>
+            <a:r>
+              <a:rPr lang="en-US" sz="1400" dirty="0">
+                <a:solidFill>
+                  <a:srgbClr val="C8C8D8"/>
+                </a:solidFill>
+                <a:latin typeface="Calibri" pitchFamily="34" charset="0"/>
+                <a:ea typeface="Calibri" pitchFamily="34" charset="-122"/>
+                <a:cs typeface="Calibri" pitchFamily="34" charset="-120"/>
+              </a:rPr>
+              <a:t>github.com/TaylorONeal/mirror-palace</a:t>
+            </a:r>
             <a:endParaRPr lang="en-US" sz="1400" dirty="0"/>
           </a:p>
         </p:txBody>
       </p:sp>
       <p:sp>
         <p:nvSpPr>
-          <p:cNvPr id="10" name="Text 7"/>
-          <p:cNvSpPr/>
-          <p:nvPr/>
-        </p:nvSpPr>
-        <p:spPr>
-          <a:xfrm>
-            <a:off x="457200" y="3931920"/>
-            <a:ext cx="8229600" cy="457200"/>
+          <p:cNvPr id="11" name="Text 8"/>
+          <p:cNvSpPr/>
+          <p:nvPr/>
+        </p:nvSpPr>
+        <p:spPr>
+          <a:xfrm>
+            <a:off x="457200" y="3474720"/>
+            <a:ext cx="8229600" cy="274320"/>
           </a:xfrm>
           <a:prstGeom prst="rect">
             <a:avLst/>
@@ -12503,23 +12542,386 @@
               <a:buNone/>
             </a:pPr>
             <a:r>
-              <a:rPr lang="en-US" sz="1400" dirty="0">
-                <a:solidFill>
-                  <a:srgbClr val="C8C8D8"/>
-                </a:solidFill>
-                <a:latin typeface="Calibri" pitchFamily="34" charset="0"/>
-                <a:ea typeface="Calibri" pitchFamily="34" charset="-122"/>
-                <a:cs typeface="Calibri" pitchFamily="34" charset="-120"/>
-              </a:rPr>
-              <a:t>github.com/TaylorONeal/mirror-palace</a:t>
-            </a:r>
-            <a:endParaRPr lang="en-US" sz="1400" dirty="0"/>
-          </a:p>
-        </p:txBody>
-      </p:sp>
-      <p:sp>
-        <p:nvSpPr>
-          <p:cNvPr id="11" name="Shape 8"/>
+              <a:rPr lang="en-US" sz="1000" spc="400" kern="0" dirty="0">
+                <a:solidFill>
+                  <a:srgbClr val="9999BB"/>
+                </a:solidFill>
+                <a:latin typeface="Calibri" pitchFamily="34" charset="0"/>
+                <a:ea typeface="Calibri" pitchFamily="34" charset="-122"/>
+                <a:cs typeface="Calibri" pitchFamily="34" charset="-120"/>
+              </a:rPr>
+              <a:t>LIVE NOW</a:t>
+            </a:r>
+            <a:endParaRPr lang="en-US" sz="1000" dirty="0"/>
+          </a:p>
+        </p:txBody>
+      </p:sp>
+      <p:sp>
+        <p:nvSpPr>
+          <p:cNvPr id="12" name="Shape 9"/>
+          <p:cNvSpPr/>
+          <p:nvPr/>
+        </p:nvSpPr>
+        <p:spPr>
+          <a:xfrm>
+            <a:off x="457200" y="3840480"/>
+            <a:ext cx="2651760" cy="960120"/>
+          </a:xfrm>
+          <a:prstGeom prst="rect">
+            <a:avLst/>
+          </a:prstGeom>
+          <a:solidFill>
+            <a:srgbClr val="16213E"/>
+          </a:solidFill>
+          <a:ln/>
+        </p:spPr>
+      </p:sp>
+      <p:sp>
+        <p:nvSpPr>
+          <p:cNvPr id="13" name="Shape 10"/>
+          <p:cNvSpPr/>
+          <p:nvPr/>
+        </p:nvSpPr>
+        <p:spPr>
+          <a:xfrm>
+            <a:off x="457200" y="3840480"/>
+            <a:ext cx="2651760" cy="36576"/>
+          </a:xfrm>
+          <a:prstGeom prst="rect">
+            <a:avLst/>
+          </a:prstGeom>
+          <a:solidFill>
+            <a:srgbClr val="4ECDC4"/>
+          </a:solidFill>
+          <a:ln/>
+        </p:spPr>
+      </p:sp>
+      <p:sp>
+        <p:nvSpPr>
+          <p:cNvPr id="14" name="Text 11"/>
+          <p:cNvSpPr/>
+          <p:nvPr/>
+        </p:nvSpPr>
+        <p:spPr>
+          <a:xfrm>
+            <a:off x="566928" y="3931920"/>
+            <a:ext cx="2432304" cy="274320"/>
+          </a:xfrm>
+          <a:prstGeom prst="rect">
+            <a:avLst/>
+          </a:prstGeom>
+          <a:noFill/>
+          <a:ln/>
+        </p:spPr>
+        <p:txBody>
+          <a:bodyPr wrap="square" lIns="0" tIns="0" rIns="0" bIns="0" rtlCol="0" anchor="ctr"/>
+          <a:lstStyle/>
+          <a:p>
+            <a:pPr indent="0" marL="0">
+              <a:buNone/>
+            </a:pPr>
+            <a:r>
+              <a:rPr lang="en-US" sz="1000" b="1" dirty="0">
+                <a:solidFill>
+                  <a:srgbClr val="4ECDC4"/>
+                </a:solidFill>
+                <a:latin typeface="Calibri" pitchFamily="34" charset="0"/>
+                <a:ea typeface="Calibri" pitchFamily="34" charset="-122"/>
+                <a:cs typeface="Calibri" pitchFamily="34" charset="-120"/>
+              </a:rPr>
+              <a:t>FRAMEWORK-MAP.md</a:t>
+            </a:r>
+            <a:endParaRPr lang="en-US" sz="1000" dirty="0"/>
+          </a:p>
+        </p:txBody>
+      </p:sp>
+      <p:sp>
+        <p:nvSpPr>
+          <p:cNvPr id="15" name="Text 12"/>
+          <p:cNvSpPr/>
+          <p:nvPr/>
+        </p:nvSpPr>
+        <p:spPr>
+          <a:xfrm>
+            <a:off x="566928" y="4206240"/>
+            <a:ext cx="2432304" cy="502920"/>
+          </a:xfrm>
+          <a:prstGeom prst="rect">
+            <a:avLst/>
+          </a:prstGeom>
+          <a:noFill/>
+          <a:ln/>
+        </p:spPr>
+        <p:txBody>
+          <a:bodyPr wrap="square" lIns="0" tIns="0" rIns="0" bIns="0" rtlCol="0" anchor="ctr"/>
+          <a:lstStyle/>
+          <a:p>
+            <a:pPr indent="0" marL="0">
+              <a:lnSpc>
+                <a:spcPct val="120000"/>
+              </a:lnSpc>
+              <a:buNone/>
+            </a:pPr>
+            <a:r>
+              <a:rPr lang="en-US" sz="900" dirty="0">
+                <a:solidFill>
+                  <a:srgbClr val="9999BB"/>
+                </a:solidFill>
+                <a:latin typeface="Calibri" pitchFamily="34" charset="0"/>
+                <a:ea typeface="Calibri" pitchFamily="34" charset="-122"/>
+                <a:cs typeface="Calibri" pitchFamily="34" charset="-120"/>
+              </a:rPr>
+              <a:t>Full system reference with all 36 frameworks, categories, and connections</a:t>
+            </a:r>
+            <a:endParaRPr lang="en-US" sz="900" dirty="0"/>
+          </a:p>
+        </p:txBody>
+      </p:sp>
+      <p:sp>
+        <p:nvSpPr>
+          <p:cNvPr id="16" name="Shape 13"/>
+          <p:cNvSpPr/>
+          <p:nvPr/>
+        </p:nvSpPr>
+        <p:spPr>
+          <a:xfrm>
+            <a:off x="3291840" y="3840480"/>
+            <a:ext cx="2651760" cy="960120"/>
+          </a:xfrm>
+          <a:prstGeom prst="rect">
+            <a:avLst/>
+          </a:prstGeom>
+          <a:solidFill>
+            <a:srgbClr val="16213E"/>
+          </a:solidFill>
+          <a:ln/>
+        </p:spPr>
+      </p:sp>
+      <p:sp>
+        <p:nvSpPr>
+          <p:cNvPr id="17" name="Shape 14"/>
+          <p:cNvSpPr/>
+          <p:nvPr/>
+        </p:nvSpPr>
+        <p:spPr>
+          <a:xfrm>
+            <a:off x="3291840" y="3840480"/>
+            <a:ext cx="2651760" cy="36576"/>
+          </a:xfrm>
+          <a:prstGeom prst="rect">
+            <a:avLst/>
+          </a:prstGeom>
+          <a:solidFill>
+            <a:srgbClr val="FF6B6B"/>
+          </a:solidFill>
+          <a:ln/>
+        </p:spPr>
+      </p:sp>
+      <p:sp>
+        <p:nvSpPr>
+          <p:cNvPr id="18" name="Text 15"/>
+          <p:cNvSpPr/>
+          <p:nvPr/>
+        </p:nvSpPr>
+        <p:spPr>
+          <a:xfrm>
+            <a:off x="3401568" y="3931920"/>
+            <a:ext cx="2432304" cy="274320"/>
+          </a:xfrm>
+          <a:prstGeom prst="rect">
+            <a:avLst/>
+          </a:prstGeom>
+          <a:noFill/>
+          <a:ln/>
+        </p:spPr>
+        <p:txBody>
+          <a:bodyPr wrap="square" lIns="0" tIns="0" rIns="0" bIns="0" rtlCol="0" anchor="ctr"/>
+          <a:lstStyle/>
+          <a:p>
+            <a:pPr indent="0" marL="0">
+              <a:buNone/>
+            </a:pPr>
+            <a:r>
+              <a:rPr lang="en-US" sz="1000" b="1" dirty="0">
+                <a:solidFill>
+                  <a:srgbClr val="FF6B6B"/>
+                </a:solidFill>
+                <a:latin typeface="Calibri" pitchFamily="34" charset="0"/>
+                <a:ea typeface="Calibri" pitchFamily="34" charset="-122"/>
+                <a:cs typeface="Calibri" pitchFamily="34" charset="-120"/>
+              </a:rPr>
+              <a:t>framework-map.html</a:t>
+            </a:r>
+            <a:endParaRPr lang="en-US" sz="1000" dirty="0"/>
+          </a:p>
+        </p:txBody>
+      </p:sp>
+      <p:sp>
+        <p:nvSpPr>
+          <p:cNvPr id="19" name="Text 16"/>
+          <p:cNvSpPr/>
+          <p:nvPr/>
+        </p:nvSpPr>
+        <p:spPr>
+          <a:xfrm>
+            <a:off x="3401568" y="4206240"/>
+            <a:ext cx="2432304" cy="502920"/>
+          </a:xfrm>
+          <a:prstGeom prst="rect">
+            <a:avLst/>
+          </a:prstGeom>
+          <a:noFill/>
+          <a:ln/>
+        </p:spPr>
+        <p:txBody>
+          <a:bodyPr wrap="square" lIns="0" tIns="0" rIns="0" bIns="0" rtlCol="0" anchor="ctr"/>
+          <a:lstStyle/>
+          <a:p>
+            <a:pPr indent="0" marL="0">
+              <a:lnSpc>
+                <a:spcPct val="120000"/>
+              </a:lnSpc>
+              <a:buNone/>
+            </a:pPr>
+            <a:r>
+              <a:rPr lang="en-US" sz="900" dirty="0">
+                <a:solidFill>
+                  <a:srgbClr val="9999BB"/>
+                </a:solidFill>
+                <a:latin typeface="Calibri" pitchFamily="34" charset="0"/>
+                <a:ea typeface="Calibri" pitchFamily="34" charset="-122"/>
+                <a:cs typeface="Calibri" pitchFamily="34" charset="-120"/>
+              </a:rPr>
+              <a:t>Interactive visual map with Mermaid diagrams. Open in any browser.</a:t>
+            </a:r>
+            <a:endParaRPr lang="en-US" sz="900" dirty="0"/>
+          </a:p>
+        </p:txBody>
+      </p:sp>
+      <p:sp>
+        <p:nvSpPr>
+          <p:cNvPr id="20" name="Shape 17"/>
+          <p:cNvSpPr/>
+          <p:nvPr/>
+        </p:nvSpPr>
+        <p:spPr>
+          <a:xfrm>
+            <a:off x="6126480" y="3840480"/>
+            <a:ext cx="2651760" cy="960120"/>
+          </a:xfrm>
+          <a:prstGeom prst="rect">
+            <a:avLst/>
+          </a:prstGeom>
+          <a:solidFill>
+            <a:srgbClr val="16213E"/>
+          </a:solidFill>
+          <a:ln/>
+        </p:spPr>
+      </p:sp>
+      <p:sp>
+        <p:nvSpPr>
+          <p:cNvPr id="21" name="Shape 18"/>
+          <p:cNvSpPr/>
+          <p:nvPr/>
+        </p:nvSpPr>
+        <p:spPr>
+          <a:xfrm>
+            <a:off x="6126480" y="3840480"/>
+            <a:ext cx="2651760" cy="36576"/>
+          </a:xfrm>
+          <a:prstGeom prst="rect">
+            <a:avLst/>
+          </a:prstGeom>
+          <a:solidFill>
+            <a:srgbClr val="FFD93D"/>
+          </a:solidFill>
+          <a:ln/>
+        </p:spPr>
+      </p:sp>
+      <p:sp>
+        <p:nvSpPr>
+          <p:cNvPr id="22" name="Text 19"/>
+          <p:cNvSpPr/>
+          <p:nvPr/>
+        </p:nvSpPr>
+        <p:spPr>
+          <a:xfrm>
+            <a:off x="6236208" y="3931920"/>
+            <a:ext cx="2432304" cy="274320"/>
+          </a:xfrm>
+          <a:prstGeom prst="rect">
+            <a:avLst/>
+          </a:prstGeom>
+          <a:noFill/>
+          <a:ln/>
+        </p:spPr>
+        <p:txBody>
+          <a:bodyPr wrap="square" lIns="0" tIns="0" rIns="0" bIns="0" rtlCol="0" anchor="ctr"/>
+          <a:lstStyle/>
+          <a:p>
+            <a:pPr indent="0" marL="0">
+              <a:buNone/>
+            </a:pPr>
+            <a:r>
+              <a:rPr lang="en-US" sz="1000" b="1" dirty="0">
+                <a:solidFill>
+                  <a:srgbClr val="FFD93D"/>
+                </a:solidFill>
+                <a:latin typeface="Calibri" pitchFamily="34" charset="0"/>
+                <a:ea typeface="Calibri" pitchFamily="34" charset="-122"/>
+                <a:cs typeface="Calibri" pitchFamily="34" charset="-120"/>
+              </a:rPr>
+              <a:t>docs/routing-layer-task-status.md</a:t>
+            </a:r>
+            <a:endParaRPr lang="en-US" sz="1000" dirty="0"/>
+          </a:p>
+        </p:txBody>
+      </p:sp>
+      <p:sp>
+        <p:nvSpPr>
+          <p:cNvPr id="23" name="Text 20"/>
+          <p:cNvSpPr/>
+          <p:nvPr/>
+        </p:nvSpPr>
+        <p:spPr>
+          <a:xfrm>
+            <a:off x="6236208" y="4206240"/>
+            <a:ext cx="2432304" cy="502920"/>
+          </a:xfrm>
+          <a:prstGeom prst="rect">
+            <a:avLst/>
+          </a:prstGeom>
+          <a:noFill/>
+          <a:ln/>
+        </p:spPr>
+        <p:txBody>
+          <a:bodyPr wrap="square" lIns="0" tIns="0" rIns="0" bIns="0" rtlCol="0" anchor="ctr"/>
+          <a:lstStyle/>
+          <a:p>
+            <a:pPr indent="0" marL="0">
+              <a:lnSpc>
+                <a:spcPct val="120000"/>
+              </a:lnSpc>
+              <a:buNone/>
+            </a:pPr>
+            <a:r>
+              <a:rPr lang="en-US" sz="900" dirty="0">
+                <a:solidFill>
+                  <a:srgbClr val="9999BB"/>
+                </a:solidFill>
+                <a:latin typeface="Calibri" pitchFamily="34" charset="0"/>
+                <a:ea typeface="Calibri" pitchFamily="34" charset="-122"/>
+                <a:cs typeface="Calibri" pitchFamily="34" charset="-120"/>
+              </a:rPr>
+              <a:t>Routing layer implementation status and continuation instructions</a:t>
+            </a:r>
+            <a:endParaRPr lang="en-US" sz="900" dirty="0"/>
+          </a:p>
+        </p:txBody>
+      </p:sp>
+      <p:sp>
+        <p:nvSpPr>
+          <p:cNvPr id="24" name="Shape 21"/>
           <p:cNvSpPr/>
           <p:nvPr/>
         </p:nvSpPr>

</xml_diff>

<commit_message>
Add git/SSH workflow docs and mark routing layer phases 1-3 complete
Co-Authored-By: Claude Opus 4.7 (1M context) <noreply@anthropic.com>
</commit_message>
<xml_diff>
--- a/mirror-palace-keynote.pptx
+++ b/mirror-palace-keynote.pptx
@@ -12308,8 +12308,8 @@
         </p:blipFill>
         <p:spPr>
           <a:xfrm>
-            <a:off x="4114800" y="365760"/>
-            <a:ext cx="640080" cy="640080"/>
+            <a:off x="4114800" y="548640"/>
+            <a:ext cx="731520" cy="731520"/>
           </a:xfrm>
           <a:prstGeom prst="rect">
             <a:avLst/>
@@ -12324,8 +12324,8 @@
         </p:nvSpPr>
         <p:spPr>
           <a:xfrm>
-            <a:off x="457200" y="1051560"/>
-            <a:ext cx="8229600" cy="365760"/>
+            <a:off x="457200" y="1371600"/>
+            <a:ext cx="8229600" cy="457200"/>
           </a:xfrm>
           <a:prstGeom prst="rect">
             <a:avLst/>
@@ -12363,8 +12363,8 @@
         </p:nvSpPr>
         <p:spPr>
           <a:xfrm>
-            <a:off x="457200" y="1417320"/>
-            <a:ext cx="8229600" cy="777240"/>
+            <a:off x="457200" y="1920240"/>
+            <a:ext cx="8229600" cy="914400"/>
           </a:xfrm>
           <a:prstGeom prst="rect">
             <a:avLst/>
@@ -12383,7 +12383,7 @@
               <a:buNone/>
             </a:pPr>
             <a:r>
-              <a:rPr lang="en-US" sz="2400" b="1" dirty="0">
+              <a:rPr lang="en-US" sz="2600" b="1" dirty="0">
                 <a:solidFill>
                   <a:srgbClr val="FFFFFF"/>
                 </a:solidFill>
@@ -12393,7 +12393,7 @@
               </a:rPr>
               <a:t>Build agents that actually understand</a:t>
             </a:r>
-            <a:endParaRPr lang="en-US" sz="2400" dirty="0"/>
+            <a:endParaRPr lang="en-US" sz="2600" dirty="0"/>
           </a:p>
           <a:p>
             <a:pPr algn="ctr" indent="0" marL="0">
@@ -12403,7 +12403,7 @@
               <a:buNone/>
             </a:pPr>
             <a:r>
-              <a:rPr lang="en-US" sz="2400" b="1" dirty="0">
+              <a:rPr lang="en-US" sz="2600" b="1" dirty="0">
                 <a:solidFill>
                   <a:srgbClr val="FFFFFF"/>
                 </a:solidFill>
@@ -12413,7 +12413,7 @@
               </a:rPr>
               <a:t>the humans they serve.</a:t>
             </a:r>
-            <a:endParaRPr lang="en-US" sz="2400" dirty="0"/>
+            <a:endParaRPr lang="en-US" sz="2600" dirty="0"/>
           </a:p>
         </p:txBody>
       </p:sp>
@@ -12425,8 +12425,8 @@
         </p:nvSpPr>
         <p:spPr>
           <a:xfrm>
-            <a:off x="2743200" y="2331720"/>
-            <a:ext cx="3657600" cy="502920"/>
+            <a:off x="2743200" y="3108960"/>
+            <a:ext cx="3657600" cy="594360"/>
           </a:xfrm>
           <a:prstGeom prst="rect">
             <a:avLst/>
@@ -12447,8 +12447,8 @@
         </p:nvSpPr>
         <p:spPr>
           <a:xfrm>
-            <a:off x="2743200" y="2331720"/>
-            <a:ext cx="3657600" cy="502920"/>
+            <a:off x="2743200" y="3108960"/>
+            <a:ext cx="3657600" cy="594360"/>
           </a:xfrm>
           <a:prstGeom prst="rect">
             <a:avLst/>
@@ -12464,7 +12464,7 @@
               <a:buNone/>
             </a:pPr>
             <a:r>
-              <a:rPr lang="en-US" sz="1300" b="1" dirty="0">
+              <a:rPr lang="en-US" sz="1400" b="1" dirty="0">
                 <a:solidFill>
                   <a:srgbClr val="4ECDC4"/>
                 </a:solidFill>
@@ -12474,7 +12474,7 @@
               </a:rPr>
               <a:t>Open Source  ·  MIT Licensed  ·  GitHub</a:t>
             </a:r>
-            <a:endParaRPr lang="en-US" sz="1300" dirty="0"/>
+            <a:endParaRPr lang="en-US" sz="1400" dirty="0"/>
           </a:p>
         </p:txBody>
       </p:sp>
@@ -12486,8 +12486,8 @@
         </p:nvSpPr>
         <p:spPr>
           <a:xfrm>
-            <a:off x="457200" y="2926080"/>
-            <a:ext cx="8229600" cy="365760"/>
+            <a:off x="457200" y="3931920"/>
+            <a:ext cx="8229600" cy="457200"/>
           </a:xfrm>
           <a:prstGeom prst="rect">
             <a:avLst/>
@@ -12519,409 +12519,7 @@
       </p:sp>
       <p:sp>
         <p:nvSpPr>
-          <p:cNvPr id="11" name="Text 8"/>
-          <p:cNvSpPr/>
-          <p:nvPr/>
-        </p:nvSpPr>
-        <p:spPr>
-          <a:xfrm>
-            <a:off x="457200" y="3474720"/>
-            <a:ext cx="8229600" cy="274320"/>
-          </a:xfrm>
-          <a:prstGeom prst="rect">
-            <a:avLst/>
-          </a:prstGeom>
-          <a:noFill/>
-          <a:ln/>
-        </p:spPr>
-        <p:txBody>
-          <a:bodyPr wrap="square" lIns="0" tIns="0" rIns="0" bIns="0" rtlCol="0" anchor="ctr"/>
-          <a:lstStyle/>
-          <a:p>
-            <a:pPr algn="ctr" indent="0" marL="0">
-              <a:buNone/>
-            </a:pPr>
-            <a:r>
-              <a:rPr lang="en-US" sz="1000" spc="400" kern="0" dirty="0">
-                <a:solidFill>
-                  <a:srgbClr val="9999BB"/>
-                </a:solidFill>
-                <a:latin typeface="Calibri" pitchFamily="34" charset="0"/>
-                <a:ea typeface="Calibri" pitchFamily="34" charset="-122"/>
-                <a:cs typeface="Calibri" pitchFamily="34" charset="-120"/>
-              </a:rPr>
-              <a:t>LIVE NOW</a:t>
-            </a:r>
-            <a:endParaRPr lang="en-US" sz="1000" dirty="0"/>
-          </a:p>
-        </p:txBody>
-      </p:sp>
-      <p:sp>
-        <p:nvSpPr>
-          <p:cNvPr id="12" name="Shape 9"/>
-          <p:cNvSpPr/>
-          <p:nvPr/>
-        </p:nvSpPr>
-        <p:spPr>
-          <a:xfrm>
-            <a:off x="457200" y="3840480"/>
-            <a:ext cx="2651760" cy="960120"/>
-          </a:xfrm>
-          <a:prstGeom prst="rect">
-            <a:avLst/>
-          </a:prstGeom>
-          <a:solidFill>
-            <a:srgbClr val="16213E"/>
-          </a:solidFill>
-          <a:ln/>
-        </p:spPr>
-      </p:sp>
-      <p:sp>
-        <p:nvSpPr>
-          <p:cNvPr id="13" name="Shape 10"/>
-          <p:cNvSpPr/>
-          <p:nvPr/>
-        </p:nvSpPr>
-        <p:spPr>
-          <a:xfrm>
-            <a:off x="457200" y="3840480"/>
-            <a:ext cx="2651760" cy="36576"/>
-          </a:xfrm>
-          <a:prstGeom prst="rect">
-            <a:avLst/>
-          </a:prstGeom>
-          <a:solidFill>
-            <a:srgbClr val="4ECDC4"/>
-          </a:solidFill>
-          <a:ln/>
-        </p:spPr>
-      </p:sp>
-      <p:sp>
-        <p:nvSpPr>
-          <p:cNvPr id="14" name="Text 11"/>
-          <p:cNvSpPr/>
-          <p:nvPr/>
-        </p:nvSpPr>
-        <p:spPr>
-          <a:xfrm>
-            <a:off x="566928" y="3931920"/>
-            <a:ext cx="2432304" cy="274320"/>
-          </a:xfrm>
-          <a:prstGeom prst="rect">
-            <a:avLst/>
-          </a:prstGeom>
-          <a:noFill/>
-          <a:ln/>
-        </p:spPr>
-        <p:txBody>
-          <a:bodyPr wrap="square" lIns="0" tIns="0" rIns="0" bIns="0" rtlCol="0" anchor="ctr"/>
-          <a:lstStyle/>
-          <a:p>
-            <a:pPr indent="0" marL="0">
-              <a:buNone/>
-            </a:pPr>
-            <a:r>
-              <a:rPr lang="en-US" sz="1000" b="1" dirty="0">
-                <a:solidFill>
-                  <a:srgbClr val="4ECDC4"/>
-                </a:solidFill>
-                <a:latin typeface="Calibri" pitchFamily="34" charset="0"/>
-                <a:ea typeface="Calibri" pitchFamily="34" charset="-122"/>
-                <a:cs typeface="Calibri" pitchFamily="34" charset="-120"/>
-              </a:rPr>
-              <a:t>FRAMEWORK-MAP.md</a:t>
-            </a:r>
-            <a:endParaRPr lang="en-US" sz="1000" dirty="0"/>
-          </a:p>
-        </p:txBody>
-      </p:sp>
-      <p:sp>
-        <p:nvSpPr>
-          <p:cNvPr id="15" name="Text 12"/>
-          <p:cNvSpPr/>
-          <p:nvPr/>
-        </p:nvSpPr>
-        <p:spPr>
-          <a:xfrm>
-            <a:off x="566928" y="4206240"/>
-            <a:ext cx="2432304" cy="502920"/>
-          </a:xfrm>
-          <a:prstGeom prst="rect">
-            <a:avLst/>
-          </a:prstGeom>
-          <a:noFill/>
-          <a:ln/>
-        </p:spPr>
-        <p:txBody>
-          <a:bodyPr wrap="square" lIns="0" tIns="0" rIns="0" bIns="0" rtlCol="0" anchor="ctr"/>
-          <a:lstStyle/>
-          <a:p>
-            <a:pPr indent="0" marL="0">
-              <a:lnSpc>
-                <a:spcPct val="120000"/>
-              </a:lnSpc>
-              <a:buNone/>
-            </a:pPr>
-            <a:r>
-              <a:rPr lang="en-US" sz="900" dirty="0">
-                <a:solidFill>
-                  <a:srgbClr val="9999BB"/>
-                </a:solidFill>
-                <a:latin typeface="Calibri" pitchFamily="34" charset="0"/>
-                <a:ea typeface="Calibri" pitchFamily="34" charset="-122"/>
-                <a:cs typeface="Calibri" pitchFamily="34" charset="-120"/>
-              </a:rPr>
-              <a:t>Full system reference with all 36 frameworks, categories, and connections</a:t>
-            </a:r>
-            <a:endParaRPr lang="en-US" sz="900" dirty="0"/>
-          </a:p>
-        </p:txBody>
-      </p:sp>
-      <p:sp>
-        <p:nvSpPr>
-          <p:cNvPr id="16" name="Shape 13"/>
-          <p:cNvSpPr/>
-          <p:nvPr/>
-        </p:nvSpPr>
-        <p:spPr>
-          <a:xfrm>
-            <a:off x="3291840" y="3840480"/>
-            <a:ext cx="2651760" cy="960120"/>
-          </a:xfrm>
-          <a:prstGeom prst="rect">
-            <a:avLst/>
-          </a:prstGeom>
-          <a:solidFill>
-            <a:srgbClr val="16213E"/>
-          </a:solidFill>
-          <a:ln/>
-        </p:spPr>
-      </p:sp>
-      <p:sp>
-        <p:nvSpPr>
-          <p:cNvPr id="17" name="Shape 14"/>
-          <p:cNvSpPr/>
-          <p:nvPr/>
-        </p:nvSpPr>
-        <p:spPr>
-          <a:xfrm>
-            <a:off x="3291840" y="3840480"/>
-            <a:ext cx="2651760" cy="36576"/>
-          </a:xfrm>
-          <a:prstGeom prst="rect">
-            <a:avLst/>
-          </a:prstGeom>
-          <a:solidFill>
-            <a:srgbClr val="FF6B6B"/>
-          </a:solidFill>
-          <a:ln/>
-        </p:spPr>
-      </p:sp>
-      <p:sp>
-        <p:nvSpPr>
-          <p:cNvPr id="18" name="Text 15"/>
-          <p:cNvSpPr/>
-          <p:nvPr/>
-        </p:nvSpPr>
-        <p:spPr>
-          <a:xfrm>
-            <a:off x="3401568" y="3931920"/>
-            <a:ext cx="2432304" cy="274320"/>
-          </a:xfrm>
-          <a:prstGeom prst="rect">
-            <a:avLst/>
-          </a:prstGeom>
-          <a:noFill/>
-          <a:ln/>
-        </p:spPr>
-        <p:txBody>
-          <a:bodyPr wrap="square" lIns="0" tIns="0" rIns="0" bIns="0" rtlCol="0" anchor="ctr"/>
-          <a:lstStyle/>
-          <a:p>
-            <a:pPr indent="0" marL="0">
-              <a:buNone/>
-            </a:pPr>
-            <a:r>
-              <a:rPr lang="en-US" sz="1000" b="1" dirty="0">
-                <a:solidFill>
-                  <a:srgbClr val="FF6B6B"/>
-                </a:solidFill>
-                <a:latin typeface="Calibri" pitchFamily="34" charset="0"/>
-                <a:ea typeface="Calibri" pitchFamily="34" charset="-122"/>
-                <a:cs typeface="Calibri" pitchFamily="34" charset="-120"/>
-              </a:rPr>
-              <a:t>framework-map.html</a:t>
-            </a:r>
-            <a:endParaRPr lang="en-US" sz="1000" dirty="0"/>
-          </a:p>
-        </p:txBody>
-      </p:sp>
-      <p:sp>
-        <p:nvSpPr>
-          <p:cNvPr id="19" name="Text 16"/>
-          <p:cNvSpPr/>
-          <p:nvPr/>
-        </p:nvSpPr>
-        <p:spPr>
-          <a:xfrm>
-            <a:off x="3401568" y="4206240"/>
-            <a:ext cx="2432304" cy="502920"/>
-          </a:xfrm>
-          <a:prstGeom prst="rect">
-            <a:avLst/>
-          </a:prstGeom>
-          <a:noFill/>
-          <a:ln/>
-        </p:spPr>
-        <p:txBody>
-          <a:bodyPr wrap="square" lIns="0" tIns="0" rIns="0" bIns="0" rtlCol="0" anchor="ctr"/>
-          <a:lstStyle/>
-          <a:p>
-            <a:pPr indent="0" marL="0">
-              <a:lnSpc>
-                <a:spcPct val="120000"/>
-              </a:lnSpc>
-              <a:buNone/>
-            </a:pPr>
-            <a:r>
-              <a:rPr lang="en-US" sz="900" dirty="0">
-                <a:solidFill>
-                  <a:srgbClr val="9999BB"/>
-                </a:solidFill>
-                <a:latin typeface="Calibri" pitchFamily="34" charset="0"/>
-                <a:ea typeface="Calibri" pitchFamily="34" charset="-122"/>
-                <a:cs typeface="Calibri" pitchFamily="34" charset="-120"/>
-              </a:rPr>
-              <a:t>Interactive visual map with Mermaid diagrams. Open in any browser.</a:t>
-            </a:r>
-            <a:endParaRPr lang="en-US" sz="900" dirty="0"/>
-          </a:p>
-        </p:txBody>
-      </p:sp>
-      <p:sp>
-        <p:nvSpPr>
-          <p:cNvPr id="20" name="Shape 17"/>
-          <p:cNvSpPr/>
-          <p:nvPr/>
-        </p:nvSpPr>
-        <p:spPr>
-          <a:xfrm>
-            <a:off x="6126480" y="3840480"/>
-            <a:ext cx="2651760" cy="960120"/>
-          </a:xfrm>
-          <a:prstGeom prst="rect">
-            <a:avLst/>
-          </a:prstGeom>
-          <a:solidFill>
-            <a:srgbClr val="16213E"/>
-          </a:solidFill>
-          <a:ln/>
-        </p:spPr>
-      </p:sp>
-      <p:sp>
-        <p:nvSpPr>
-          <p:cNvPr id="21" name="Shape 18"/>
-          <p:cNvSpPr/>
-          <p:nvPr/>
-        </p:nvSpPr>
-        <p:spPr>
-          <a:xfrm>
-            <a:off x="6126480" y="3840480"/>
-            <a:ext cx="2651760" cy="36576"/>
-          </a:xfrm>
-          <a:prstGeom prst="rect">
-            <a:avLst/>
-          </a:prstGeom>
-          <a:solidFill>
-            <a:srgbClr val="FFD93D"/>
-          </a:solidFill>
-          <a:ln/>
-        </p:spPr>
-      </p:sp>
-      <p:sp>
-        <p:nvSpPr>
-          <p:cNvPr id="22" name="Text 19"/>
-          <p:cNvSpPr/>
-          <p:nvPr/>
-        </p:nvSpPr>
-        <p:spPr>
-          <a:xfrm>
-            <a:off x="6236208" y="3931920"/>
-            <a:ext cx="2432304" cy="274320"/>
-          </a:xfrm>
-          <a:prstGeom prst="rect">
-            <a:avLst/>
-          </a:prstGeom>
-          <a:noFill/>
-          <a:ln/>
-        </p:spPr>
-        <p:txBody>
-          <a:bodyPr wrap="square" lIns="0" tIns="0" rIns="0" bIns="0" rtlCol="0" anchor="ctr"/>
-          <a:lstStyle/>
-          <a:p>
-            <a:pPr indent="0" marL="0">
-              <a:buNone/>
-            </a:pPr>
-            <a:r>
-              <a:rPr lang="en-US" sz="1000" b="1" dirty="0">
-                <a:solidFill>
-                  <a:srgbClr val="FFD93D"/>
-                </a:solidFill>
-                <a:latin typeface="Calibri" pitchFamily="34" charset="0"/>
-                <a:ea typeface="Calibri" pitchFamily="34" charset="-122"/>
-                <a:cs typeface="Calibri" pitchFamily="34" charset="-120"/>
-              </a:rPr>
-              <a:t>docs/routing-layer-task-status.md</a:t>
-            </a:r>
-            <a:endParaRPr lang="en-US" sz="1000" dirty="0"/>
-          </a:p>
-        </p:txBody>
-      </p:sp>
-      <p:sp>
-        <p:nvSpPr>
-          <p:cNvPr id="23" name="Text 20"/>
-          <p:cNvSpPr/>
-          <p:nvPr/>
-        </p:nvSpPr>
-        <p:spPr>
-          <a:xfrm>
-            <a:off x="6236208" y="4206240"/>
-            <a:ext cx="2432304" cy="502920"/>
-          </a:xfrm>
-          <a:prstGeom prst="rect">
-            <a:avLst/>
-          </a:prstGeom>
-          <a:noFill/>
-          <a:ln/>
-        </p:spPr>
-        <p:txBody>
-          <a:bodyPr wrap="square" lIns="0" tIns="0" rIns="0" bIns="0" rtlCol="0" anchor="ctr"/>
-          <a:lstStyle/>
-          <a:p>
-            <a:pPr indent="0" marL="0">
-              <a:lnSpc>
-                <a:spcPct val="120000"/>
-              </a:lnSpc>
-              <a:buNone/>
-            </a:pPr>
-            <a:r>
-              <a:rPr lang="en-US" sz="900" dirty="0">
-                <a:solidFill>
-                  <a:srgbClr val="9999BB"/>
-                </a:solidFill>
-                <a:latin typeface="Calibri" pitchFamily="34" charset="0"/>
-                <a:ea typeface="Calibri" pitchFamily="34" charset="-122"/>
-                <a:cs typeface="Calibri" pitchFamily="34" charset="-120"/>
-              </a:rPr>
-              <a:t>Routing layer implementation status and continuation instructions</a:t>
-            </a:r>
-            <a:endParaRPr lang="en-US" sz="900" dirty="0"/>
-          </a:p>
-        </p:txBody>
-      </p:sp>
-      <p:sp>
-        <p:nvSpPr>
-          <p:cNvPr id="24" name="Shape 21"/>
+          <p:cNvPr id="11" name="Shape 8"/>
           <p:cNvSpPr/>
           <p:nvPr/>
         </p:nvSpPr>

</xml_diff>